<commit_message>
Update AX architecture presentation and roadmap
</commit_message>
<xml_diff>
--- a/LatamFX_AX_5min_presentation.pptx
+++ b/LatamFX_AX_5min_presentation.pptx
@@ -140,7 +140,7 @@
           <p:cNvPr id="2" name="제목 1">
             <a:extLst>
               <a:ext uri="{FF2B5EF4-FFF2-40B4-BE49-F238E27FC236}">
-                <a16:creationId xmlns:a16="http://schemas.microsoft.com/office/drawing/2014/main" id="{14D84128-7FE9-A5B7-9754-926F4836761D}"/>
+                <a16:creationId xmlns:a16="http://schemas.microsoft.com/office/drawing/2014/main" id="{CB92976C-A38F-604E-E1E4-E2B8D9A8617D}"/>
               </a:ext>
             </a:extLst>
           </p:cNvPr>
@@ -177,7 +177,7 @@
           <p:cNvPr id="3" name="부제목 2">
             <a:extLst>
               <a:ext uri="{FF2B5EF4-FFF2-40B4-BE49-F238E27FC236}">
-                <a16:creationId xmlns:a16="http://schemas.microsoft.com/office/drawing/2014/main" id="{17024A39-2AA8-6E45-5C7F-4F8FEDA121FF}"/>
+                <a16:creationId xmlns:a16="http://schemas.microsoft.com/office/drawing/2014/main" id="{F472D79E-7CEE-2AC5-0F4B-CA256694EFD0}"/>
               </a:ext>
             </a:extLst>
           </p:cNvPr>
@@ -247,7 +247,7 @@
           <p:cNvPr id="4" name="날짜 개체 틀 3">
             <a:extLst>
               <a:ext uri="{FF2B5EF4-FFF2-40B4-BE49-F238E27FC236}">
-                <a16:creationId xmlns:a16="http://schemas.microsoft.com/office/drawing/2014/main" id="{4CDDE30B-9BF9-9324-1610-A863A9AB4D42}"/>
+                <a16:creationId xmlns:a16="http://schemas.microsoft.com/office/drawing/2014/main" id="{BB6B294D-F06A-6209-9E14-93A4EDAC83F9}"/>
               </a:ext>
             </a:extLst>
           </p:cNvPr>
@@ -263,7 +263,7 @@
           <a:bodyPr/>
           <a:lstStyle/>
           <a:p>
-            <a:fld id="{BFD95B0C-501E-4FB7-8F81-D76307BABC43}" type="datetimeFigureOut">
+            <a:fld id="{040579BA-4DDE-4614-936A-8D9BB37CE8C7}" type="datetimeFigureOut">
               <a:rPr lang="ko-KR" altLang="en-US" smtClean="0"/>
               <a:t>2026-06-23</a:t>
             </a:fld>
@@ -276,7 +276,7 @@
           <p:cNvPr id="5" name="바닥글 개체 틀 4">
             <a:extLst>
               <a:ext uri="{FF2B5EF4-FFF2-40B4-BE49-F238E27FC236}">
-                <a16:creationId xmlns:a16="http://schemas.microsoft.com/office/drawing/2014/main" id="{7D7A7060-5C67-3B38-EA2C-31910416A5AF}"/>
+                <a16:creationId xmlns:a16="http://schemas.microsoft.com/office/drawing/2014/main" id="{5FF1D608-9E0A-CE1F-43D7-76448BE97871}"/>
               </a:ext>
             </a:extLst>
           </p:cNvPr>
@@ -301,7 +301,7 @@
           <p:cNvPr id="6" name="슬라이드 번호 개체 틀 5">
             <a:extLst>
               <a:ext uri="{FF2B5EF4-FFF2-40B4-BE49-F238E27FC236}">
-                <a16:creationId xmlns:a16="http://schemas.microsoft.com/office/drawing/2014/main" id="{AB572610-90FA-3177-7C37-F6EEF4FBAD87}"/>
+                <a16:creationId xmlns:a16="http://schemas.microsoft.com/office/drawing/2014/main" id="{5AD8E374-A681-9C9E-4D4C-AE263B323970}"/>
               </a:ext>
             </a:extLst>
           </p:cNvPr>
@@ -317,7 +317,7 @@
           <a:bodyPr/>
           <a:lstStyle/>
           <a:p>
-            <a:fld id="{9C20B6F7-E686-4599-A449-5D29F9261C26}" type="slidenum">
+            <a:fld id="{11AE5220-36C5-4438-BBAD-DEDD24D9D647}" type="slidenum">
               <a:rPr lang="ko-KR" altLang="en-US" smtClean="0"/>
               <a:t>‹#›</a:t>
             </a:fld>
@@ -328,7 +328,7 @@
     </p:spTree>
     <p:extLst>
       <p:ext uri="{BB962C8B-B14F-4D97-AF65-F5344CB8AC3E}">
-        <p14:creationId xmlns:p14="http://schemas.microsoft.com/office/powerpoint/2010/main" val="2725307871"/>
+        <p14:creationId xmlns:p14="http://schemas.microsoft.com/office/powerpoint/2010/main" val="3111986572"/>
       </p:ext>
     </p:extLst>
   </p:cSld>
@@ -360,7 +360,7 @@
           <p:cNvPr id="2" name="제목 1">
             <a:extLst>
               <a:ext uri="{FF2B5EF4-FFF2-40B4-BE49-F238E27FC236}">
-                <a16:creationId xmlns:a16="http://schemas.microsoft.com/office/drawing/2014/main" id="{F29D8DC8-2029-0DAF-C445-7F9E9C5E1744}"/>
+                <a16:creationId xmlns:a16="http://schemas.microsoft.com/office/drawing/2014/main" id="{630E46C0-6021-6A00-9AAB-2FCF79D7A550}"/>
               </a:ext>
             </a:extLst>
           </p:cNvPr>
@@ -388,7 +388,7 @@
           <p:cNvPr id="3" name="세로 텍스트 개체 틀 2">
             <a:extLst>
               <a:ext uri="{FF2B5EF4-FFF2-40B4-BE49-F238E27FC236}">
-                <a16:creationId xmlns:a16="http://schemas.microsoft.com/office/drawing/2014/main" id="{6F02CD44-A43A-518D-CCF2-4A5869AF7A49}"/>
+                <a16:creationId xmlns:a16="http://schemas.microsoft.com/office/drawing/2014/main" id="{9EB12766-35D0-0A48-A172-892CBA1F3AB8}"/>
               </a:ext>
             </a:extLst>
           </p:cNvPr>
@@ -445,7 +445,7 @@
           <p:cNvPr id="4" name="날짜 개체 틀 3">
             <a:extLst>
               <a:ext uri="{FF2B5EF4-FFF2-40B4-BE49-F238E27FC236}">
-                <a16:creationId xmlns:a16="http://schemas.microsoft.com/office/drawing/2014/main" id="{79B89E8C-8593-D9DE-B00D-728414617FAB}"/>
+                <a16:creationId xmlns:a16="http://schemas.microsoft.com/office/drawing/2014/main" id="{5468F8AB-7BB2-2770-82B6-E20AFB0B8D3C}"/>
               </a:ext>
             </a:extLst>
           </p:cNvPr>
@@ -461,7 +461,7 @@
           <a:bodyPr/>
           <a:lstStyle/>
           <a:p>
-            <a:fld id="{BFD95B0C-501E-4FB7-8F81-D76307BABC43}" type="datetimeFigureOut">
+            <a:fld id="{040579BA-4DDE-4614-936A-8D9BB37CE8C7}" type="datetimeFigureOut">
               <a:rPr lang="ko-KR" altLang="en-US" smtClean="0"/>
               <a:t>2026-06-23</a:t>
             </a:fld>
@@ -474,7 +474,7 @@
           <p:cNvPr id="5" name="바닥글 개체 틀 4">
             <a:extLst>
               <a:ext uri="{FF2B5EF4-FFF2-40B4-BE49-F238E27FC236}">
-                <a16:creationId xmlns:a16="http://schemas.microsoft.com/office/drawing/2014/main" id="{34FB3F16-1DEB-26BC-AEAA-02BCA7199268}"/>
+                <a16:creationId xmlns:a16="http://schemas.microsoft.com/office/drawing/2014/main" id="{5E46ED6F-A4AC-FBFF-B28C-67464C89134B}"/>
               </a:ext>
             </a:extLst>
           </p:cNvPr>
@@ -499,7 +499,7 @@
           <p:cNvPr id="6" name="슬라이드 번호 개체 틀 5">
             <a:extLst>
               <a:ext uri="{FF2B5EF4-FFF2-40B4-BE49-F238E27FC236}">
-                <a16:creationId xmlns:a16="http://schemas.microsoft.com/office/drawing/2014/main" id="{0DAFFC2E-DA6E-7071-C196-A8AC2608CD99}"/>
+                <a16:creationId xmlns:a16="http://schemas.microsoft.com/office/drawing/2014/main" id="{6CE8A208-FF47-6632-A40E-A37B6A9FE01C}"/>
               </a:ext>
             </a:extLst>
           </p:cNvPr>
@@ -515,7 +515,7 @@
           <a:bodyPr/>
           <a:lstStyle/>
           <a:p>
-            <a:fld id="{9C20B6F7-E686-4599-A449-5D29F9261C26}" type="slidenum">
+            <a:fld id="{11AE5220-36C5-4438-BBAD-DEDD24D9D647}" type="slidenum">
               <a:rPr lang="ko-KR" altLang="en-US" smtClean="0"/>
               <a:t>‹#›</a:t>
             </a:fld>
@@ -526,7 +526,7 @@
     </p:spTree>
     <p:extLst>
       <p:ext uri="{BB962C8B-B14F-4D97-AF65-F5344CB8AC3E}">
-        <p14:creationId xmlns:p14="http://schemas.microsoft.com/office/powerpoint/2010/main" val="2500385306"/>
+        <p14:creationId xmlns:p14="http://schemas.microsoft.com/office/powerpoint/2010/main" val="2301663969"/>
       </p:ext>
     </p:extLst>
   </p:cSld>
@@ -558,7 +558,7 @@
           <p:cNvPr id="2" name="세로 제목 1">
             <a:extLst>
               <a:ext uri="{FF2B5EF4-FFF2-40B4-BE49-F238E27FC236}">
-                <a16:creationId xmlns:a16="http://schemas.microsoft.com/office/drawing/2014/main" id="{FEC08AD5-4B25-FDE8-8BDB-F2DEEA0D64D2}"/>
+                <a16:creationId xmlns:a16="http://schemas.microsoft.com/office/drawing/2014/main" id="{4B8ED275-55C1-1720-DA49-0380337E6EB2}"/>
               </a:ext>
             </a:extLst>
           </p:cNvPr>
@@ -591,7 +591,7 @@
           <p:cNvPr id="3" name="세로 텍스트 개체 틀 2">
             <a:extLst>
               <a:ext uri="{FF2B5EF4-FFF2-40B4-BE49-F238E27FC236}">
-                <a16:creationId xmlns:a16="http://schemas.microsoft.com/office/drawing/2014/main" id="{4A83C679-759F-E2D2-F190-B2579E4243D4}"/>
+                <a16:creationId xmlns:a16="http://schemas.microsoft.com/office/drawing/2014/main" id="{5280C97A-192F-2968-71AB-06CFB6FC1851}"/>
               </a:ext>
             </a:extLst>
           </p:cNvPr>
@@ -653,7 +653,7 @@
           <p:cNvPr id="4" name="날짜 개체 틀 3">
             <a:extLst>
               <a:ext uri="{FF2B5EF4-FFF2-40B4-BE49-F238E27FC236}">
-                <a16:creationId xmlns:a16="http://schemas.microsoft.com/office/drawing/2014/main" id="{DB1D00F5-2DF3-BBD6-FEA5-F009C9863B2C}"/>
+                <a16:creationId xmlns:a16="http://schemas.microsoft.com/office/drawing/2014/main" id="{C3278E78-B032-780B-423E-903709129B8A}"/>
               </a:ext>
             </a:extLst>
           </p:cNvPr>
@@ -669,7 +669,7 @@
           <a:bodyPr/>
           <a:lstStyle/>
           <a:p>
-            <a:fld id="{BFD95B0C-501E-4FB7-8F81-D76307BABC43}" type="datetimeFigureOut">
+            <a:fld id="{040579BA-4DDE-4614-936A-8D9BB37CE8C7}" type="datetimeFigureOut">
               <a:rPr lang="ko-KR" altLang="en-US" smtClean="0"/>
               <a:t>2026-06-23</a:t>
             </a:fld>
@@ -682,7 +682,7 @@
           <p:cNvPr id="5" name="바닥글 개체 틀 4">
             <a:extLst>
               <a:ext uri="{FF2B5EF4-FFF2-40B4-BE49-F238E27FC236}">
-                <a16:creationId xmlns:a16="http://schemas.microsoft.com/office/drawing/2014/main" id="{23832280-6256-911D-06D5-447C17327C22}"/>
+                <a16:creationId xmlns:a16="http://schemas.microsoft.com/office/drawing/2014/main" id="{B6478509-07E1-51A0-5549-19D500065423}"/>
               </a:ext>
             </a:extLst>
           </p:cNvPr>
@@ -707,7 +707,7 @@
           <p:cNvPr id="6" name="슬라이드 번호 개체 틀 5">
             <a:extLst>
               <a:ext uri="{FF2B5EF4-FFF2-40B4-BE49-F238E27FC236}">
-                <a16:creationId xmlns:a16="http://schemas.microsoft.com/office/drawing/2014/main" id="{25B822C9-5D10-1F05-FE40-340B048C83B3}"/>
+                <a16:creationId xmlns:a16="http://schemas.microsoft.com/office/drawing/2014/main" id="{BF65FA18-8F55-6BE5-4770-855FAB70B574}"/>
               </a:ext>
             </a:extLst>
           </p:cNvPr>
@@ -723,7 +723,7 @@
           <a:bodyPr/>
           <a:lstStyle/>
           <a:p>
-            <a:fld id="{9C20B6F7-E686-4599-A449-5D29F9261C26}" type="slidenum">
+            <a:fld id="{11AE5220-36C5-4438-BBAD-DEDD24D9D647}" type="slidenum">
               <a:rPr lang="ko-KR" altLang="en-US" smtClean="0"/>
               <a:t>‹#›</a:t>
             </a:fld>
@@ -734,7 +734,7 @@
     </p:spTree>
     <p:extLst>
       <p:ext uri="{BB962C8B-B14F-4D97-AF65-F5344CB8AC3E}">
-        <p14:creationId xmlns:p14="http://schemas.microsoft.com/office/powerpoint/2010/main" val="1618780670"/>
+        <p14:creationId xmlns:p14="http://schemas.microsoft.com/office/powerpoint/2010/main" val="2953613858"/>
       </p:ext>
     </p:extLst>
   </p:cSld>
@@ -766,7 +766,7 @@
           <p:cNvPr id="2" name="제목 1">
             <a:extLst>
               <a:ext uri="{FF2B5EF4-FFF2-40B4-BE49-F238E27FC236}">
-                <a16:creationId xmlns:a16="http://schemas.microsoft.com/office/drawing/2014/main" id="{8C1CF756-412E-C433-5B14-0410D7C2B24A}"/>
+                <a16:creationId xmlns:a16="http://schemas.microsoft.com/office/drawing/2014/main" id="{5F896F50-6072-0CF1-5E66-C4B7707D8CF8}"/>
               </a:ext>
             </a:extLst>
           </p:cNvPr>
@@ -794,7 +794,7 @@
           <p:cNvPr id="3" name="내용 개체 틀 2">
             <a:extLst>
               <a:ext uri="{FF2B5EF4-FFF2-40B4-BE49-F238E27FC236}">
-                <a16:creationId xmlns:a16="http://schemas.microsoft.com/office/drawing/2014/main" id="{8153523B-6A55-E05C-CE34-357A222E0E32}"/>
+                <a16:creationId xmlns:a16="http://schemas.microsoft.com/office/drawing/2014/main" id="{85616039-D21B-91FA-8F15-B6FDE356DDA9}"/>
               </a:ext>
             </a:extLst>
           </p:cNvPr>
@@ -851,7 +851,7 @@
           <p:cNvPr id="4" name="날짜 개체 틀 3">
             <a:extLst>
               <a:ext uri="{FF2B5EF4-FFF2-40B4-BE49-F238E27FC236}">
-                <a16:creationId xmlns:a16="http://schemas.microsoft.com/office/drawing/2014/main" id="{78CF5E38-60D3-F297-233F-BD1097CC4C1E}"/>
+                <a16:creationId xmlns:a16="http://schemas.microsoft.com/office/drawing/2014/main" id="{8EFF0AA3-2425-A804-CDC8-0C8D8BA607CA}"/>
               </a:ext>
             </a:extLst>
           </p:cNvPr>
@@ -867,7 +867,7 @@
           <a:bodyPr/>
           <a:lstStyle/>
           <a:p>
-            <a:fld id="{BFD95B0C-501E-4FB7-8F81-D76307BABC43}" type="datetimeFigureOut">
+            <a:fld id="{040579BA-4DDE-4614-936A-8D9BB37CE8C7}" type="datetimeFigureOut">
               <a:rPr lang="ko-KR" altLang="en-US" smtClean="0"/>
               <a:t>2026-06-23</a:t>
             </a:fld>
@@ -880,7 +880,7 @@
           <p:cNvPr id="5" name="바닥글 개체 틀 4">
             <a:extLst>
               <a:ext uri="{FF2B5EF4-FFF2-40B4-BE49-F238E27FC236}">
-                <a16:creationId xmlns:a16="http://schemas.microsoft.com/office/drawing/2014/main" id="{48C945AB-994B-D87A-37A4-5AAAD97E9129}"/>
+                <a16:creationId xmlns:a16="http://schemas.microsoft.com/office/drawing/2014/main" id="{7E19CB12-47CE-0743-8ADE-BB5FC709C8F1}"/>
               </a:ext>
             </a:extLst>
           </p:cNvPr>
@@ -905,7 +905,7 @@
           <p:cNvPr id="6" name="슬라이드 번호 개체 틀 5">
             <a:extLst>
               <a:ext uri="{FF2B5EF4-FFF2-40B4-BE49-F238E27FC236}">
-                <a16:creationId xmlns:a16="http://schemas.microsoft.com/office/drawing/2014/main" id="{4A68AA89-4AF8-6FA6-C7AF-D7D1AD20C69E}"/>
+                <a16:creationId xmlns:a16="http://schemas.microsoft.com/office/drawing/2014/main" id="{6B2B4C71-12FB-C534-C91F-9A146B34EA02}"/>
               </a:ext>
             </a:extLst>
           </p:cNvPr>
@@ -921,7 +921,7 @@
           <a:bodyPr/>
           <a:lstStyle/>
           <a:p>
-            <a:fld id="{9C20B6F7-E686-4599-A449-5D29F9261C26}" type="slidenum">
+            <a:fld id="{11AE5220-36C5-4438-BBAD-DEDD24D9D647}" type="slidenum">
               <a:rPr lang="ko-KR" altLang="en-US" smtClean="0"/>
               <a:t>‹#›</a:t>
             </a:fld>
@@ -932,7 +932,7 @@
     </p:spTree>
     <p:extLst>
       <p:ext uri="{BB962C8B-B14F-4D97-AF65-F5344CB8AC3E}">
-        <p14:creationId xmlns:p14="http://schemas.microsoft.com/office/powerpoint/2010/main" val="2737381116"/>
+        <p14:creationId xmlns:p14="http://schemas.microsoft.com/office/powerpoint/2010/main" val="522205944"/>
       </p:ext>
     </p:extLst>
   </p:cSld>
@@ -964,7 +964,7 @@
           <p:cNvPr id="2" name="제목 1">
             <a:extLst>
               <a:ext uri="{FF2B5EF4-FFF2-40B4-BE49-F238E27FC236}">
-                <a16:creationId xmlns:a16="http://schemas.microsoft.com/office/drawing/2014/main" id="{7F4ED80A-52AE-03DA-4C6F-D10AB3ABA18F}"/>
+                <a16:creationId xmlns:a16="http://schemas.microsoft.com/office/drawing/2014/main" id="{77B4EFA9-031E-A1BB-54AF-34497877CFAE}"/>
               </a:ext>
             </a:extLst>
           </p:cNvPr>
@@ -1001,7 +1001,7 @@
           <p:cNvPr id="3" name="텍스트 개체 틀 2">
             <a:extLst>
               <a:ext uri="{FF2B5EF4-FFF2-40B4-BE49-F238E27FC236}">
-                <a16:creationId xmlns:a16="http://schemas.microsoft.com/office/drawing/2014/main" id="{64DD3624-D115-CEB6-3CFB-07B26DDD3B0C}"/>
+                <a16:creationId xmlns:a16="http://schemas.microsoft.com/office/drawing/2014/main" id="{54CF6F18-168B-8EBC-1562-B8203EE9FFC4}"/>
               </a:ext>
             </a:extLst>
           </p:cNvPr>
@@ -1126,7 +1126,7 @@
           <p:cNvPr id="4" name="날짜 개체 틀 3">
             <a:extLst>
               <a:ext uri="{FF2B5EF4-FFF2-40B4-BE49-F238E27FC236}">
-                <a16:creationId xmlns:a16="http://schemas.microsoft.com/office/drawing/2014/main" id="{DEBB54F8-1326-E1BE-40FC-B51A73214133}"/>
+                <a16:creationId xmlns:a16="http://schemas.microsoft.com/office/drawing/2014/main" id="{3D31B905-844A-02D0-C4C3-B612CC2979DA}"/>
               </a:ext>
             </a:extLst>
           </p:cNvPr>
@@ -1142,7 +1142,7 @@
           <a:bodyPr/>
           <a:lstStyle/>
           <a:p>
-            <a:fld id="{BFD95B0C-501E-4FB7-8F81-D76307BABC43}" type="datetimeFigureOut">
+            <a:fld id="{040579BA-4DDE-4614-936A-8D9BB37CE8C7}" type="datetimeFigureOut">
               <a:rPr lang="ko-KR" altLang="en-US" smtClean="0"/>
               <a:t>2026-06-23</a:t>
             </a:fld>
@@ -1155,7 +1155,7 @@
           <p:cNvPr id="5" name="바닥글 개체 틀 4">
             <a:extLst>
               <a:ext uri="{FF2B5EF4-FFF2-40B4-BE49-F238E27FC236}">
-                <a16:creationId xmlns:a16="http://schemas.microsoft.com/office/drawing/2014/main" id="{122139F0-90BE-14C6-7DB7-E33C3067072E}"/>
+                <a16:creationId xmlns:a16="http://schemas.microsoft.com/office/drawing/2014/main" id="{131D85BB-07D2-A58C-A0FA-C6B207276DD0}"/>
               </a:ext>
             </a:extLst>
           </p:cNvPr>
@@ -1180,7 +1180,7 @@
           <p:cNvPr id="6" name="슬라이드 번호 개체 틀 5">
             <a:extLst>
               <a:ext uri="{FF2B5EF4-FFF2-40B4-BE49-F238E27FC236}">
-                <a16:creationId xmlns:a16="http://schemas.microsoft.com/office/drawing/2014/main" id="{26170E1B-78F2-52E6-0F2D-AF81463F1B98}"/>
+                <a16:creationId xmlns:a16="http://schemas.microsoft.com/office/drawing/2014/main" id="{031466BD-EBB2-65D8-7CBD-429CF47A8049}"/>
               </a:ext>
             </a:extLst>
           </p:cNvPr>
@@ -1196,7 +1196,7 @@
           <a:bodyPr/>
           <a:lstStyle/>
           <a:p>
-            <a:fld id="{9C20B6F7-E686-4599-A449-5D29F9261C26}" type="slidenum">
+            <a:fld id="{11AE5220-36C5-4438-BBAD-DEDD24D9D647}" type="slidenum">
               <a:rPr lang="ko-KR" altLang="en-US" smtClean="0"/>
               <a:t>‹#›</a:t>
             </a:fld>
@@ -1207,7 +1207,7 @@
     </p:spTree>
     <p:extLst>
       <p:ext uri="{BB962C8B-B14F-4D97-AF65-F5344CB8AC3E}">
-        <p14:creationId xmlns:p14="http://schemas.microsoft.com/office/powerpoint/2010/main" val="4101809724"/>
+        <p14:creationId xmlns:p14="http://schemas.microsoft.com/office/powerpoint/2010/main" val="3034716736"/>
       </p:ext>
     </p:extLst>
   </p:cSld>
@@ -1239,7 +1239,7 @@
           <p:cNvPr id="2" name="제목 1">
             <a:extLst>
               <a:ext uri="{FF2B5EF4-FFF2-40B4-BE49-F238E27FC236}">
-                <a16:creationId xmlns:a16="http://schemas.microsoft.com/office/drawing/2014/main" id="{ADD97C2E-AF78-A7B4-5D17-E411A8584200}"/>
+                <a16:creationId xmlns:a16="http://schemas.microsoft.com/office/drawing/2014/main" id="{01F57411-744B-7D42-DAF5-311A05A2FE09}"/>
               </a:ext>
             </a:extLst>
           </p:cNvPr>
@@ -1267,7 +1267,7 @@
           <p:cNvPr id="3" name="내용 개체 틀 2">
             <a:extLst>
               <a:ext uri="{FF2B5EF4-FFF2-40B4-BE49-F238E27FC236}">
-                <a16:creationId xmlns:a16="http://schemas.microsoft.com/office/drawing/2014/main" id="{88934A80-18B0-B938-A2DA-F3DCDD90674E}"/>
+                <a16:creationId xmlns:a16="http://schemas.microsoft.com/office/drawing/2014/main" id="{37E2A45E-B1C3-EFA7-4645-556C059E1573}"/>
               </a:ext>
             </a:extLst>
           </p:cNvPr>
@@ -1329,7 +1329,7 @@
           <p:cNvPr id="4" name="내용 개체 틀 3">
             <a:extLst>
               <a:ext uri="{FF2B5EF4-FFF2-40B4-BE49-F238E27FC236}">
-                <a16:creationId xmlns:a16="http://schemas.microsoft.com/office/drawing/2014/main" id="{209A294F-92D9-7673-E412-6C5D67DB5DD8}"/>
+                <a16:creationId xmlns:a16="http://schemas.microsoft.com/office/drawing/2014/main" id="{9A492FED-1C36-4490-9648-0D0771A230DE}"/>
               </a:ext>
             </a:extLst>
           </p:cNvPr>
@@ -1391,7 +1391,7 @@
           <p:cNvPr id="5" name="날짜 개체 틀 4">
             <a:extLst>
               <a:ext uri="{FF2B5EF4-FFF2-40B4-BE49-F238E27FC236}">
-                <a16:creationId xmlns:a16="http://schemas.microsoft.com/office/drawing/2014/main" id="{A390036D-E08D-76EA-00B2-9D4F129C4649}"/>
+                <a16:creationId xmlns:a16="http://schemas.microsoft.com/office/drawing/2014/main" id="{C43B49E0-EF08-E8E2-7B3A-6CDE8C08A43C}"/>
               </a:ext>
             </a:extLst>
           </p:cNvPr>
@@ -1407,7 +1407,7 @@
           <a:bodyPr/>
           <a:lstStyle/>
           <a:p>
-            <a:fld id="{BFD95B0C-501E-4FB7-8F81-D76307BABC43}" type="datetimeFigureOut">
+            <a:fld id="{040579BA-4DDE-4614-936A-8D9BB37CE8C7}" type="datetimeFigureOut">
               <a:rPr lang="ko-KR" altLang="en-US" smtClean="0"/>
               <a:t>2026-06-23</a:t>
             </a:fld>
@@ -1420,7 +1420,7 @@
           <p:cNvPr id="6" name="바닥글 개체 틀 5">
             <a:extLst>
               <a:ext uri="{FF2B5EF4-FFF2-40B4-BE49-F238E27FC236}">
-                <a16:creationId xmlns:a16="http://schemas.microsoft.com/office/drawing/2014/main" id="{1CAE733C-4435-EB1D-035D-CED0EA6A2863}"/>
+                <a16:creationId xmlns:a16="http://schemas.microsoft.com/office/drawing/2014/main" id="{6920D399-6215-AC87-423B-47A334169102}"/>
               </a:ext>
             </a:extLst>
           </p:cNvPr>
@@ -1445,7 +1445,7 @@
           <p:cNvPr id="7" name="슬라이드 번호 개체 틀 6">
             <a:extLst>
               <a:ext uri="{FF2B5EF4-FFF2-40B4-BE49-F238E27FC236}">
-                <a16:creationId xmlns:a16="http://schemas.microsoft.com/office/drawing/2014/main" id="{3636FF42-F2FA-65C4-2936-8076B2C93B61}"/>
+                <a16:creationId xmlns:a16="http://schemas.microsoft.com/office/drawing/2014/main" id="{84B3018E-AE88-B846-8ECC-EB0BA517EDF9}"/>
               </a:ext>
             </a:extLst>
           </p:cNvPr>
@@ -1461,7 +1461,7 @@
           <a:bodyPr/>
           <a:lstStyle/>
           <a:p>
-            <a:fld id="{9C20B6F7-E686-4599-A449-5D29F9261C26}" type="slidenum">
+            <a:fld id="{11AE5220-36C5-4438-BBAD-DEDD24D9D647}" type="slidenum">
               <a:rPr lang="ko-KR" altLang="en-US" smtClean="0"/>
               <a:t>‹#›</a:t>
             </a:fld>
@@ -1472,7 +1472,7 @@
     </p:spTree>
     <p:extLst>
       <p:ext uri="{BB962C8B-B14F-4D97-AF65-F5344CB8AC3E}">
-        <p14:creationId xmlns:p14="http://schemas.microsoft.com/office/powerpoint/2010/main" val="762506719"/>
+        <p14:creationId xmlns:p14="http://schemas.microsoft.com/office/powerpoint/2010/main" val="216369219"/>
       </p:ext>
     </p:extLst>
   </p:cSld>
@@ -1504,7 +1504,7 @@
           <p:cNvPr id="2" name="제목 1">
             <a:extLst>
               <a:ext uri="{FF2B5EF4-FFF2-40B4-BE49-F238E27FC236}">
-                <a16:creationId xmlns:a16="http://schemas.microsoft.com/office/drawing/2014/main" id="{01BADF5A-01B9-3078-119E-71EF72B0376A}"/>
+                <a16:creationId xmlns:a16="http://schemas.microsoft.com/office/drawing/2014/main" id="{E363AE83-7663-4C7E-6251-02C16A24F79E}"/>
               </a:ext>
             </a:extLst>
           </p:cNvPr>
@@ -1537,7 +1537,7 @@
           <p:cNvPr id="3" name="텍스트 개체 틀 2">
             <a:extLst>
               <a:ext uri="{FF2B5EF4-FFF2-40B4-BE49-F238E27FC236}">
-                <a16:creationId xmlns:a16="http://schemas.microsoft.com/office/drawing/2014/main" id="{C90B12F4-7301-2444-D92A-A0278D68B18D}"/>
+                <a16:creationId xmlns:a16="http://schemas.microsoft.com/office/drawing/2014/main" id="{4BCBB6BA-BA0B-E878-043C-0254FF1473BF}"/>
               </a:ext>
             </a:extLst>
           </p:cNvPr>
@@ -1608,7 +1608,7 @@
           <p:cNvPr id="4" name="내용 개체 틀 3">
             <a:extLst>
               <a:ext uri="{FF2B5EF4-FFF2-40B4-BE49-F238E27FC236}">
-                <a16:creationId xmlns:a16="http://schemas.microsoft.com/office/drawing/2014/main" id="{A2144C6D-06A9-5C3A-4344-43397DA55DD9}"/>
+                <a16:creationId xmlns:a16="http://schemas.microsoft.com/office/drawing/2014/main" id="{69AEF421-0F46-B5AB-7599-9CBC5807C4BA}"/>
               </a:ext>
             </a:extLst>
           </p:cNvPr>
@@ -1670,7 +1670,7 @@
           <p:cNvPr id="5" name="텍스트 개체 틀 4">
             <a:extLst>
               <a:ext uri="{FF2B5EF4-FFF2-40B4-BE49-F238E27FC236}">
-                <a16:creationId xmlns:a16="http://schemas.microsoft.com/office/drawing/2014/main" id="{D826677B-9B7A-E06F-E7DC-F85EC93AFFAD}"/>
+                <a16:creationId xmlns:a16="http://schemas.microsoft.com/office/drawing/2014/main" id="{25A597FE-886D-E7AB-C231-3605020BEA15}"/>
               </a:ext>
             </a:extLst>
           </p:cNvPr>
@@ -1741,7 +1741,7 @@
           <p:cNvPr id="6" name="내용 개체 틀 5">
             <a:extLst>
               <a:ext uri="{FF2B5EF4-FFF2-40B4-BE49-F238E27FC236}">
-                <a16:creationId xmlns:a16="http://schemas.microsoft.com/office/drawing/2014/main" id="{2F42186B-58B3-E2D8-E4E8-F46069A52C70}"/>
+                <a16:creationId xmlns:a16="http://schemas.microsoft.com/office/drawing/2014/main" id="{E69B221A-78F9-318A-6A47-40979A12CE80}"/>
               </a:ext>
             </a:extLst>
           </p:cNvPr>
@@ -1803,7 +1803,7 @@
           <p:cNvPr id="7" name="날짜 개체 틀 6">
             <a:extLst>
               <a:ext uri="{FF2B5EF4-FFF2-40B4-BE49-F238E27FC236}">
-                <a16:creationId xmlns:a16="http://schemas.microsoft.com/office/drawing/2014/main" id="{9BF66F32-FE97-2CDB-34E4-5A2CB05B1DF6}"/>
+                <a16:creationId xmlns:a16="http://schemas.microsoft.com/office/drawing/2014/main" id="{C50FDF74-C693-5CEB-497D-41EF1F7C9789}"/>
               </a:ext>
             </a:extLst>
           </p:cNvPr>
@@ -1819,7 +1819,7 @@
           <a:bodyPr/>
           <a:lstStyle/>
           <a:p>
-            <a:fld id="{BFD95B0C-501E-4FB7-8F81-D76307BABC43}" type="datetimeFigureOut">
+            <a:fld id="{040579BA-4DDE-4614-936A-8D9BB37CE8C7}" type="datetimeFigureOut">
               <a:rPr lang="ko-KR" altLang="en-US" smtClean="0"/>
               <a:t>2026-06-23</a:t>
             </a:fld>
@@ -1832,7 +1832,7 @@
           <p:cNvPr id="8" name="바닥글 개체 틀 7">
             <a:extLst>
               <a:ext uri="{FF2B5EF4-FFF2-40B4-BE49-F238E27FC236}">
-                <a16:creationId xmlns:a16="http://schemas.microsoft.com/office/drawing/2014/main" id="{5F21E882-DAE8-9B9D-53DC-21CA31A65A52}"/>
+                <a16:creationId xmlns:a16="http://schemas.microsoft.com/office/drawing/2014/main" id="{D8DF5DB2-B31D-A4F1-8F56-B7D964B90589}"/>
               </a:ext>
             </a:extLst>
           </p:cNvPr>
@@ -1857,7 +1857,7 @@
           <p:cNvPr id="9" name="슬라이드 번호 개체 틀 8">
             <a:extLst>
               <a:ext uri="{FF2B5EF4-FFF2-40B4-BE49-F238E27FC236}">
-                <a16:creationId xmlns:a16="http://schemas.microsoft.com/office/drawing/2014/main" id="{3D2335B4-8677-A6CD-5E19-54CC5816FC15}"/>
+                <a16:creationId xmlns:a16="http://schemas.microsoft.com/office/drawing/2014/main" id="{6F11D099-8F5F-2504-1C7D-0065F889B05E}"/>
               </a:ext>
             </a:extLst>
           </p:cNvPr>
@@ -1873,7 +1873,7 @@
           <a:bodyPr/>
           <a:lstStyle/>
           <a:p>
-            <a:fld id="{9C20B6F7-E686-4599-A449-5D29F9261C26}" type="slidenum">
+            <a:fld id="{11AE5220-36C5-4438-BBAD-DEDD24D9D647}" type="slidenum">
               <a:rPr lang="ko-KR" altLang="en-US" smtClean="0"/>
               <a:t>‹#›</a:t>
             </a:fld>
@@ -1884,7 +1884,7 @@
     </p:spTree>
     <p:extLst>
       <p:ext uri="{BB962C8B-B14F-4D97-AF65-F5344CB8AC3E}">
-        <p14:creationId xmlns:p14="http://schemas.microsoft.com/office/powerpoint/2010/main" val="62999771"/>
+        <p14:creationId xmlns:p14="http://schemas.microsoft.com/office/powerpoint/2010/main" val="2573752952"/>
       </p:ext>
     </p:extLst>
   </p:cSld>
@@ -1916,7 +1916,7 @@
           <p:cNvPr id="2" name="제목 1">
             <a:extLst>
               <a:ext uri="{FF2B5EF4-FFF2-40B4-BE49-F238E27FC236}">
-                <a16:creationId xmlns:a16="http://schemas.microsoft.com/office/drawing/2014/main" id="{7E5FB85E-B09F-B67F-9341-AD34163906AC}"/>
+                <a16:creationId xmlns:a16="http://schemas.microsoft.com/office/drawing/2014/main" id="{DC7EA043-3C97-B05E-63F9-121E2F481A50}"/>
               </a:ext>
             </a:extLst>
           </p:cNvPr>
@@ -1944,7 +1944,7 @@
           <p:cNvPr id="3" name="날짜 개체 틀 2">
             <a:extLst>
               <a:ext uri="{FF2B5EF4-FFF2-40B4-BE49-F238E27FC236}">
-                <a16:creationId xmlns:a16="http://schemas.microsoft.com/office/drawing/2014/main" id="{B2835B5D-2BD2-A022-B614-5585BA602BA4}"/>
+                <a16:creationId xmlns:a16="http://schemas.microsoft.com/office/drawing/2014/main" id="{9CB7F249-D929-D013-179A-5E3B6135311F}"/>
               </a:ext>
             </a:extLst>
           </p:cNvPr>
@@ -1960,7 +1960,7 @@
           <a:bodyPr/>
           <a:lstStyle/>
           <a:p>
-            <a:fld id="{BFD95B0C-501E-4FB7-8F81-D76307BABC43}" type="datetimeFigureOut">
+            <a:fld id="{040579BA-4DDE-4614-936A-8D9BB37CE8C7}" type="datetimeFigureOut">
               <a:rPr lang="ko-KR" altLang="en-US" smtClean="0"/>
               <a:t>2026-06-23</a:t>
             </a:fld>
@@ -1973,7 +1973,7 @@
           <p:cNvPr id="4" name="바닥글 개체 틀 3">
             <a:extLst>
               <a:ext uri="{FF2B5EF4-FFF2-40B4-BE49-F238E27FC236}">
-                <a16:creationId xmlns:a16="http://schemas.microsoft.com/office/drawing/2014/main" id="{2EBE246E-DA2C-0D05-BAE5-63EB535CF09C}"/>
+                <a16:creationId xmlns:a16="http://schemas.microsoft.com/office/drawing/2014/main" id="{52520AD7-9BE2-78C4-F60C-D21AE1BFD00C}"/>
               </a:ext>
             </a:extLst>
           </p:cNvPr>
@@ -1998,7 +1998,7 @@
           <p:cNvPr id="5" name="슬라이드 번호 개체 틀 4">
             <a:extLst>
               <a:ext uri="{FF2B5EF4-FFF2-40B4-BE49-F238E27FC236}">
-                <a16:creationId xmlns:a16="http://schemas.microsoft.com/office/drawing/2014/main" id="{1F2C1C5D-0614-AED5-DE14-ADF0627ABA36}"/>
+                <a16:creationId xmlns:a16="http://schemas.microsoft.com/office/drawing/2014/main" id="{A549729B-8FD6-22E8-AFA5-0CC8E7870D15}"/>
               </a:ext>
             </a:extLst>
           </p:cNvPr>
@@ -2014,7 +2014,7 @@
           <a:bodyPr/>
           <a:lstStyle/>
           <a:p>
-            <a:fld id="{9C20B6F7-E686-4599-A449-5D29F9261C26}" type="slidenum">
+            <a:fld id="{11AE5220-36C5-4438-BBAD-DEDD24D9D647}" type="slidenum">
               <a:rPr lang="ko-KR" altLang="en-US" smtClean="0"/>
               <a:t>‹#›</a:t>
             </a:fld>
@@ -2025,7 +2025,7 @@
     </p:spTree>
     <p:extLst>
       <p:ext uri="{BB962C8B-B14F-4D97-AF65-F5344CB8AC3E}">
-        <p14:creationId xmlns:p14="http://schemas.microsoft.com/office/powerpoint/2010/main" val="2070605478"/>
+        <p14:creationId xmlns:p14="http://schemas.microsoft.com/office/powerpoint/2010/main" val="1806363567"/>
       </p:ext>
     </p:extLst>
   </p:cSld>
@@ -2057,7 +2057,7 @@
           <p:cNvPr id="2" name="날짜 개체 틀 1">
             <a:extLst>
               <a:ext uri="{FF2B5EF4-FFF2-40B4-BE49-F238E27FC236}">
-                <a16:creationId xmlns:a16="http://schemas.microsoft.com/office/drawing/2014/main" id="{31E8CF90-7454-1739-9E1B-9F47449348BE}"/>
+                <a16:creationId xmlns:a16="http://schemas.microsoft.com/office/drawing/2014/main" id="{60A62827-B5A5-489A-0742-BFFD499C900D}"/>
               </a:ext>
             </a:extLst>
           </p:cNvPr>
@@ -2073,7 +2073,7 @@
           <a:bodyPr/>
           <a:lstStyle/>
           <a:p>
-            <a:fld id="{BFD95B0C-501E-4FB7-8F81-D76307BABC43}" type="datetimeFigureOut">
+            <a:fld id="{040579BA-4DDE-4614-936A-8D9BB37CE8C7}" type="datetimeFigureOut">
               <a:rPr lang="ko-KR" altLang="en-US" smtClean="0"/>
               <a:t>2026-06-23</a:t>
             </a:fld>
@@ -2086,7 +2086,7 @@
           <p:cNvPr id="3" name="바닥글 개체 틀 2">
             <a:extLst>
               <a:ext uri="{FF2B5EF4-FFF2-40B4-BE49-F238E27FC236}">
-                <a16:creationId xmlns:a16="http://schemas.microsoft.com/office/drawing/2014/main" id="{26C2F535-488A-9F69-BF34-B6FFF51AE5A6}"/>
+                <a16:creationId xmlns:a16="http://schemas.microsoft.com/office/drawing/2014/main" id="{5BCA3428-8306-C41D-E3FA-20E3C370AD22}"/>
               </a:ext>
             </a:extLst>
           </p:cNvPr>
@@ -2111,7 +2111,7 @@
           <p:cNvPr id="4" name="슬라이드 번호 개체 틀 3">
             <a:extLst>
               <a:ext uri="{FF2B5EF4-FFF2-40B4-BE49-F238E27FC236}">
-                <a16:creationId xmlns:a16="http://schemas.microsoft.com/office/drawing/2014/main" id="{2616EC71-2EE3-3D92-8E7B-EB8A77B4CBF9}"/>
+                <a16:creationId xmlns:a16="http://schemas.microsoft.com/office/drawing/2014/main" id="{B028ADAF-E041-E23E-9299-AF2B65F70D5C}"/>
               </a:ext>
             </a:extLst>
           </p:cNvPr>
@@ -2127,7 +2127,7 @@
           <a:bodyPr/>
           <a:lstStyle/>
           <a:p>
-            <a:fld id="{9C20B6F7-E686-4599-A449-5D29F9261C26}" type="slidenum">
+            <a:fld id="{11AE5220-36C5-4438-BBAD-DEDD24D9D647}" type="slidenum">
               <a:rPr lang="ko-KR" altLang="en-US" smtClean="0"/>
               <a:t>‹#›</a:t>
             </a:fld>
@@ -2138,7 +2138,7 @@
     </p:spTree>
     <p:extLst>
       <p:ext uri="{BB962C8B-B14F-4D97-AF65-F5344CB8AC3E}">
-        <p14:creationId xmlns:p14="http://schemas.microsoft.com/office/powerpoint/2010/main" val="2900063500"/>
+        <p14:creationId xmlns:p14="http://schemas.microsoft.com/office/powerpoint/2010/main" val="2364695523"/>
       </p:ext>
     </p:extLst>
   </p:cSld>
@@ -2170,7 +2170,7 @@
           <p:cNvPr id="2" name="제목 1">
             <a:extLst>
               <a:ext uri="{FF2B5EF4-FFF2-40B4-BE49-F238E27FC236}">
-                <a16:creationId xmlns:a16="http://schemas.microsoft.com/office/drawing/2014/main" id="{E3F5E441-0120-7608-6AD2-F9CDBC640404}"/>
+                <a16:creationId xmlns:a16="http://schemas.microsoft.com/office/drawing/2014/main" id="{1AE6F668-0A30-5E98-5039-DA479856D30B}"/>
               </a:ext>
             </a:extLst>
           </p:cNvPr>
@@ -2207,7 +2207,7 @@
           <p:cNvPr id="3" name="내용 개체 틀 2">
             <a:extLst>
               <a:ext uri="{FF2B5EF4-FFF2-40B4-BE49-F238E27FC236}">
-                <a16:creationId xmlns:a16="http://schemas.microsoft.com/office/drawing/2014/main" id="{F2AB811B-28B4-BB2C-6F77-934A66C6DD6C}"/>
+                <a16:creationId xmlns:a16="http://schemas.microsoft.com/office/drawing/2014/main" id="{82950690-8E8E-95A2-E38A-A168BB2C326C}"/>
               </a:ext>
             </a:extLst>
           </p:cNvPr>
@@ -2297,7 +2297,7 @@
           <p:cNvPr id="4" name="텍스트 개체 틀 3">
             <a:extLst>
               <a:ext uri="{FF2B5EF4-FFF2-40B4-BE49-F238E27FC236}">
-                <a16:creationId xmlns:a16="http://schemas.microsoft.com/office/drawing/2014/main" id="{8D78036F-3101-B23C-833B-1AB973CF7160}"/>
+                <a16:creationId xmlns:a16="http://schemas.microsoft.com/office/drawing/2014/main" id="{15504C08-A15F-28BE-1554-7B2C06024068}"/>
               </a:ext>
             </a:extLst>
           </p:cNvPr>
@@ -2368,7 +2368,7 @@
           <p:cNvPr id="5" name="날짜 개체 틀 4">
             <a:extLst>
               <a:ext uri="{FF2B5EF4-FFF2-40B4-BE49-F238E27FC236}">
-                <a16:creationId xmlns:a16="http://schemas.microsoft.com/office/drawing/2014/main" id="{1154D033-A963-9BDC-632F-4F1D49297B97}"/>
+                <a16:creationId xmlns:a16="http://schemas.microsoft.com/office/drawing/2014/main" id="{1B16D7AA-E97D-85ED-F509-3A7D24540099}"/>
               </a:ext>
             </a:extLst>
           </p:cNvPr>
@@ -2384,7 +2384,7 @@
           <a:bodyPr/>
           <a:lstStyle/>
           <a:p>
-            <a:fld id="{BFD95B0C-501E-4FB7-8F81-D76307BABC43}" type="datetimeFigureOut">
+            <a:fld id="{040579BA-4DDE-4614-936A-8D9BB37CE8C7}" type="datetimeFigureOut">
               <a:rPr lang="ko-KR" altLang="en-US" smtClean="0"/>
               <a:t>2026-06-23</a:t>
             </a:fld>
@@ -2397,7 +2397,7 @@
           <p:cNvPr id="6" name="바닥글 개체 틀 5">
             <a:extLst>
               <a:ext uri="{FF2B5EF4-FFF2-40B4-BE49-F238E27FC236}">
-                <a16:creationId xmlns:a16="http://schemas.microsoft.com/office/drawing/2014/main" id="{DAF1524D-B89A-45E9-3570-C9C2F8E30AFA}"/>
+                <a16:creationId xmlns:a16="http://schemas.microsoft.com/office/drawing/2014/main" id="{16D03AF5-C924-385F-657B-9742F48BFD7C}"/>
               </a:ext>
             </a:extLst>
           </p:cNvPr>
@@ -2422,7 +2422,7 @@
           <p:cNvPr id="7" name="슬라이드 번호 개체 틀 6">
             <a:extLst>
               <a:ext uri="{FF2B5EF4-FFF2-40B4-BE49-F238E27FC236}">
-                <a16:creationId xmlns:a16="http://schemas.microsoft.com/office/drawing/2014/main" id="{8ECB030E-01B9-22E5-4A53-2D7A2E5CB343}"/>
+                <a16:creationId xmlns:a16="http://schemas.microsoft.com/office/drawing/2014/main" id="{17DE0AA3-69E0-026B-C4C3-CD19CE7524C2}"/>
               </a:ext>
             </a:extLst>
           </p:cNvPr>
@@ -2438,7 +2438,7 @@
           <a:bodyPr/>
           <a:lstStyle/>
           <a:p>
-            <a:fld id="{9C20B6F7-E686-4599-A449-5D29F9261C26}" type="slidenum">
+            <a:fld id="{11AE5220-36C5-4438-BBAD-DEDD24D9D647}" type="slidenum">
               <a:rPr lang="ko-KR" altLang="en-US" smtClean="0"/>
               <a:t>‹#›</a:t>
             </a:fld>
@@ -2449,7 +2449,7 @@
     </p:spTree>
     <p:extLst>
       <p:ext uri="{BB962C8B-B14F-4D97-AF65-F5344CB8AC3E}">
-        <p14:creationId xmlns:p14="http://schemas.microsoft.com/office/powerpoint/2010/main" val="1730581599"/>
+        <p14:creationId xmlns:p14="http://schemas.microsoft.com/office/powerpoint/2010/main" val="3702757807"/>
       </p:ext>
     </p:extLst>
   </p:cSld>
@@ -2481,7 +2481,7 @@
           <p:cNvPr id="2" name="제목 1">
             <a:extLst>
               <a:ext uri="{FF2B5EF4-FFF2-40B4-BE49-F238E27FC236}">
-                <a16:creationId xmlns:a16="http://schemas.microsoft.com/office/drawing/2014/main" id="{72583C6F-CA91-BE5C-F53B-4DB9A3EDD60D}"/>
+                <a16:creationId xmlns:a16="http://schemas.microsoft.com/office/drawing/2014/main" id="{0A5E9435-9592-6461-7E91-3246E2AE8077}"/>
               </a:ext>
             </a:extLst>
           </p:cNvPr>
@@ -2518,7 +2518,7 @@
           <p:cNvPr id="3" name="그림 개체 틀 2">
             <a:extLst>
               <a:ext uri="{FF2B5EF4-FFF2-40B4-BE49-F238E27FC236}">
-                <a16:creationId xmlns:a16="http://schemas.microsoft.com/office/drawing/2014/main" id="{BD155FFF-6AEC-1896-EB52-7F8AC680ED0B}"/>
+                <a16:creationId xmlns:a16="http://schemas.microsoft.com/office/drawing/2014/main" id="{19817C8B-9B72-FFDE-0D89-E577C158BA46}"/>
               </a:ext>
             </a:extLst>
           </p:cNvPr>
@@ -2585,7 +2585,7 @@
           <p:cNvPr id="4" name="텍스트 개체 틀 3">
             <a:extLst>
               <a:ext uri="{FF2B5EF4-FFF2-40B4-BE49-F238E27FC236}">
-                <a16:creationId xmlns:a16="http://schemas.microsoft.com/office/drawing/2014/main" id="{5B71EE63-47E2-8BFC-3882-220A8221649A}"/>
+                <a16:creationId xmlns:a16="http://schemas.microsoft.com/office/drawing/2014/main" id="{55EC035A-D146-1F3E-A525-14AE62C73971}"/>
               </a:ext>
             </a:extLst>
           </p:cNvPr>
@@ -2656,7 +2656,7 @@
           <p:cNvPr id="5" name="날짜 개체 틀 4">
             <a:extLst>
               <a:ext uri="{FF2B5EF4-FFF2-40B4-BE49-F238E27FC236}">
-                <a16:creationId xmlns:a16="http://schemas.microsoft.com/office/drawing/2014/main" id="{6A18CD10-4C6C-A495-B522-6FF384D1FA0A}"/>
+                <a16:creationId xmlns:a16="http://schemas.microsoft.com/office/drawing/2014/main" id="{C7A333DB-43AD-58E9-A366-2EEA6498AC39}"/>
               </a:ext>
             </a:extLst>
           </p:cNvPr>
@@ -2672,7 +2672,7 @@
           <a:bodyPr/>
           <a:lstStyle/>
           <a:p>
-            <a:fld id="{BFD95B0C-501E-4FB7-8F81-D76307BABC43}" type="datetimeFigureOut">
+            <a:fld id="{040579BA-4DDE-4614-936A-8D9BB37CE8C7}" type="datetimeFigureOut">
               <a:rPr lang="ko-KR" altLang="en-US" smtClean="0"/>
               <a:t>2026-06-23</a:t>
             </a:fld>
@@ -2685,7 +2685,7 @@
           <p:cNvPr id="6" name="바닥글 개체 틀 5">
             <a:extLst>
               <a:ext uri="{FF2B5EF4-FFF2-40B4-BE49-F238E27FC236}">
-                <a16:creationId xmlns:a16="http://schemas.microsoft.com/office/drawing/2014/main" id="{DC334232-8169-E88C-EE7B-4559B27FAF48}"/>
+                <a16:creationId xmlns:a16="http://schemas.microsoft.com/office/drawing/2014/main" id="{EB818E4B-B2B0-B7DA-8247-DB61548C1E53}"/>
               </a:ext>
             </a:extLst>
           </p:cNvPr>
@@ -2710,7 +2710,7 @@
           <p:cNvPr id="7" name="슬라이드 번호 개체 틀 6">
             <a:extLst>
               <a:ext uri="{FF2B5EF4-FFF2-40B4-BE49-F238E27FC236}">
-                <a16:creationId xmlns:a16="http://schemas.microsoft.com/office/drawing/2014/main" id="{9124DB33-0703-FD01-FC6E-AA999CAD429C}"/>
+                <a16:creationId xmlns:a16="http://schemas.microsoft.com/office/drawing/2014/main" id="{2279335F-A7B1-1FC0-9AB9-8EC54B9340C4}"/>
               </a:ext>
             </a:extLst>
           </p:cNvPr>
@@ -2726,7 +2726,7 @@
           <a:bodyPr/>
           <a:lstStyle/>
           <a:p>
-            <a:fld id="{9C20B6F7-E686-4599-A449-5D29F9261C26}" type="slidenum">
+            <a:fld id="{11AE5220-36C5-4438-BBAD-DEDD24D9D647}" type="slidenum">
               <a:rPr lang="ko-KR" altLang="en-US" smtClean="0"/>
               <a:t>‹#›</a:t>
             </a:fld>
@@ -2737,7 +2737,7 @@
     </p:spTree>
     <p:extLst>
       <p:ext uri="{BB962C8B-B14F-4D97-AF65-F5344CB8AC3E}">
-        <p14:creationId xmlns:p14="http://schemas.microsoft.com/office/powerpoint/2010/main" val="4087033048"/>
+        <p14:creationId xmlns:p14="http://schemas.microsoft.com/office/powerpoint/2010/main" val="309868862"/>
       </p:ext>
     </p:extLst>
   </p:cSld>
@@ -2774,7 +2774,7 @@
           <p:cNvPr id="2" name="제목 개체 틀 1">
             <a:extLst>
               <a:ext uri="{FF2B5EF4-FFF2-40B4-BE49-F238E27FC236}">
-                <a16:creationId xmlns:a16="http://schemas.microsoft.com/office/drawing/2014/main" id="{6B86DB32-3035-9F2A-6672-1DD6200827CD}"/>
+                <a16:creationId xmlns:a16="http://schemas.microsoft.com/office/drawing/2014/main" id="{4A283823-E00A-80F3-7712-45B7F8B8B583}"/>
               </a:ext>
             </a:extLst>
           </p:cNvPr>
@@ -2812,7 +2812,7 @@
           <p:cNvPr id="3" name="텍스트 개체 틀 2">
             <a:extLst>
               <a:ext uri="{FF2B5EF4-FFF2-40B4-BE49-F238E27FC236}">
-                <a16:creationId xmlns:a16="http://schemas.microsoft.com/office/drawing/2014/main" id="{01F772C0-A331-654E-9B67-375A8614E6CB}"/>
+                <a16:creationId xmlns:a16="http://schemas.microsoft.com/office/drawing/2014/main" id="{F55D5404-6F89-A401-0C4C-BCEFBE8B5BCF}"/>
               </a:ext>
             </a:extLst>
           </p:cNvPr>
@@ -2879,7 +2879,7 @@
           <p:cNvPr id="4" name="날짜 개체 틀 3">
             <a:extLst>
               <a:ext uri="{FF2B5EF4-FFF2-40B4-BE49-F238E27FC236}">
-                <a16:creationId xmlns:a16="http://schemas.microsoft.com/office/drawing/2014/main" id="{0F971F8B-A402-5C55-FB17-A8A1EA25526D}"/>
+                <a16:creationId xmlns:a16="http://schemas.microsoft.com/office/drawing/2014/main" id="{9C99ED82-E3BC-8AFB-C754-6E6C72E56B77}"/>
               </a:ext>
             </a:extLst>
           </p:cNvPr>
@@ -2913,7 +2913,7 @@
             </a:lvl1pPr>
           </a:lstStyle>
           <a:p>
-            <a:fld id="{BFD95B0C-501E-4FB7-8F81-D76307BABC43}" type="datetimeFigureOut">
+            <a:fld id="{040579BA-4DDE-4614-936A-8D9BB37CE8C7}" type="datetimeFigureOut">
               <a:rPr lang="ko-KR" altLang="en-US" smtClean="0"/>
               <a:t>2026-06-23</a:t>
             </a:fld>
@@ -2926,7 +2926,7 @@
           <p:cNvPr id="5" name="바닥글 개체 틀 4">
             <a:extLst>
               <a:ext uri="{FF2B5EF4-FFF2-40B4-BE49-F238E27FC236}">
-                <a16:creationId xmlns:a16="http://schemas.microsoft.com/office/drawing/2014/main" id="{229817EA-5FA3-2F5A-F562-4FC55B4D9875}"/>
+                <a16:creationId xmlns:a16="http://schemas.microsoft.com/office/drawing/2014/main" id="{FC1B5286-38C8-76BC-43CA-7C1DA206D3A3}"/>
               </a:ext>
             </a:extLst>
           </p:cNvPr>
@@ -2969,7 +2969,7 @@
           <p:cNvPr id="6" name="슬라이드 번호 개체 틀 5">
             <a:extLst>
               <a:ext uri="{FF2B5EF4-FFF2-40B4-BE49-F238E27FC236}">
-                <a16:creationId xmlns:a16="http://schemas.microsoft.com/office/drawing/2014/main" id="{1C5B3D1E-5034-4F06-6102-1769BC1A7300}"/>
+                <a16:creationId xmlns:a16="http://schemas.microsoft.com/office/drawing/2014/main" id="{E76ED7D0-7D92-DD79-6C99-9E01E5511D3B}"/>
               </a:ext>
             </a:extLst>
           </p:cNvPr>
@@ -3003,7 +3003,7 @@
             </a:lvl1pPr>
           </a:lstStyle>
           <a:p>
-            <a:fld id="{9C20B6F7-E686-4599-A449-5D29F9261C26}" type="slidenum">
+            <a:fld id="{11AE5220-36C5-4438-BBAD-DEDD24D9D647}" type="slidenum">
               <a:rPr lang="ko-KR" altLang="en-US" smtClean="0"/>
               <a:t>‹#›</a:t>
             </a:fld>
@@ -3014,7 +3014,7 @@
     </p:spTree>
     <p:extLst>
       <p:ext uri="{BB962C8B-B14F-4D97-AF65-F5344CB8AC3E}">
-        <p14:creationId xmlns:p14="http://schemas.microsoft.com/office/powerpoint/2010/main" val="2646143560"/>
+        <p14:creationId xmlns:p14="http://schemas.microsoft.com/office/powerpoint/2010/main" val="2093818794"/>
       </p:ext>
     </p:extLst>
   </p:cSld>
@@ -3345,7 +3345,7 @@
           <p:cNvPr id="2" name="사각형: 둥근 모서리 1">
             <a:extLst>
               <a:ext uri="{FF2B5EF4-FFF2-40B4-BE49-F238E27FC236}">
-                <a16:creationId xmlns:a16="http://schemas.microsoft.com/office/drawing/2014/main" id="{E9D8A6DC-171B-DA34-CE97-70670162E72A}"/>
+                <a16:creationId xmlns:a16="http://schemas.microsoft.com/office/drawing/2014/main" id="{8AEB4E0F-3111-7E70-BDEE-81416F9F90B5}"/>
               </a:ext>
             </a:extLst>
           </p:cNvPr>
@@ -3430,7 +3430,7 @@
           <p:cNvPr id="3" name="TextBox 2">
             <a:extLst>
               <a:ext uri="{FF2B5EF4-FFF2-40B4-BE49-F238E27FC236}">
-                <a16:creationId xmlns:a16="http://schemas.microsoft.com/office/drawing/2014/main" id="{5386BDCD-A950-C890-DB3C-3D11059E061B}"/>
+                <a16:creationId xmlns:a16="http://schemas.microsoft.com/office/drawing/2014/main" id="{01E4D2AF-2A9A-9F2A-F046-332561566F0E}"/>
               </a:ext>
             </a:extLst>
           </p:cNvPr>
@@ -3470,7 +3470,7 @@
           <p:cNvPr id="4" name="TextBox 3">
             <a:extLst>
               <a:ext uri="{FF2B5EF4-FFF2-40B4-BE49-F238E27FC236}">
-                <a16:creationId xmlns:a16="http://schemas.microsoft.com/office/drawing/2014/main" id="{F5B8DC26-8E1B-3CB6-4C7B-0533A257CEBA}"/>
+                <a16:creationId xmlns:a16="http://schemas.microsoft.com/office/drawing/2014/main" id="{2C63610C-0A67-10E5-0769-94B1274B315C}"/>
               </a:ext>
             </a:extLst>
           </p:cNvPr>
@@ -3519,7 +3519,7 @@
           <p:cNvPr id="5" name="TextBox 4">
             <a:extLst>
               <a:ext uri="{FF2B5EF4-FFF2-40B4-BE49-F238E27FC236}">
-                <a16:creationId xmlns:a16="http://schemas.microsoft.com/office/drawing/2014/main" id="{A170F513-4AB9-21DA-08C1-CB94AB151A4C}"/>
+                <a16:creationId xmlns:a16="http://schemas.microsoft.com/office/drawing/2014/main" id="{1FDE113D-720E-0691-8AF1-31F796C51807}"/>
               </a:ext>
             </a:extLst>
           </p:cNvPr>
@@ -3577,7 +3577,7 @@
           <p:cNvPr id="6" name="사각형: 둥근 모서리 5">
             <a:extLst>
               <a:ext uri="{FF2B5EF4-FFF2-40B4-BE49-F238E27FC236}">
-                <a16:creationId xmlns:a16="http://schemas.microsoft.com/office/drawing/2014/main" id="{1B1AE8CD-273C-E021-4E9C-B6A16CB1D990}"/>
+                <a16:creationId xmlns:a16="http://schemas.microsoft.com/office/drawing/2014/main" id="{64599856-8684-3CBB-8F8B-C0C5FB99DDDF}"/>
               </a:ext>
             </a:extLst>
           </p:cNvPr>
@@ -3645,7 +3645,7 @@
           <p:cNvPr id="7" name="TextBox 6">
             <a:extLst>
               <a:ext uri="{FF2B5EF4-FFF2-40B4-BE49-F238E27FC236}">
-                <a16:creationId xmlns:a16="http://schemas.microsoft.com/office/drawing/2014/main" id="{02BBE408-21F7-FCBA-FBD8-2E70EC961D51}"/>
+                <a16:creationId xmlns:a16="http://schemas.microsoft.com/office/drawing/2014/main" id="{FB58C13E-D7B8-0B94-18C4-F27A81C8DC12}"/>
               </a:ext>
             </a:extLst>
           </p:cNvPr>
@@ -3736,7 +3736,7 @@
           <p:cNvPr id="8" name="TextBox 7">
             <a:extLst>
               <a:ext uri="{FF2B5EF4-FFF2-40B4-BE49-F238E27FC236}">
-                <a16:creationId xmlns:a16="http://schemas.microsoft.com/office/drawing/2014/main" id="{0E097AAB-0BD3-3149-3E4B-1FA3343A8B87}"/>
+                <a16:creationId xmlns:a16="http://schemas.microsoft.com/office/drawing/2014/main" id="{63CCA804-1DE9-CAA0-73F9-C9F07C2513C7}"/>
               </a:ext>
             </a:extLst>
           </p:cNvPr>
@@ -3816,7 +3816,7 @@
     </p:spTree>
     <p:extLst>
       <p:ext uri="{BB962C8B-B14F-4D97-AF65-F5344CB8AC3E}">
-        <p14:creationId xmlns:p14="http://schemas.microsoft.com/office/powerpoint/2010/main" val="1638838043"/>
+        <p14:creationId xmlns:p14="http://schemas.microsoft.com/office/powerpoint/2010/main" val="2632762576"/>
       </p:ext>
     </p:extLst>
   </p:cSld>
@@ -3856,7 +3856,7 @@
           <p:cNvPr id="2" name="사각형: 둥근 모서리 1">
             <a:extLst>
               <a:ext uri="{FF2B5EF4-FFF2-40B4-BE49-F238E27FC236}">
-                <a16:creationId xmlns:a16="http://schemas.microsoft.com/office/drawing/2014/main" id="{DB9DC069-EB14-E756-CC46-E112B5ED0A02}"/>
+                <a16:creationId xmlns:a16="http://schemas.microsoft.com/office/drawing/2014/main" id="{BC73ED4C-2E86-8972-3AA2-A5EC43934D32}"/>
               </a:ext>
             </a:extLst>
           </p:cNvPr>
@@ -3938,7 +3938,7 @@
           <p:cNvPr id="3" name="TextBox 2">
             <a:extLst>
               <a:ext uri="{FF2B5EF4-FFF2-40B4-BE49-F238E27FC236}">
-                <a16:creationId xmlns:a16="http://schemas.microsoft.com/office/drawing/2014/main" id="{82C0FC39-885F-AC68-0F96-59E947CD5B6B}"/>
+                <a16:creationId xmlns:a16="http://schemas.microsoft.com/office/drawing/2014/main" id="{5C942494-6E1D-B5EE-65A2-41A8B93D088F}"/>
               </a:ext>
             </a:extLst>
           </p:cNvPr>
@@ -3978,7 +3978,7 @@
           <p:cNvPr id="4" name="TextBox 3">
             <a:extLst>
               <a:ext uri="{FF2B5EF4-FFF2-40B4-BE49-F238E27FC236}">
-                <a16:creationId xmlns:a16="http://schemas.microsoft.com/office/drawing/2014/main" id="{8212CB1A-24E7-4B4F-83A5-5857A0F541FA}"/>
+                <a16:creationId xmlns:a16="http://schemas.microsoft.com/office/drawing/2014/main" id="{FF9E5F96-E3E4-23E1-6685-0A7CC2655824}"/>
               </a:ext>
             </a:extLst>
           </p:cNvPr>
@@ -4018,7 +4018,7 @@
           <p:cNvPr id="5" name="사각형: 둥근 모서리 4">
             <a:extLst>
               <a:ext uri="{FF2B5EF4-FFF2-40B4-BE49-F238E27FC236}">
-                <a16:creationId xmlns:a16="http://schemas.microsoft.com/office/drawing/2014/main" id="{DD3F2D22-29C0-BC05-4172-FC7F19635CBC}"/>
+                <a16:creationId xmlns:a16="http://schemas.microsoft.com/office/drawing/2014/main" id="{C3872708-0B3D-8D5A-A3AF-B68E01632764}"/>
               </a:ext>
             </a:extLst>
           </p:cNvPr>
@@ -4077,7 +4077,7 @@
           <p:cNvPr id="7" name="그림 6">
             <a:extLst>
               <a:ext uri="{FF2B5EF4-FFF2-40B4-BE49-F238E27FC236}">
-                <a16:creationId xmlns:a16="http://schemas.microsoft.com/office/drawing/2014/main" id="{AE42666D-9F5F-384E-AF97-D042D20AF474}"/>
+                <a16:creationId xmlns:a16="http://schemas.microsoft.com/office/drawing/2014/main" id="{7D3B07B2-2893-D45A-CF6A-48FDA78C8208}"/>
               </a:ext>
             </a:extLst>
           </p:cNvPr>
@@ -4113,7 +4113,7 @@
           <p:cNvPr id="8" name="사각형: 둥근 모서리 7">
             <a:extLst>
               <a:ext uri="{FF2B5EF4-FFF2-40B4-BE49-F238E27FC236}">
-                <a16:creationId xmlns:a16="http://schemas.microsoft.com/office/drawing/2014/main" id="{95E07477-1ED4-3592-82FD-FC00A8DF97E8}"/>
+                <a16:creationId xmlns:a16="http://schemas.microsoft.com/office/drawing/2014/main" id="{6197EA7A-E718-2418-0459-6169D0372D45}"/>
               </a:ext>
             </a:extLst>
           </p:cNvPr>
@@ -4167,7 +4167,7 @@
           <p:cNvPr id="9" name="직사각형 8">
             <a:extLst>
               <a:ext uri="{FF2B5EF4-FFF2-40B4-BE49-F238E27FC236}">
-                <a16:creationId xmlns:a16="http://schemas.microsoft.com/office/drawing/2014/main" id="{E9E82F8F-2B9B-D1D3-88B1-38DA3834F6C0}"/>
+                <a16:creationId xmlns:a16="http://schemas.microsoft.com/office/drawing/2014/main" id="{D2763B34-9480-939F-24D3-19B01E61575B}"/>
               </a:ext>
             </a:extLst>
           </p:cNvPr>
@@ -4235,7 +4235,7 @@
           <p:cNvPr id="10" name="TextBox 9">
             <a:extLst>
               <a:ext uri="{FF2B5EF4-FFF2-40B4-BE49-F238E27FC236}">
-                <a16:creationId xmlns:a16="http://schemas.microsoft.com/office/drawing/2014/main" id="{50F8293B-973D-D3FA-73C5-5A025BFCF8F3}"/>
+                <a16:creationId xmlns:a16="http://schemas.microsoft.com/office/drawing/2014/main" id="{259E8CC2-C0B6-3E80-0DF3-43B44050320B}"/>
               </a:ext>
             </a:extLst>
           </p:cNvPr>
@@ -4275,7 +4275,7 @@
           <p:cNvPr id="11" name="TextBox 10">
             <a:extLst>
               <a:ext uri="{FF2B5EF4-FFF2-40B4-BE49-F238E27FC236}">
-                <a16:creationId xmlns:a16="http://schemas.microsoft.com/office/drawing/2014/main" id="{3E436198-8F9E-BE37-26C9-4EC4884C2517}"/>
+                <a16:creationId xmlns:a16="http://schemas.microsoft.com/office/drawing/2014/main" id="{743573A8-656B-3A2E-BEB4-05C03F75B696}"/>
               </a:ext>
             </a:extLst>
           </p:cNvPr>
@@ -4413,7 +4413,7 @@
           <p:cNvPr id="12" name="사각형: 둥근 모서리 11">
             <a:extLst>
               <a:ext uri="{FF2B5EF4-FFF2-40B4-BE49-F238E27FC236}">
-                <a16:creationId xmlns:a16="http://schemas.microsoft.com/office/drawing/2014/main" id="{40F098AF-96C3-E2C7-3C81-28AB64A5992A}"/>
+                <a16:creationId xmlns:a16="http://schemas.microsoft.com/office/drawing/2014/main" id="{BA09D80C-E1F2-17DA-B4FD-38CA2000524A}"/>
               </a:ext>
             </a:extLst>
           </p:cNvPr>
@@ -4467,7 +4467,7 @@
           <p:cNvPr id="13" name="직사각형 12">
             <a:extLst>
               <a:ext uri="{FF2B5EF4-FFF2-40B4-BE49-F238E27FC236}">
-                <a16:creationId xmlns:a16="http://schemas.microsoft.com/office/drawing/2014/main" id="{B108E6F1-E7BC-4D4C-23E8-BB86D0CA9532}"/>
+                <a16:creationId xmlns:a16="http://schemas.microsoft.com/office/drawing/2014/main" id="{942DC3EC-5856-2C9F-FA28-AC6927B04993}"/>
               </a:ext>
             </a:extLst>
           </p:cNvPr>
@@ -4535,7 +4535,7 @@
           <p:cNvPr id="14" name="TextBox 13">
             <a:extLst>
               <a:ext uri="{FF2B5EF4-FFF2-40B4-BE49-F238E27FC236}">
-                <a16:creationId xmlns:a16="http://schemas.microsoft.com/office/drawing/2014/main" id="{EA69B422-505C-85AA-2864-0B0E376DBF0B}"/>
+                <a16:creationId xmlns:a16="http://schemas.microsoft.com/office/drawing/2014/main" id="{8F1B8DEE-E287-9AFD-CF6E-E895F7D0266D}"/>
               </a:ext>
             </a:extLst>
           </p:cNvPr>
@@ -4575,7 +4575,7 @@
           <p:cNvPr id="15" name="TextBox 14">
             <a:extLst>
               <a:ext uri="{FF2B5EF4-FFF2-40B4-BE49-F238E27FC236}">
-                <a16:creationId xmlns:a16="http://schemas.microsoft.com/office/drawing/2014/main" id="{BD3ED2C2-A19D-4EC3-0A76-F56370CA8A89}"/>
+                <a16:creationId xmlns:a16="http://schemas.microsoft.com/office/drawing/2014/main" id="{66FD93A8-CCB4-0584-B25F-7965BC566BE4}"/>
               </a:ext>
             </a:extLst>
           </p:cNvPr>
@@ -4635,7 +4635,7 @@
     </p:spTree>
     <p:extLst>
       <p:ext uri="{BB962C8B-B14F-4D97-AF65-F5344CB8AC3E}">
-        <p14:creationId xmlns:p14="http://schemas.microsoft.com/office/powerpoint/2010/main" val="2230737751"/>
+        <p14:creationId xmlns:p14="http://schemas.microsoft.com/office/powerpoint/2010/main" val="804719269"/>
       </p:ext>
     </p:extLst>
   </p:cSld>
@@ -4675,7 +4675,7 @@
           <p:cNvPr id="2" name="사각형: 둥근 모서리 1">
             <a:extLst>
               <a:ext uri="{FF2B5EF4-FFF2-40B4-BE49-F238E27FC236}">
-                <a16:creationId xmlns:a16="http://schemas.microsoft.com/office/drawing/2014/main" id="{16B16536-F9BA-1C19-7A61-B8385908888E}"/>
+                <a16:creationId xmlns:a16="http://schemas.microsoft.com/office/drawing/2014/main" id="{D0317305-E611-2C4F-014E-31D2C67D16CF}"/>
               </a:ext>
             </a:extLst>
           </p:cNvPr>
@@ -4757,7 +4757,7 @@
           <p:cNvPr id="3" name="TextBox 2">
             <a:extLst>
               <a:ext uri="{FF2B5EF4-FFF2-40B4-BE49-F238E27FC236}">
-                <a16:creationId xmlns:a16="http://schemas.microsoft.com/office/drawing/2014/main" id="{2A0C7542-AB9D-5B58-954C-FC06C5C0A541}"/>
+                <a16:creationId xmlns:a16="http://schemas.microsoft.com/office/drawing/2014/main" id="{B966EE13-1826-64E2-A844-F109BBDB7F59}"/>
               </a:ext>
             </a:extLst>
           </p:cNvPr>
@@ -4815,7 +4815,7 @@
           <p:cNvPr id="4" name="TextBox 3">
             <a:extLst>
               <a:ext uri="{FF2B5EF4-FFF2-40B4-BE49-F238E27FC236}">
-                <a16:creationId xmlns:a16="http://schemas.microsoft.com/office/drawing/2014/main" id="{4B9EECCD-9746-05E4-9F72-DC3ECCE3B56E}"/>
+                <a16:creationId xmlns:a16="http://schemas.microsoft.com/office/drawing/2014/main" id="{6A5CEA59-A1CC-E1F3-B599-26E615E808E6}"/>
               </a:ext>
             </a:extLst>
           </p:cNvPr>
@@ -4873,7 +4873,7 @@
           <p:cNvPr id="5" name="사각형: 둥근 모서리 4">
             <a:extLst>
               <a:ext uri="{FF2B5EF4-FFF2-40B4-BE49-F238E27FC236}">
-                <a16:creationId xmlns:a16="http://schemas.microsoft.com/office/drawing/2014/main" id="{1B218422-9968-D5BD-519F-8526E55C5795}"/>
+                <a16:creationId xmlns:a16="http://schemas.microsoft.com/office/drawing/2014/main" id="{BEB5EB4B-623A-5935-9056-F13C9C3A8A1D}"/>
               </a:ext>
             </a:extLst>
           </p:cNvPr>
@@ -4927,7 +4927,7 @@
           <p:cNvPr id="6" name="직사각형 5">
             <a:extLst>
               <a:ext uri="{FF2B5EF4-FFF2-40B4-BE49-F238E27FC236}">
-                <a16:creationId xmlns:a16="http://schemas.microsoft.com/office/drawing/2014/main" id="{F610BB5D-54E4-14FB-5331-56D5BD0ECD73}"/>
+                <a16:creationId xmlns:a16="http://schemas.microsoft.com/office/drawing/2014/main" id="{56BC62D9-26B1-B264-693C-8DCA008C4FBC}"/>
               </a:ext>
             </a:extLst>
           </p:cNvPr>
@@ -4995,7 +4995,7 @@
           <p:cNvPr id="7" name="TextBox 6">
             <a:extLst>
               <a:ext uri="{FF2B5EF4-FFF2-40B4-BE49-F238E27FC236}">
-                <a16:creationId xmlns:a16="http://schemas.microsoft.com/office/drawing/2014/main" id="{C1CB57CB-6F10-A05A-FB6A-9BD24738D340}"/>
+                <a16:creationId xmlns:a16="http://schemas.microsoft.com/office/drawing/2014/main" id="{DA5AD9F4-7E45-8496-4850-445CEDE6BC86}"/>
               </a:ext>
             </a:extLst>
           </p:cNvPr>
@@ -5035,7 +5035,7 @@
           <p:cNvPr id="8" name="TextBox 7">
             <a:extLst>
               <a:ext uri="{FF2B5EF4-FFF2-40B4-BE49-F238E27FC236}">
-                <a16:creationId xmlns:a16="http://schemas.microsoft.com/office/drawing/2014/main" id="{7B5EB2CD-8E32-4527-15B5-23E849DB50C7}"/>
+                <a16:creationId xmlns:a16="http://schemas.microsoft.com/office/drawing/2014/main" id="{3F0A7FF7-0B0F-4D63-8D7B-9BA42B725A44}"/>
               </a:ext>
             </a:extLst>
           </p:cNvPr>
@@ -5102,7 +5102,7 @@
           <p:cNvPr id="9" name="사각형: 둥근 모서리 8">
             <a:extLst>
               <a:ext uri="{FF2B5EF4-FFF2-40B4-BE49-F238E27FC236}">
-                <a16:creationId xmlns:a16="http://schemas.microsoft.com/office/drawing/2014/main" id="{AE8753AF-F60E-AA4B-6F71-0B2F4330D8FD}"/>
+                <a16:creationId xmlns:a16="http://schemas.microsoft.com/office/drawing/2014/main" id="{72F0E362-3754-5DBD-82C0-C01334369F12}"/>
               </a:ext>
             </a:extLst>
           </p:cNvPr>
@@ -5156,7 +5156,7 @@
           <p:cNvPr id="10" name="직사각형 9">
             <a:extLst>
               <a:ext uri="{FF2B5EF4-FFF2-40B4-BE49-F238E27FC236}">
-                <a16:creationId xmlns:a16="http://schemas.microsoft.com/office/drawing/2014/main" id="{03E0BAB6-630E-0185-6C8F-9FD462BB56D6}"/>
+                <a16:creationId xmlns:a16="http://schemas.microsoft.com/office/drawing/2014/main" id="{E5C077BE-0F82-FBE0-5A98-C81CE193E30E}"/>
               </a:ext>
             </a:extLst>
           </p:cNvPr>
@@ -5224,7 +5224,7 @@
           <p:cNvPr id="11" name="TextBox 10">
             <a:extLst>
               <a:ext uri="{FF2B5EF4-FFF2-40B4-BE49-F238E27FC236}">
-                <a16:creationId xmlns:a16="http://schemas.microsoft.com/office/drawing/2014/main" id="{34AFC727-8D1F-EAE5-4039-9039A5C43B69}"/>
+                <a16:creationId xmlns:a16="http://schemas.microsoft.com/office/drawing/2014/main" id="{6C64C4B2-ABF6-F06C-9FDA-C425E657998F}"/>
               </a:ext>
             </a:extLst>
           </p:cNvPr>
@@ -5264,7 +5264,7 @@
           <p:cNvPr id="12" name="TextBox 11">
             <a:extLst>
               <a:ext uri="{FF2B5EF4-FFF2-40B4-BE49-F238E27FC236}">
-                <a16:creationId xmlns:a16="http://schemas.microsoft.com/office/drawing/2014/main" id="{32AC7C03-C56D-6BEB-9DCC-FE415D8E22EF}"/>
+                <a16:creationId xmlns:a16="http://schemas.microsoft.com/office/drawing/2014/main" id="{C3B61464-66D7-2099-AC85-F161D931EB61}"/>
               </a:ext>
             </a:extLst>
           </p:cNvPr>
@@ -5304,7 +5304,7 @@
           <p:cNvPr id="13" name="사각형: 둥근 모서리 12">
             <a:extLst>
               <a:ext uri="{FF2B5EF4-FFF2-40B4-BE49-F238E27FC236}">
-                <a16:creationId xmlns:a16="http://schemas.microsoft.com/office/drawing/2014/main" id="{867B4632-5EEE-E6FF-AF63-FE01FFF19C6B}"/>
+                <a16:creationId xmlns:a16="http://schemas.microsoft.com/office/drawing/2014/main" id="{E1E52E0C-52AD-A3A7-C4D8-CDE6063CB444}"/>
               </a:ext>
             </a:extLst>
           </p:cNvPr>
@@ -5358,7 +5358,7 @@
           <p:cNvPr id="14" name="직사각형 13">
             <a:extLst>
               <a:ext uri="{FF2B5EF4-FFF2-40B4-BE49-F238E27FC236}">
-                <a16:creationId xmlns:a16="http://schemas.microsoft.com/office/drawing/2014/main" id="{824BE17D-438B-C6F5-E78A-372E69C8981F}"/>
+                <a16:creationId xmlns:a16="http://schemas.microsoft.com/office/drawing/2014/main" id="{58E7DE36-B0AD-2CD6-7F99-C04E95138531}"/>
               </a:ext>
             </a:extLst>
           </p:cNvPr>
@@ -5426,7 +5426,7 @@
           <p:cNvPr id="15" name="TextBox 14">
             <a:extLst>
               <a:ext uri="{FF2B5EF4-FFF2-40B4-BE49-F238E27FC236}">
-                <a16:creationId xmlns:a16="http://schemas.microsoft.com/office/drawing/2014/main" id="{3D9268AA-3CD4-0F47-B985-63D3B71F4764}"/>
+                <a16:creationId xmlns:a16="http://schemas.microsoft.com/office/drawing/2014/main" id="{188B5FEB-3FDD-B371-7F9C-CECA277FD73B}"/>
               </a:ext>
             </a:extLst>
           </p:cNvPr>
@@ -5466,7 +5466,7 @@
           <p:cNvPr id="16" name="TextBox 15">
             <a:extLst>
               <a:ext uri="{FF2B5EF4-FFF2-40B4-BE49-F238E27FC236}">
-                <a16:creationId xmlns:a16="http://schemas.microsoft.com/office/drawing/2014/main" id="{910F94A8-401C-E8DC-5632-38E2C322B6CA}"/>
+                <a16:creationId xmlns:a16="http://schemas.microsoft.com/office/drawing/2014/main" id="{A84386A1-0067-B152-745C-34C795241130}"/>
               </a:ext>
             </a:extLst>
           </p:cNvPr>
@@ -5506,7 +5506,7 @@
           <p:cNvPr id="17" name="TextBox 16">
             <a:extLst>
               <a:ext uri="{FF2B5EF4-FFF2-40B4-BE49-F238E27FC236}">
-                <a16:creationId xmlns:a16="http://schemas.microsoft.com/office/drawing/2014/main" id="{455B6D41-4196-0889-E34F-327EBAF39A3F}"/>
+                <a16:creationId xmlns:a16="http://schemas.microsoft.com/office/drawing/2014/main" id="{166C8FFB-16FD-44A9-FD85-BD10F3FAF98A}"/>
               </a:ext>
             </a:extLst>
           </p:cNvPr>
@@ -5572,7 +5572,7 @@
     </p:spTree>
     <p:extLst>
       <p:ext uri="{BB962C8B-B14F-4D97-AF65-F5344CB8AC3E}">
-        <p14:creationId xmlns:p14="http://schemas.microsoft.com/office/powerpoint/2010/main" val="1832381834"/>
+        <p14:creationId xmlns:p14="http://schemas.microsoft.com/office/powerpoint/2010/main" val="1835994320"/>
       </p:ext>
     </p:extLst>
   </p:cSld>
@@ -5612,7 +5612,7 @@
           <p:cNvPr id="2" name="사각형: 둥근 모서리 1">
             <a:extLst>
               <a:ext uri="{FF2B5EF4-FFF2-40B4-BE49-F238E27FC236}">
-                <a16:creationId xmlns:a16="http://schemas.microsoft.com/office/drawing/2014/main" id="{3B609658-664E-62C3-EAA8-8179446C9715}"/>
+                <a16:creationId xmlns:a16="http://schemas.microsoft.com/office/drawing/2014/main" id="{C325DF40-6C8C-130F-1CEB-B39C576DA793}"/>
               </a:ext>
             </a:extLst>
           </p:cNvPr>
@@ -5694,7 +5694,7 @@
           <p:cNvPr id="3" name="TextBox 2">
             <a:extLst>
               <a:ext uri="{FF2B5EF4-FFF2-40B4-BE49-F238E27FC236}">
-                <a16:creationId xmlns:a16="http://schemas.microsoft.com/office/drawing/2014/main" id="{A850DC06-13CB-1820-ABBD-87F4C5E90A31}"/>
+                <a16:creationId xmlns:a16="http://schemas.microsoft.com/office/drawing/2014/main" id="{337E68C8-A12C-7FF6-CF03-F292096604C7}"/>
               </a:ext>
             </a:extLst>
           </p:cNvPr>
@@ -5734,7 +5734,7 @@
           <p:cNvPr id="4" name="TextBox 3">
             <a:extLst>
               <a:ext uri="{FF2B5EF4-FFF2-40B4-BE49-F238E27FC236}">
-                <a16:creationId xmlns:a16="http://schemas.microsoft.com/office/drawing/2014/main" id="{AC55A6F3-1DFD-87EE-4DDA-3170F3578354}"/>
+                <a16:creationId xmlns:a16="http://schemas.microsoft.com/office/drawing/2014/main" id="{738D984C-21D4-8B5A-F3DE-D4570DEFBE57}"/>
               </a:ext>
             </a:extLst>
           </p:cNvPr>
@@ -5828,7 +5828,7 @@
           <p:cNvPr id="5" name="사각형: 둥근 모서리 4">
             <a:extLst>
               <a:ext uri="{FF2B5EF4-FFF2-40B4-BE49-F238E27FC236}">
-                <a16:creationId xmlns:a16="http://schemas.microsoft.com/office/drawing/2014/main" id="{668A12D0-CB50-37B8-3540-D106D1193405}"/>
+                <a16:creationId xmlns:a16="http://schemas.microsoft.com/office/drawing/2014/main" id="{E41C297B-6E7F-E139-7055-2D5A9360BAD3}"/>
               </a:ext>
             </a:extLst>
           </p:cNvPr>
@@ -5887,7 +5887,7 @@
           <p:cNvPr id="7" name="그림 6">
             <a:extLst>
               <a:ext uri="{FF2B5EF4-FFF2-40B4-BE49-F238E27FC236}">
-                <a16:creationId xmlns:a16="http://schemas.microsoft.com/office/drawing/2014/main" id="{CE871BC4-7C4D-5FCD-6409-42D6EC2A58D6}"/>
+                <a16:creationId xmlns:a16="http://schemas.microsoft.com/office/drawing/2014/main" id="{6F5051AE-09A3-2599-9836-641447750E75}"/>
               </a:ext>
             </a:extLst>
           </p:cNvPr>
@@ -5923,7 +5923,7 @@
           <p:cNvPr id="8" name="사각형: 둥근 모서리 7">
             <a:extLst>
               <a:ext uri="{FF2B5EF4-FFF2-40B4-BE49-F238E27FC236}">
-                <a16:creationId xmlns:a16="http://schemas.microsoft.com/office/drawing/2014/main" id="{98ADD97B-AD7E-6750-A555-7CC5DBC4E72C}"/>
+                <a16:creationId xmlns:a16="http://schemas.microsoft.com/office/drawing/2014/main" id="{5ED739C1-EF67-1CCA-46DC-1C1167321BD9}"/>
               </a:ext>
             </a:extLst>
           </p:cNvPr>
@@ -5982,7 +5982,7 @@
           <p:cNvPr id="10" name="그림 9">
             <a:extLst>
               <a:ext uri="{FF2B5EF4-FFF2-40B4-BE49-F238E27FC236}">
-                <a16:creationId xmlns:a16="http://schemas.microsoft.com/office/drawing/2014/main" id="{756C6A87-CF64-D464-ADBA-64C3A2491A1D}"/>
+                <a16:creationId xmlns:a16="http://schemas.microsoft.com/office/drawing/2014/main" id="{4F48AC60-3574-FC93-F44D-DA0242ECD56A}"/>
               </a:ext>
             </a:extLst>
           </p:cNvPr>
@@ -6018,7 +6018,7 @@
           <p:cNvPr id="11" name="사각형: 둥근 모서리 10">
             <a:extLst>
               <a:ext uri="{FF2B5EF4-FFF2-40B4-BE49-F238E27FC236}">
-                <a16:creationId xmlns:a16="http://schemas.microsoft.com/office/drawing/2014/main" id="{28A24952-B450-FC34-697F-96162C3EA554}"/>
+                <a16:creationId xmlns:a16="http://schemas.microsoft.com/office/drawing/2014/main" id="{E903F256-8E5D-7210-BBB6-E53B0C51BC09}"/>
               </a:ext>
             </a:extLst>
           </p:cNvPr>
@@ -6077,7 +6077,7 @@
           <p:cNvPr id="13" name="그림 12">
             <a:extLst>
               <a:ext uri="{FF2B5EF4-FFF2-40B4-BE49-F238E27FC236}">
-                <a16:creationId xmlns:a16="http://schemas.microsoft.com/office/drawing/2014/main" id="{B0346AA2-975A-986F-3612-8221BDFD6A9C}"/>
+                <a16:creationId xmlns:a16="http://schemas.microsoft.com/office/drawing/2014/main" id="{B5DF76EB-5CC2-DDE4-8BCA-11631E72F82C}"/>
               </a:ext>
             </a:extLst>
           </p:cNvPr>
@@ -6113,7 +6113,7 @@
           <p:cNvPr id="14" name="사각형: 둥근 모서리 13">
             <a:extLst>
               <a:ext uri="{FF2B5EF4-FFF2-40B4-BE49-F238E27FC236}">
-                <a16:creationId xmlns:a16="http://schemas.microsoft.com/office/drawing/2014/main" id="{5A71CED9-65F2-BDCB-25DE-4842165EB7CB}"/>
+                <a16:creationId xmlns:a16="http://schemas.microsoft.com/office/drawing/2014/main" id="{ADC76B9A-2477-B98C-2DB0-FF482AE62AB5}"/>
               </a:ext>
             </a:extLst>
           </p:cNvPr>
@@ -6167,7 +6167,7 @@
           <p:cNvPr id="15" name="직사각형 14">
             <a:extLst>
               <a:ext uri="{FF2B5EF4-FFF2-40B4-BE49-F238E27FC236}">
-                <a16:creationId xmlns:a16="http://schemas.microsoft.com/office/drawing/2014/main" id="{FA5F2A28-943F-BE7C-EDA3-755C115AB3BF}"/>
+                <a16:creationId xmlns:a16="http://schemas.microsoft.com/office/drawing/2014/main" id="{E11EBC87-4053-A881-6A7C-059411533277}"/>
               </a:ext>
             </a:extLst>
           </p:cNvPr>
@@ -6235,7 +6235,7 @@
           <p:cNvPr id="16" name="TextBox 15">
             <a:extLst>
               <a:ext uri="{FF2B5EF4-FFF2-40B4-BE49-F238E27FC236}">
-                <a16:creationId xmlns:a16="http://schemas.microsoft.com/office/drawing/2014/main" id="{10DDCA10-5611-E283-678E-2AFA48720DA0}"/>
+                <a16:creationId xmlns:a16="http://schemas.microsoft.com/office/drawing/2014/main" id="{E10405F6-517B-6465-FAE0-4C2922973FDA}"/>
               </a:ext>
             </a:extLst>
           </p:cNvPr>
@@ -6293,7 +6293,7 @@
           <p:cNvPr id="17" name="TextBox 16">
             <a:extLst>
               <a:ext uri="{FF2B5EF4-FFF2-40B4-BE49-F238E27FC236}">
-                <a16:creationId xmlns:a16="http://schemas.microsoft.com/office/drawing/2014/main" id="{3544A2E8-476B-574C-C741-EFBA72461750}"/>
+                <a16:creationId xmlns:a16="http://schemas.microsoft.com/office/drawing/2014/main" id="{48083436-EC68-E52B-CAC1-722E40D17318}"/>
               </a:ext>
             </a:extLst>
           </p:cNvPr>
@@ -6333,7 +6333,7 @@
           <p:cNvPr id="18" name="사각형: 둥근 모서리 17">
             <a:extLst>
               <a:ext uri="{FF2B5EF4-FFF2-40B4-BE49-F238E27FC236}">
-                <a16:creationId xmlns:a16="http://schemas.microsoft.com/office/drawing/2014/main" id="{BCBB57C4-2002-492D-5271-0838C47EF693}"/>
+                <a16:creationId xmlns:a16="http://schemas.microsoft.com/office/drawing/2014/main" id="{5B910603-13F0-0C46-B914-2F06FC6E9ACA}"/>
               </a:ext>
             </a:extLst>
           </p:cNvPr>
@@ -6387,7 +6387,7 @@
           <p:cNvPr id="19" name="직사각형 18">
             <a:extLst>
               <a:ext uri="{FF2B5EF4-FFF2-40B4-BE49-F238E27FC236}">
-                <a16:creationId xmlns:a16="http://schemas.microsoft.com/office/drawing/2014/main" id="{3F44CEE9-6920-8CED-0017-536D0BD010F9}"/>
+                <a16:creationId xmlns:a16="http://schemas.microsoft.com/office/drawing/2014/main" id="{18DA8250-3587-A349-23C0-FAB7A6F66DC8}"/>
               </a:ext>
             </a:extLst>
           </p:cNvPr>
@@ -6455,7 +6455,7 @@
           <p:cNvPr id="20" name="TextBox 19">
             <a:extLst>
               <a:ext uri="{FF2B5EF4-FFF2-40B4-BE49-F238E27FC236}">
-                <a16:creationId xmlns:a16="http://schemas.microsoft.com/office/drawing/2014/main" id="{3825CC3C-1299-0D7B-715F-04B5B381D093}"/>
+                <a16:creationId xmlns:a16="http://schemas.microsoft.com/office/drawing/2014/main" id="{256E26BF-C3DC-1A53-3F3D-B3159C1CE19F}"/>
               </a:ext>
             </a:extLst>
           </p:cNvPr>
@@ -6495,7 +6495,7 @@
           <p:cNvPr id="21" name="TextBox 20">
             <a:extLst>
               <a:ext uri="{FF2B5EF4-FFF2-40B4-BE49-F238E27FC236}">
-                <a16:creationId xmlns:a16="http://schemas.microsoft.com/office/drawing/2014/main" id="{6985D783-3169-FE39-6375-3EFE2B9AEB17}"/>
+                <a16:creationId xmlns:a16="http://schemas.microsoft.com/office/drawing/2014/main" id="{CCC0966D-C342-BC16-DD0E-68EFED6CBBC2}"/>
               </a:ext>
             </a:extLst>
           </p:cNvPr>
@@ -6535,7 +6535,7 @@
           <p:cNvPr id="22" name="사각형: 둥근 모서리 21">
             <a:extLst>
               <a:ext uri="{FF2B5EF4-FFF2-40B4-BE49-F238E27FC236}">
-                <a16:creationId xmlns:a16="http://schemas.microsoft.com/office/drawing/2014/main" id="{88A40923-3EED-8AE7-29B3-5F3C631A707C}"/>
+                <a16:creationId xmlns:a16="http://schemas.microsoft.com/office/drawing/2014/main" id="{C0B5AE80-8B7B-F3E8-50CF-D2A685120684}"/>
               </a:ext>
             </a:extLst>
           </p:cNvPr>
@@ -6589,7 +6589,7 @@
           <p:cNvPr id="23" name="직사각형 22">
             <a:extLst>
               <a:ext uri="{FF2B5EF4-FFF2-40B4-BE49-F238E27FC236}">
-                <a16:creationId xmlns:a16="http://schemas.microsoft.com/office/drawing/2014/main" id="{CE3865E4-98D9-4374-C1CB-73F6B373EB4A}"/>
+                <a16:creationId xmlns:a16="http://schemas.microsoft.com/office/drawing/2014/main" id="{5BE7AF40-A24C-5C1F-E2ED-4DF9D6AE8224}"/>
               </a:ext>
             </a:extLst>
           </p:cNvPr>
@@ -6657,7 +6657,7 @@
           <p:cNvPr id="24" name="TextBox 23">
             <a:extLst>
               <a:ext uri="{FF2B5EF4-FFF2-40B4-BE49-F238E27FC236}">
-                <a16:creationId xmlns:a16="http://schemas.microsoft.com/office/drawing/2014/main" id="{719128CB-7909-F454-1E34-FD508D300831}"/>
+                <a16:creationId xmlns:a16="http://schemas.microsoft.com/office/drawing/2014/main" id="{80036917-D4D3-03CB-F5FE-6D17AE5C1CE0}"/>
               </a:ext>
             </a:extLst>
           </p:cNvPr>
@@ -6715,7 +6715,7 @@
           <p:cNvPr id="25" name="TextBox 24">
             <a:extLst>
               <a:ext uri="{FF2B5EF4-FFF2-40B4-BE49-F238E27FC236}">
-                <a16:creationId xmlns:a16="http://schemas.microsoft.com/office/drawing/2014/main" id="{B2F8BD7D-EFDB-EB2D-F0D9-4FA04EE05098}"/>
+                <a16:creationId xmlns:a16="http://schemas.microsoft.com/office/drawing/2014/main" id="{0D99565B-BA7B-4667-7FC7-E7333B01FBCA}"/>
               </a:ext>
             </a:extLst>
           </p:cNvPr>
@@ -6771,7 +6771,7 @@
     </p:spTree>
     <p:extLst>
       <p:ext uri="{BB962C8B-B14F-4D97-AF65-F5344CB8AC3E}">
-        <p14:creationId xmlns:p14="http://schemas.microsoft.com/office/powerpoint/2010/main" val="1443611508"/>
+        <p14:creationId xmlns:p14="http://schemas.microsoft.com/office/powerpoint/2010/main" val="3196447357"/>
       </p:ext>
     </p:extLst>
   </p:cSld>
@@ -6811,7 +6811,7 @@
           <p:cNvPr id="2" name="TextBox 1">
             <a:extLst>
               <a:ext uri="{FF2B5EF4-FFF2-40B4-BE49-F238E27FC236}">
-                <a16:creationId xmlns:a16="http://schemas.microsoft.com/office/drawing/2014/main" id="{079B4C96-818C-8B8C-7151-96A343681FE8}"/>
+                <a16:creationId xmlns:a16="http://schemas.microsoft.com/office/drawing/2014/main" id="{E34D568A-3C02-E9E2-A6D1-A95ED8BAFA51}"/>
               </a:ext>
             </a:extLst>
           </p:cNvPr>
@@ -6857,7 +6857,7 @@
           <p:cNvPr id="3" name="TextBox 2">
             <a:extLst>
               <a:ext uri="{FF2B5EF4-FFF2-40B4-BE49-F238E27FC236}">
-                <a16:creationId xmlns:a16="http://schemas.microsoft.com/office/drawing/2014/main" id="{CF602833-7DBB-CCB8-5E61-EBEF98319264}"/>
+                <a16:creationId xmlns:a16="http://schemas.microsoft.com/office/drawing/2014/main" id="{7EC2E046-C620-7622-AD6D-0B6E0B1CC2F0}"/>
               </a:ext>
             </a:extLst>
           </p:cNvPr>
@@ -6903,7 +6903,7 @@
           <p:cNvPr id="4" name="TextBox 3">
             <a:extLst>
               <a:ext uri="{FF2B5EF4-FFF2-40B4-BE49-F238E27FC236}">
-                <a16:creationId xmlns:a16="http://schemas.microsoft.com/office/drawing/2014/main" id="{D853726F-28E8-5501-3AE6-A9D3115F5D9A}"/>
+                <a16:creationId xmlns:a16="http://schemas.microsoft.com/office/drawing/2014/main" id="{EB5528AF-4D06-02A2-12F1-2C78C84AF29B}"/>
               </a:ext>
             </a:extLst>
           </p:cNvPr>
@@ -6961,7 +6961,7 @@
           <p:cNvPr id="5" name="TextBox 4">
             <a:extLst>
               <a:ext uri="{FF2B5EF4-FFF2-40B4-BE49-F238E27FC236}">
-                <a16:creationId xmlns:a16="http://schemas.microsoft.com/office/drawing/2014/main" id="{4DC2FEFB-A2BA-C4D2-A4A3-06CE1AE7CB4C}"/>
+                <a16:creationId xmlns:a16="http://schemas.microsoft.com/office/drawing/2014/main" id="{FAA0C64E-127E-E19B-0D9F-3681580C9B19}"/>
               </a:ext>
             </a:extLst>
           </p:cNvPr>
@@ -7019,7 +7019,7 @@
           <p:cNvPr id="6" name="사각형: 둥근 모서리 5">
             <a:extLst>
               <a:ext uri="{FF2B5EF4-FFF2-40B4-BE49-F238E27FC236}">
-                <a16:creationId xmlns:a16="http://schemas.microsoft.com/office/drawing/2014/main" id="{B296D931-6BEF-7FA3-C4E8-DCB898B17C60}"/>
+                <a16:creationId xmlns:a16="http://schemas.microsoft.com/office/drawing/2014/main" id="{4F0F73E0-B290-65C2-C014-85FA6B7892FE}"/>
               </a:ext>
             </a:extLst>
           </p:cNvPr>
@@ -7095,7 +7095,7 @@
           <p:cNvPr id="7" name="직선 연결선 6">
             <a:extLst>
               <a:ext uri="{FF2B5EF4-FFF2-40B4-BE49-F238E27FC236}">
-                <a16:creationId xmlns:a16="http://schemas.microsoft.com/office/drawing/2014/main" id="{CD962D63-6582-F5CB-5409-2D864D0E358A}"/>
+                <a16:creationId xmlns:a16="http://schemas.microsoft.com/office/drawing/2014/main" id="{D7C2EA73-FE96-3A8F-D05A-CB67ECFE91B0}"/>
               </a:ext>
             </a:extLst>
           </p:cNvPr>
@@ -7137,7 +7137,7 @@
           <p:cNvPr id="8" name="사각형: 둥근 모서리 7">
             <a:extLst>
               <a:ext uri="{FF2B5EF4-FFF2-40B4-BE49-F238E27FC236}">
-                <a16:creationId xmlns:a16="http://schemas.microsoft.com/office/drawing/2014/main" id="{6C302D55-D6A4-17EA-6A45-6D40F739C81D}"/>
+                <a16:creationId xmlns:a16="http://schemas.microsoft.com/office/drawing/2014/main" id="{6C6DFFA9-13FC-F576-EF58-25D2F9628999}"/>
               </a:ext>
             </a:extLst>
           </p:cNvPr>
@@ -7213,7 +7213,7 @@
           <p:cNvPr id="9" name="직선 연결선 8">
             <a:extLst>
               <a:ext uri="{FF2B5EF4-FFF2-40B4-BE49-F238E27FC236}">
-                <a16:creationId xmlns:a16="http://schemas.microsoft.com/office/drawing/2014/main" id="{FE85D14C-2267-F3F0-E4CE-6333938BEF82}"/>
+                <a16:creationId xmlns:a16="http://schemas.microsoft.com/office/drawing/2014/main" id="{4AAEAC09-F970-9611-68CA-D996BF31E9AB}"/>
               </a:ext>
             </a:extLst>
           </p:cNvPr>
@@ -7255,7 +7255,7 @@
           <p:cNvPr id="10" name="사각형: 둥근 모서리 9">
             <a:extLst>
               <a:ext uri="{FF2B5EF4-FFF2-40B4-BE49-F238E27FC236}">
-                <a16:creationId xmlns:a16="http://schemas.microsoft.com/office/drawing/2014/main" id="{88020644-D8D7-7285-0FB0-B4D9E9D5DC6F}"/>
+                <a16:creationId xmlns:a16="http://schemas.microsoft.com/office/drawing/2014/main" id="{044BC50C-492D-CA68-927F-0EA1C1F35B68}"/>
               </a:ext>
             </a:extLst>
           </p:cNvPr>
@@ -7331,7 +7331,7 @@
           <p:cNvPr id="11" name="직선 연결선 10">
             <a:extLst>
               <a:ext uri="{FF2B5EF4-FFF2-40B4-BE49-F238E27FC236}">
-                <a16:creationId xmlns:a16="http://schemas.microsoft.com/office/drawing/2014/main" id="{E9DC2715-7363-5432-EF67-9B10BC3A3122}"/>
+                <a16:creationId xmlns:a16="http://schemas.microsoft.com/office/drawing/2014/main" id="{BEF71335-EA6E-AFDF-1B9A-5A26A8B8ABF7}"/>
               </a:ext>
             </a:extLst>
           </p:cNvPr>
@@ -7373,7 +7373,7 @@
           <p:cNvPr id="12" name="사각형: 둥근 모서리 11">
             <a:extLst>
               <a:ext uri="{FF2B5EF4-FFF2-40B4-BE49-F238E27FC236}">
-                <a16:creationId xmlns:a16="http://schemas.microsoft.com/office/drawing/2014/main" id="{0E792D20-873D-6E2F-26D0-B2F9DFA83585}"/>
+                <a16:creationId xmlns:a16="http://schemas.microsoft.com/office/drawing/2014/main" id="{186A61CE-B08F-91E5-4E79-574F1C2EF6B0}"/>
               </a:ext>
             </a:extLst>
           </p:cNvPr>
@@ -7449,7 +7449,7 @@
           <p:cNvPr id="13" name="직선 연결선 12">
             <a:extLst>
               <a:ext uri="{FF2B5EF4-FFF2-40B4-BE49-F238E27FC236}">
-                <a16:creationId xmlns:a16="http://schemas.microsoft.com/office/drawing/2014/main" id="{018E8F9D-373C-0876-0C79-AB78A5019690}"/>
+                <a16:creationId xmlns:a16="http://schemas.microsoft.com/office/drawing/2014/main" id="{78A279BB-A58B-9FB7-1E21-08E7EEB2AE9F}"/>
               </a:ext>
             </a:extLst>
           </p:cNvPr>
@@ -7491,7 +7491,7 @@
           <p:cNvPr id="14" name="사각형: 둥근 모서리 13">
             <a:extLst>
               <a:ext uri="{FF2B5EF4-FFF2-40B4-BE49-F238E27FC236}">
-                <a16:creationId xmlns:a16="http://schemas.microsoft.com/office/drawing/2014/main" id="{BB919B42-0E46-31AC-4DB6-E6BF887D2EA1}"/>
+                <a16:creationId xmlns:a16="http://schemas.microsoft.com/office/drawing/2014/main" id="{5C301DC4-556A-DCF8-11A6-2FC7DBE050E5}"/>
               </a:ext>
             </a:extLst>
           </p:cNvPr>
@@ -7567,7 +7567,7 @@
           <p:cNvPr id="15" name="사각형: 둥근 모서리 14">
             <a:extLst>
               <a:ext uri="{FF2B5EF4-FFF2-40B4-BE49-F238E27FC236}">
-                <a16:creationId xmlns:a16="http://schemas.microsoft.com/office/drawing/2014/main" id="{22364582-AD89-D83A-5AD1-8C532E50C666}"/>
+                <a16:creationId xmlns:a16="http://schemas.microsoft.com/office/drawing/2014/main" id="{B7324A23-C827-69A6-063C-CB846B6AC740}"/>
               </a:ext>
             </a:extLst>
           </p:cNvPr>
@@ -7621,7 +7621,7 @@
           <p:cNvPr id="16" name="직사각형 15">
             <a:extLst>
               <a:ext uri="{FF2B5EF4-FFF2-40B4-BE49-F238E27FC236}">
-                <a16:creationId xmlns:a16="http://schemas.microsoft.com/office/drawing/2014/main" id="{D68D9DA8-D74E-C1DB-FFA1-BD090FCD6E0D}"/>
+                <a16:creationId xmlns:a16="http://schemas.microsoft.com/office/drawing/2014/main" id="{77678488-0039-A60B-0677-EFD043215DE4}"/>
               </a:ext>
             </a:extLst>
           </p:cNvPr>
@@ -7689,7 +7689,7 @@
           <p:cNvPr id="17" name="TextBox 16">
             <a:extLst>
               <a:ext uri="{FF2B5EF4-FFF2-40B4-BE49-F238E27FC236}">
-                <a16:creationId xmlns:a16="http://schemas.microsoft.com/office/drawing/2014/main" id="{5DCA1CBC-2F18-32B5-BC59-770321BE98C0}"/>
+                <a16:creationId xmlns:a16="http://schemas.microsoft.com/office/drawing/2014/main" id="{D674DD68-AE65-C4B5-536D-27D05EDF1087}"/>
               </a:ext>
             </a:extLst>
           </p:cNvPr>
@@ -7729,7 +7729,7 @@
           <p:cNvPr id="18" name="TextBox 17">
             <a:extLst>
               <a:ext uri="{FF2B5EF4-FFF2-40B4-BE49-F238E27FC236}">
-                <a16:creationId xmlns:a16="http://schemas.microsoft.com/office/drawing/2014/main" id="{BC41E0F8-6027-45E8-BE13-0A644CBFCCA2}"/>
+                <a16:creationId xmlns:a16="http://schemas.microsoft.com/office/drawing/2014/main" id="{D167BD62-8EAF-A417-692C-E787EDDB47B4}"/>
               </a:ext>
             </a:extLst>
           </p:cNvPr>
@@ -7802,7 +7802,7 @@
           <p:cNvPr id="19" name="사각형: 둥근 모서리 18">
             <a:extLst>
               <a:ext uri="{FF2B5EF4-FFF2-40B4-BE49-F238E27FC236}">
-                <a16:creationId xmlns:a16="http://schemas.microsoft.com/office/drawing/2014/main" id="{212D2464-987B-C384-8579-FC208CF8F444}"/>
+                <a16:creationId xmlns:a16="http://schemas.microsoft.com/office/drawing/2014/main" id="{31894536-3612-68AA-6133-590D33CADE2C}"/>
               </a:ext>
             </a:extLst>
           </p:cNvPr>
@@ -7856,7 +7856,7 @@
           <p:cNvPr id="20" name="직사각형 19">
             <a:extLst>
               <a:ext uri="{FF2B5EF4-FFF2-40B4-BE49-F238E27FC236}">
-                <a16:creationId xmlns:a16="http://schemas.microsoft.com/office/drawing/2014/main" id="{CD353838-E3B4-ABE4-91A7-9D7082081652}"/>
+                <a16:creationId xmlns:a16="http://schemas.microsoft.com/office/drawing/2014/main" id="{576C26BC-C95F-0F55-5821-15203B3854B2}"/>
               </a:ext>
             </a:extLst>
           </p:cNvPr>
@@ -7924,7 +7924,7 @@
           <p:cNvPr id="21" name="TextBox 20">
             <a:extLst>
               <a:ext uri="{FF2B5EF4-FFF2-40B4-BE49-F238E27FC236}">
-                <a16:creationId xmlns:a16="http://schemas.microsoft.com/office/drawing/2014/main" id="{1A139707-8EF0-8389-109C-3B1A87DF8105}"/>
+                <a16:creationId xmlns:a16="http://schemas.microsoft.com/office/drawing/2014/main" id="{507F37BE-2419-9D6B-E05D-C2934C1B15AB}"/>
               </a:ext>
             </a:extLst>
           </p:cNvPr>
@@ -7964,7 +7964,7 @@
           <p:cNvPr id="22" name="TextBox 21">
             <a:extLst>
               <a:ext uri="{FF2B5EF4-FFF2-40B4-BE49-F238E27FC236}">
-                <a16:creationId xmlns:a16="http://schemas.microsoft.com/office/drawing/2014/main" id="{B8D66AD0-EFCA-B815-1E95-40C689E9B308}"/>
+                <a16:creationId xmlns:a16="http://schemas.microsoft.com/office/drawing/2014/main" id="{E736EECE-13B4-7CF8-A0DB-8DA86342B986}"/>
               </a:ext>
             </a:extLst>
           </p:cNvPr>
@@ -8019,7 +8019,7 @@
           <p:cNvPr id="23" name="사각형: 둥근 모서리 22">
             <a:extLst>
               <a:ext uri="{FF2B5EF4-FFF2-40B4-BE49-F238E27FC236}">
-                <a16:creationId xmlns:a16="http://schemas.microsoft.com/office/drawing/2014/main" id="{BC243643-8D23-555A-A491-A75C0238A47E}"/>
+                <a16:creationId xmlns:a16="http://schemas.microsoft.com/office/drawing/2014/main" id="{3024051E-C3FD-10F0-D0BF-B9A51265133C}"/>
               </a:ext>
             </a:extLst>
           </p:cNvPr>
@@ -8073,7 +8073,7 @@
           <p:cNvPr id="24" name="직사각형 23">
             <a:extLst>
               <a:ext uri="{FF2B5EF4-FFF2-40B4-BE49-F238E27FC236}">
-                <a16:creationId xmlns:a16="http://schemas.microsoft.com/office/drawing/2014/main" id="{BFEFDCE8-3163-1F55-7402-A1C0D3617037}"/>
+                <a16:creationId xmlns:a16="http://schemas.microsoft.com/office/drawing/2014/main" id="{CC25534C-9F4E-BCD7-3A83-99A40EAE2C45}"/>
               </a:ext>
             </a:extLst>
           </p:cNvPr>
@@ -8141,7 +8141,7 @@
           <p:cNvPr id="25" name="TextBox 24">
             <a:extLst>
               <a:ext uri="{FF2B5EF4-FFF2-40B4-BE49-F238E27FC236}">
-                <a16:creationId xmlns:a16="http://schemas.microsoft.com/office/drawing/2014/main" id="{D5A94A5E-7DF3-F4DA-88FB-EFD75F7782B0}"/>
+                <a16:creationId xmlns:a16="http://schemas.microsoft.com/office/drawing/2014/main" id="{EDE21FBC-4649-298C-5F1B-6D1691CB9A5D}"/>
               </a:ext>
             </a:extLst>
           </p:cNvPr>
@@ -8190,7 +8190,7 @@
           <p:cNvPr id="26" name="TextBox 25">
             <a:extLst>
               <a:ext uri="{FF2B5EF4-FFF2-40B4-BE49-F238E27FC236}">
-                <a16:creationId xmlns:a16="http://schemas.microsoft.com/office/drawing/2014/main" id="{FF29586E-0F52-2091-FBF6-6DD64B120DCB}"/>
+                <a16:creationId xmlns:a16="http://schemas.microsoft.com/office/drawing/2014/main" id="{E3CE050D-C429-F171-EF12-903786D1873E}"/>
               </a:ext>
             </a:extLst>
           </p:cNvPr>
@@ -8281,7 +8281,7 @@
           <p:cNvPr id="27" name="TextBox 26">
             <a:extLst>
               <a:ext uri="{FF2B5EF4-FFF2-40B4-BE49-F238E27FC236}">
-                <a16:creationId xmlns:a16="http://schemas.microsoft.com/office/drawing/2014/main" id="{1F2E0E52-00B4-32C9-A2EF-8DDA20EA202F}"/>
+                <a16:creationId xmlns:a16="http://schemas.microsoft.com/office/drawing/2014/main" id="{35E38C37-DF8D-DD60-0D9F-5D2551A0A6ED}"/>
               </a:ext>
             </a:extLst>
           </p:cNvPr>
@@ -8346,7 +8346,7 @@
     </p:spTree>
     <p:extLst>
       <p:ext uri="{BB962C8B-B14F-4D97-AF65-F5344CB8AC3E}">
-        <p14:creationId xmlns:p14="http://schemas.microsoft.com/office/powerpoint/2010/main" val="601344133"/>
+        <p14:creationId xmlns:p14="http://schemas.microsoft.com/office/powerpoint/2010/main" val="1653548780"/>
       </p:ext>
     </p:extLst>
   </p:cSld>
@@ -8386,7 +8386,7 @@
           <p:cNvPr id="2" name="TextBox 1">
             <a:extLst>
               <a:ext uri="{FF2B5EF4-FFF2-40B4-BE49-F238E27FC236}">
-                <a16:creationId xmlns:a16="http://schemas.microsoft.com/office/drawing/2014/main" id="{93E91578-2ED9-DC0F-3BEC-303D06778C23}"/>
+                <a16:creationId xmlns:a16="http://schemas.microsoft.com/office/drawing/2014/main" id="{5ED5DFA1-0C92-4AB7-E9E9-ABAEB0B21DE6}"/>
               </a:ext>
             </a:extLst>
           </p:cNvPr>
@@ -8432,7 +8432,7 @@
           <p:cNvPr id="3" name="TextBox 2">
             <a:extLst>
               <a:ext uri="{FF2B5EF4-FFF2-40B4-BE49-F238E27FC236}">
-                <a16:creationId xmlns:a16="http://schemas.microsoft.com/office/drawing/2014/main" id="{43117D30-3A56-7BF5-63B2-388B51326667}"/>
+                <a16:creationId xmlns:a16="http://schemas.microsoft.com/office/drawing/2014/main" id="{B575AFAD-0E7E-2C11-6902-1A4909366C1D}"/>
               </a:ext>
             </a:extLst>
           </p:cNvPr>
@@ -8478,7 +8478,7 @@
           <p:cNvPr id="4" name="TextBox 3">
             <a:extLst>
               <a:ext uri="{FF2B5EF4-FFF2-40B4-BE49-F238E27FC236}">
-                <a16:creationId xmlns:a16="http://schemas.microsoft.com/office/drawing/2014/main" id="{D84AEC8D-5497-DBD7-6A5E-C6983134E68C}"/>
+                <a16:creationId xmlns:a16="http://schemas.microsoft.com/office/drawing/2014/main" id="{41A845D1-D594-BE5D-11C5-642455852CDD}"/>
               </a:ext>
             </a:extLst>
           </p:cNvPr>
@@ -8518,7 +8518,7 @@
           <p:cNvPr id="5" name="TextBox 4">
             <a:extLst>
               <a:ext uri="{FF2B5EF4-FFF2-40B4-BE49-F238E27FC236}">
-                <a16:creationId xmlns:a16="http://schemas.microsoft.com/office/drawing/2014/main" id="{D5B418AF-615F-D09D-5A8F-AE4E8F7CF55B}"/>
+                <a16:creationId xmlns:a16="http://schemas.microsoft.com/office/drawing/2014/main" id="{68F455D3-040D-6C91-9579-4C51B1E50B09}"/>
               </a:ext>
             </a:extLst>
           </p:cNvPr>
@@ -8576,7 +8576,7 @@
           <p:cNvPr id="6" name="사각형: 둥근 모서리 5">
             <a:extLst>
               <a:ext uri="{FF2B5EF4-FFF2-40B4-BE49-F238E27FC236}">
-                <a16:creationId xmlns:a16="http://schemas.microsoft.com/office/drawing/2014/main" id="{C74E511B-DCFC-0172-697A-41FF9A5B5B30}"/>
+                <a16:creationId xmlns:a16="http://schemas.microsoft.com/office/drawing/2014/main" id="{1BDAA7F3-8C82-94FF-03F7-46A0B75FCB1D}"/>
               </a:ext>
             </a:extLst>
           </p:cNvPr>
@@ -8630,7 +8630,7 @@
           <p:cNvPr id="7" name="직사각형 6">
             <a:extLst>
               <a:ext uri="{FF2B5EF4-FFF2-40B4-BE49-F238E27FC236}">
-                <a16:creationId xmlns:a16="http://schemas.microsoft.com/office/drawing/2014/main" id="{76D14A8E-AB30-1016-8925-96FCB807F578}"/>
+                <a16:creationId xmlns:a16="http://schemas.microsoft.com/office/drawing/2014/main" id="{FAC35259-4C53-6FA1-CCD7-E5E9F28A1379}"/>
               </a:ext>
             </a:extLst>
           </p:cNvPr>
@@ -8698,7 +8698,7 @@
           <p:cNvPr id="8" name="TextBox 7">
             <a:extLst>
               <a:ext uri="{FF2B5EF4-FFF2-40B4-BE49-F238E27FC236}">
-                <a16:creationId xmlns:a16="http://schemas.microsoft.com/office/drawing/2014/main" id="{B489471B-E81C-88A7-FB1B-75D4BEA134D8}"/>
+                <a16:creationId xmlns:a16="http://schemas.microsoft.com/office/drawing/2014/main" id="{95DC1D22-538B-A37A-B326-6FA0F556BB41}"/>
               </a:ext>
             </a:extLst>
           </p:cNvPr>
@@ -8747,7 +8747,7 @@
           <p:cNvPr id="9" name="TextBox 8">
             <a:extLst>
               <a:ext uri="{FF2B5EF4-FFF2-40B4-BE49-F238E27FC236}">
-                <a16:creationId xmlns:a16="http://schemas.microsoft.com/office/drawing/2014/main" id="{FEF968A4-89BA-ED0D-D9F7-A69C1525C13B}"/>
+                <a16:creationId xmlns:a16="http://schemas.microsoft.com/office/drawing/2014/main" id="{84CD3F40-4833-4E22-8532-2F6A515548AE}"/>
               </a:ext>
             </a:extLst>
           </p:cNvPr>
@@ -8809,7 +8809,7 @@
           <p:cNvPr id="10" name="사각형: 둥근 모서리 9">
             <a:extLst>
               <a:ext uri="{FF2B5EF4-FFF2-40B4-BE49-F238E27FC236}">
-                <a16:creationId xmlns:a16="http://schemas.microsoft.com/office/drawing/2014/main" id="{BA65C280-25EF-68E5-861B-BF99A4BF0BC5}"/>
+                <a16:creationId xmlns:a16="http://schemas.microsoft.com/office/drawing/2014/main" id="{1F640DAC-F187-968A-E7AB-A10DF05F4370}"/>
               </a:ext>
             </a:extLst>
           </p:cNvPr>
@@ -8863,7 +8863,7 @@
           <p:cNvPr id="11" name="직사각형 10">
             <a:extLst>
               <a:ext uri="{FF2B5EF4-FFF2-40B4-BE49-F238E27FC236}">
-                <a16:creationId xmlns:a16="http://schemas.microsoft.com/office/drawing/2014/main" id="{05A54B8C-2350-3585-E591-79FC67BACA53}"/>
+                <a16:creationId xmlns:a16="http://schemas.microsoft.com/office/drawing/2014/main" id="{27BCF40E-7548-786F-E13E-7730D6FB6C23}"/>
               </a:ext>
             </a:extLst>
           </p:cNvPr>
@@ -8931,7 +8931,7 @@
           <p:cNvPr id="12" name="TextBox 11">
             <a:extLst>
               <a:ext uri="{FF2B5EF4-FFF2-40B4-BE49-F238E27FC236}">
-                <a16:creationId xmlns:a16="http://schemas.microsoft.com/office/drawing/2014/main" id="{D48DDD9B-910A-65F5-0F56-03F2646620C8}"/>
+                <a16:creationId xmlns:a16="http://schemas.microsoft.com/office/drawing/2014/main" id="{65401FCC-F225-5683-B38F-798CBCA5DAFC}"/>
               </a:ext>
             </a:extLst>
           </p:cNvPr>
@@ -8971,7 +8971,7 @@
           <p:cNvPr id="13" name="TextBox 12">
             <a:extLst>
               <a:ext uri="{FF2B5EF4-FFF2-40B4-BE49-F238E27FC236}">
-                <a16:creationId xmlns:a16="http://schemas.microsoft.com/office/drawing/2014/main" id="{B0DE512F-2A92-A753-9659-E1B3811D3037}"/>
+                <a16:creationId xmlns:a16="http://schemas.microsoft.com/office/drawing/2014/main" id="{E99D6CEF-720B-36AE-9583-0ECCEF1D90F5}"/>
               </a:ext>
             </a:extLst>
           </p:cNvPr>
@@ -9033,7 +9033,7 @@
           <p:cNvPr id="14" name="사각형: 둥근 모서리 13">
             <a:extLst>
               <a:ext uri="{FF2B5EF4-FFF2-40B4-BE49-F238E27FC236}">
-                <a16:creationId xmlns:a16="http://schemas.microsoft.com/office/drawing/2014/main" id="{D3D11DBC-48BA-B523-6B7C-C475A631154B}"/>
+                <a16:creationId xmlns:a16="http://schemas.microsoft.com/office/drawing/2014/main" id="{A146B513-FBA5-5CF8-8E64-149587E1C0E6}"/>
               </a:ext>
             </a:extLst>
           </p:cNvPr>
@@ -9087,7 +9087,7 @@
           <p:cNvPr id="15" name="직사각형 14">
             <a:extLst>
               <a:ext uri="{FF2B5EF4-FFF2-40B4-BE49-F238E27FC236}">
-                <a16:creationId xmlns:a16="http://schemas.microsoft.com/office/drawing/2014/main" id="{D380D97A-4115-0D0A-6CF5-A1F276631A47}"/>
+                <a16:creationId xmlns:a16="http://schemas.microsoft.com/office/drawing/2014/main" id="{1979FDC8-DF58-87B3-F5B3-15BADC285383}"/>
               </a:ext>
             </a:extLst>
           </p:cNvPr>
@@ -9155,7 +9155,7 @@
           <p:cNvPr id="16" name="TextBox 15">
             <a:extLst>
               <a:ext uri="{FF2B5EF4-FFF2-40B4-BE49-F238E27FC236}">
-                <a16:creationId xmlns:a16="http://schemas.microsoft.com/office/drawing/2014/main" id="{615EBB23-B9C2-81A5-1416-9D90F3AEC5FE}"/>
+                <a16:creationId xmlns:a16="http://schemas.microsoft.com/office/drawing/2014/main" id="{756FBB02-30FD-0FE1-7A34-5EE52957109E}"/>
               </a:ext>
             </a:extLst>
           </p:cNvPr>
@@ -9195,7 +9195,7 @@
           <p:cNvPr id="17" name="TextBox 16">
             <a:extLst>
               <a:ext uri="{FF2B5EF4-FFF2-40B4-BE49-F238E27FC236}">
-                <a16:creationId xmlns:a16="http://schemas.microsoft.com/office/drawing/2014/main" id="{034A78E6-12C2-0BEE-580B-5FB5008346AD}"/>
+                <a16:creationId xmlns:a16="http://schemas.microsoft.com/office/drawing/2014/main" id="{8313AEB8-BAA6-1DBC-EF39-E4F3D825061F}"/>
               </a:ext>
             </a:extLst>
           </p:cNvPr>
@@ -9253,7 +9253,7 @@
           <p:cNvPr id="18" name="TextBox 17">
             <a:extLst>
               <a:ext uri="{FF2B5EF4-FFF2-40B4-BE49-F238E27FC236}">
-                <a16:creationId xmlns:a16="http://schemas.microsoft.com/office/drawing/2014/main" id="{897B964A-E1B7-5E63-77E1-0CD64858816F}"/>
+                <a16:creationId xmlns:a16="http://schemas.microsoft.com/office/drawing/2014/main" id="{5A30C20C-5124-128A-2B10-EC4DC3ADF847}"/>
               </a:ext>
             </a:extLst>
           </p:cNvPr>
@@ -9294,7 +9294,7 @@
           <p:cNvPr id="19" name="TextBox 18">
             <a:extLst>
               <a:ext uri="{FF2B5EF4-FFF2-40B4-BE49-F238E27FC236}">
-                <a16:creationId xmlns:a16="http://schemas.microsoft.com/office/drawing/2014/main" id="{2D3ADA42-ED03-4F66-3C29-B5D0138EFC50}"/>
+                <a16:creationId xmlns:a16="http://schemas.microsoft.com/office/drawing/2014/main" id="{BFE6EA5C-0BF1-2813-BA68-55B2815AB9DC}"/>
               </a:ext>
             </a:extLst>
           </p:cNvPr>
@@ -9350,7 +9350,7 @@
           <p:cNvPr id="20" name="TextBox 19">
             <a:extLst>
               <a:ext uri="{FF2B5EF4-FFF2-40B4-BE49-F238E27FC236}">
-                <a16:creationId xmlns:a16="http://schemas.microsoft.com/office/drawing/2014/main" id="{DAB5F165-C294-9091-50F9-94AD4E90FD22}"/>
+                <a16:creationId xmlns:a16="http://schemas.microsoft.com/office/drawing/2014/main" id="{B4D96C3B-F530-AC7C-88A6-3C9A7C67E3FB}"/>
               </a:ext>
             </a:extLst>
           </p:cNvPr>
@@ -9415,7 +9415,7 @@
     </p:spTree>
     <p:extLst>
       <p:ext uri="{BB962C8B-B14F-4D97-AF65-F5344CB8AC3E}">
-        <p14:creationId xmlns:p14="http://schemas.microsoft.com/office/powerpoint/2010/main" val="2033096556"/>
+        <p14:creationId xmlns:p14="http://schemas.microsoft.com/office/powerpoint/2010/main" val="4189166882"/>
       </p:ext>
     </p:extLst>
   </p:cSld>
@@ -9455,7 +9455,7 @@
           <p:cNvPr id="2" name="TextBox 1">
             <a:extLst>
               <a:ext uri="{FF2B5EF4-FFF2-40B4-BE49-F238E27FC236}">
-                <a16:creationId xmlns:a16="http://schemas.microsoft.com/office/drawing/2014/main" id="{9BE8521A-F37F-1D61-DAE4-E72E3A17ED0A}"/>
+                <a16:creationId xmlns:a16="http://schemas.microsoft.com/office/drawing/2014/main" id="{4A453364-0253-CD75-AC0E-307E55230766}"/>
               </a:ext>
             </a:extLst>
           </p:cNvPr>
@@ -9501,7 +9501,7 @@
           <p:cNvPr id="3" name="TextBox 2">
             <a:extLst>
               <a:ext uri="{FF2B5EF4-FFF2-40B4-BE49-F238E27FC236}">
-                <a16:creationId xmlns:a16="http://schemas.microsoft.com/office/drawing/2014/main" id="{DB883F99-7C24-89AA-1329-E667A40C6F7F}"/>
+                <a16:creationId xmlns:a16="http://schemas.microsoft.com/office/drawing/2014/main" id="{D9F04184-DC13-C1ED-4A71-340D4D49C841}"/>
               </a:ext>
             </a:extLst>
           </p:cNvPr>
@@ -9547,7 +9547,7 @@
           <p:cNvPr id="4" name="TextBox 3">
             <a:extLst>
               <a:ext uri="{FF2B5EF4-FFF2-40B4-BE49-F238E27FC236}">
-                <a16:creationId xmlns:a16="http://schemas.microsoft.com/office/drawing/2014/main" id="{6182770B-028E-DC15-26E8-E73B9782EEDE}"/>
+                <a16:creationId xmlns:a16="http://schemas.microsoft.com/office/drawing/2014/main" id="{DEBE7D6E-B8EC-426C-4230-C172FE3427AE}"/>
               </a:ext>
             </a:extLst>
           </p:cNvPr>
@@ -9596,7 +9596,7 @@
           <p:cNvPr id="5" name="TextBox 4">
             <a:extLst>
               <a:ext uri="{FF2B5EF4-FFF2-40B4-BE49-F238E27FC236}">
-                <a16:creationId xmlns:a16="http://schemas.microsoft.com/office/drawing/2014/main" id="{D184E23C-D567-2919-02B5-D03F9E646FEB}"/>
+                <a16:creationId xmlns:a16="http://schemas.microsoft.com/office/drawing/2014/main" id="{8B7DED1F-3891-A85C-8854-8DD735548453}"/>
               </a:ext>
             </a:extLst>
           </p:cNvPr>
@@ -9654,7 +9654,7 @@
           <p:cNvPr id="6" name="사각형: 둥근 모서리 5">
             <a:extLst>
               <a:ext uri="{FF2B5EF4-FFF2-40B4-BE49-F238E27FC236}">
-                <a16:creationId xmlns:a16="http://schemas.microsoft.com/office/drawing/2014/main" id="{A95991BC-659A-ECFA-AACE-3F6A19A93D74}"/>
+                <a16:creationId xmlns:a16="http://schemas.microsoft.com/office/drawing/2014/main" id="{22419922-EEA8-D342-ACB5-4CAEB11064C9}"/>
               </a:ext>
             </a:extLst>
           </p:cNvPr>
@@ -9713,7 +9713,7 @@
           <p:cNvPr id="8" name="그림 7">
             <a:extLst>
               <a:ext uri="{FF2B5EF4-FFF2-40B4-BE49-F238E27FC236}">
-                <a16:creationId xmlns:a16="http://schemas.microsoft.com/office/drawing/2014/main" id="{B12D737B-4AC7-0289-1833-52D433D64B66}"/>
+                <a16:creationId xmlns:a16="http://schemas.microsoft.com/office/drawing/2014/main" id="{4F659938-CA67-F026-11D0-9A0F2953A9F6}"/>
               </a:ext>
             </a:extLst>
           </p:cNvPr>
@@ -9749,7 +9749,7 @@
           <p:cNvPr id="9" name="사각형: 둥근 모서리 8">
             <a:extLst>
               <a:ext uri="{FF2B5EF4-FFF2-40B4-BE49-F238E27FC236}">
-                <a16:creationId xmlns:a16="http://schemas.microsoft.com/office/drawing/2014/main" id="{13C48A4C-1C89-5C04-8E1A-D1B1D6CC9FF2}"/>
+                <a16:creationId xmlns:a16="http://schemas.microsoft.com/office/drawing/2014/main" id="{6159A6E3-40AA-0D59-4F6A-A45B592695C6}"/>
               </a:ext>
             </a:extLst>
           </p:cNvPr>
@@ -9843,7 +9843,7 @@
           <p:cNvPr id="10" name="사각형: 둥근 모서리 9">
             <a:extLst>
               <a:ext uri="{FF2B5EF4-FFF2-40B4-BE49-F238E27FC236}">
-                <a16:creationId xmlns:a16="http://schemas.microsoft.com/office/drawing/2014/main" id="{22810A45-2778-065E-8104-29AA51B87172}"/>
+                <a16:creationId xmlns:a16="http://schemas.microsoft.com/office/drawing/2014/main" id="{2194BDB8-86D0-CAAD-68EF-281A0F4D0F52}"/>
               </a:ext>
             </a:extLst>
           </p:cNvPr>
@@ -9897,7 +9897,7 @@
           <p:cNvPr id="11" name="직사각형 10">
             <a:extLst>
               <a:ext uri="{FF2B5EF4-FFF2-40B4-BE49-F238E27FC236}">
-                <a16:creationId xmlns:a16="http://schemas.microsoft.com/office/drawing/2014/main" id="{73CA3148-87B1-6B72-CE0B-CB75C2A8EDF8}"/>
+                <a16:creationId xmlns:a16="http://schemas.microsoft.com/office/drawing/2014/main" id="{E20C5DE4-B0B1-F4F0-65E2-BC6919EC76EF}"/>
               </a:ext>
             </a:extLst>
           </p:cNvPr>
@@ -9965,7 +9965,7 @@
           <p:cNvPr id="12" name="TextBox 11">
             <a:extLst>
               <a:ext uri="{FF2B5EF4-FFF2-40B4-BE49-F238E27FC236}">
-                <a16:creationId xmlns:a16="http://schemas.microsoft.com/office/drawing/2014/main" id="{0349EF93-E0A8-542A-814F-7F4A217F8107}"/>
+                <a16:creationId xmlns:a16="http://schemas.microsoft.com/office/drawing/2014/main" id="{65A8A9BD-D106-5F9A-49F7-093F3CA72338}"/>
               </a:ext>
             </a:extLst>
           </p:cNvPr>
@@ -10011,7 +10011,7 @@
           <p:cNvPr id="13" name="TextBox 12">
             <a:extLst>
               <a:ext uri="{FF2B5EF4-FFF2-40B4-BE49-F238E27FC236}">
-                <a16:creationId xmlns:a16="http://schemas.microsoft.com/office/drawing/2014/main" id="{5B546A88-3A5A-4CCE-DE55-98E3653BCC03}"/>
+                <a16:creationId xmlns:a16="http://schemas.microsoft.com/office/drawing/2014/main" id="{859E4DDE-76EE-CC47-76E9-FDC5BAB22E43}"/>
               </a:ext>
             </a:extLst>
           </p:cNvPr>
@@ -10051,7 +10051,7 @@
           <p:cNvPr id="14" name="사각형: 둥근 모서리 13">
             <a:extLst>
               <a:ext uri="{FF2B5EF4-FFF2-40B4-BE49-F238E27FC236}">
-                <a16:creationId xmlns:a16="http://schemas.microsoft.com/office/drawing/2014/main" id="{9A9EA0AB-6AA5-70BC-F8AC-F68ABCFA9CD8}"/>
+                <a16:creationId xmlns:a16="http://schemas.microsoft.com/office/drawing/2014/main" id="{DA908169-7087-3719-F76C-15EC2DFD9C19}"/>
               </a:ext>
             </a:extLst>
           </p:cNvPr>
@@ -10105,7 +10105,7 @@
           <p:cNvPr id="15" name="직사각형 14">
             <a:extLst>
               <a:ext uri="{FF2B5EF4-FFF2-40B4-BE49-F238E27FC236}">
-                <a16:creationId xmlns:a16="http://schemas.microsoft.com/office/drawing/2014/main" id="{FAA65DAC-9913-B8F2-1F12-FEBFA6A934C8}"/>
+                <a16:creationId xmlns:a16="http://schemas.microsoft.com/office/drawing/2014/main" id="{E969EECB-7A7A-9C1D-3120-10C7AEB9D1BD}"/>
               </a:ext>
             </a:extLst>
           </p:cNvPr>
@@ -10173,7 +10173,7 @@
           <p:cNvPr id="16" name="TextBox 15">
             <a:extLst>
               <a:ext uri="{FF2B5EF4-FFF2-40B4-BE49-F238E27FC236}">
-                <a16:creationId xmlns:a16="http://schemas.microsoft.com/office/drawing/2014/main" id="{E540D1EB-B96B-69E9-A253-CB65310988E8}"/>
+                <a16:creationId xmlns:a16="http://schemas.microsoft.com/office/drawing/2014/main" id="{64838EB8-0301-2A68-33E9-E779C2261E08}"/>
               </a:ext>
             </a:extLst>
           </p:cNvPr>
@@ -10222,7 +10222,7 @@
           <p:cNvPr id="17" name="TextBox 16">
             <a:extLst>
               <a:ext uri="{FF2B5EF4-FFF2-40B4-BE49-F238E27FC236}">
-                <a16:creationId xmlns:a16="http://schemas.microsoft.com/office/drawing/2014/main" id="{628C9E60-279D-B09E-6A78-069CD1651919}"/>
+                <a16:creationId xmlns:a16="http://schemas.microsoft.com/office/drawing/2014/main" id="{FDE3B5E9-AC64-2445-8C34-CE38AB09B56D}"/>
               </a:ext>
             </a:extLst>
           </p:cNvPr>
@@ -10280,7 +10280,7 @@
           <p:cNvPr id="18" name="사각형: 둥근 모서리 17">
             <a:extLst>
               <a:ext uri="{FF2B5EF4-FFF2-40B4-BE49-F238E27FC236}">
-                <a16:creationId xmlns:a16="http://schemas.microsoft.com/office/drawing/2014/main" id="{F93798C3-2025-8F25-262A-A70DBCA604DC}"/>
+                <a16:creationId xmlns:a16="http://schemas.microsoft.com/office/drawing/2014/main" id="{E9C75256-9A03-8627-1308-4EE0CC147557}"/>
               </a:ext>
             </a:extLst>
           </p:cNvPr>
@@ -10334,7 +10334,7 @@
           <p:cNvPr id="19" name="직사각형 18">
             <a:extLst>
               <a:ext uri="{FF2B5EF4-FFF2-40B4-BE49-F238E27FC236}">
-                <a16:creationId xmlns:a16="http://schemas.microsoft.com/office/drawing/2014/main" id="{A9FBCF5F-FB15-0856-9F63-AEBB74A6926B}"/>
+                <a16:creationId xmlns:a16="http://schemas.microsoft.com/office/drawing/2014/main" id="{8D3DB7B7-FAAC-20B0-A0F9-D44381D316D1}"/>
               </a:ext>
             </a:extLst>
           </p:cNvPr>
@@ -10402,7 +10402,7 @@
           <p:cNvPr id="20" name="TextBox 19">
             <a:extLst>
               <a:ext uri="{FF2B5EF4-FFF2-40B4-BE49-F238E27FC236}">
-                <a16:creationId xmlns:a16="http://schemas.microsoft.com/office/drawing/2014/main" id="{3CAADCA5-3713-7757-61C1-FE41907B4B6A}"/>
+                <a16:creationId xmlns:a16="http://schemas.microsoft.com/office/drawing/2014/main" id="{8BC04397-248A-0289-CD08-A8DEF3F143B3}"/>
               </a:ext>
             </a:extLst>
           </p:cNvPr>
@@ -10451,7 +10451,7 @@
           <p:cNvPr id="21" name="TextBox 20">
             <a:extLst>
               <a:ext uri="{FF2B5EF4-FFF2-40B4-BE49-F238E27FC236}">
-                <a16:creationId xmlns:a16="http://schemas.microsoft.com/office/drawing/2014/main" id="{C85B29F9-6D3F-A68C-8735-50A6190D899F}"/>
+                <a16:creationId xmlns:a16="http://schemas.microsoft.com/office/drawing/2014/main" id="{B040AB46-29E5-C1D9-F2AB-80DE6DA6B5C5}"/>
               </a:ext>
             </a:extLst>
           </p:cNvPr>
@@ -10491,7 +10491,7 @@
           <p:cNvPr id="22" name="TextBox 21">
             <a:extLst>
               <a:ext uri="{FF2B5EF4-FFF2-40B4-BE49-F238E27FC236}">
-                <a16:creationId xmlns:a16="http://schemas.microsoft.com/office/drawing/2014/main" id="{4BA4C51B-7D6D-1A25-E60A-79C1991C700E}"/>
+                <a16:creationId xmlns:a16="http://schemas.microsoft.com/office/drawing/2014/main" id="{FB72A026-F977-CCF5-9C1F-25D7D608C607}"/>
               </a:ext>
             </a:extLst>
           </p:cNvPr>
@@ -10547,7 +10547,7 @@
     </p:spTree>
     <p:extLst>
       <p:ext uri="{BB962C8B-B14F-4D97-AF65-F5344CB8AC3E}">
-        <p14:creationId xmlns:p14="http://schemas.microsoft.com/office/powerpoint/2010/main" val="1345475468"/>
+        <p14:creationId xmlns:p14="http://schemas.microsoft.com/office/powerpoint/2010/main" val="2795642600"/>
       </p:ext>
     </p:extLst>
   </p:cSld>
@@ -10587,7 +10587,7 @@
           <p:cNvPr id="2" name="TextBox 1">
             <a:extLst>
               <a:ext uri="{FF2B5EF4-FFF2-40B4-BE49-F238E27FC236}">
-                <a16:creationId xmlns:a16="http://schemas.microsoft.com/office/drawing/2014/main" id="{77B7B2B4-5009-F624-F0FF-7E16082D7657}"/>
+                <a16:creationId xmlns:a16="http://schemas.microsoft.com/office/drawing/2014/main" id="{61123F6F-4944-2ACB-A1D7-1625F072EA0C}"/>
               </a:ext>
             </a:extLst>
           </p:cNvPr>
@@ -10633,7 +10633,7 @@
           <p:cNvPr id="3" name="TextBox 2">
             <a:extLst>
               <a:ext uri="{FF2B5EF4-FFF2-40B4-BE49-F238E27FC236}">
-                <a16:creationId xmlns:a16="http://schemas.microsoft.com/office/drawing/2014/main" id="{53BDC1C7-8EBB-8EEF-66E1-767FA853B34E}"/>
+                <a16:creationId xmlns:a16="http://schemas.microsoft.com/office/drawing/2014/main" id="{6D9E45FE-1944-1F95-5BC6-871ADC494AD0}"/>
               </a:ext>
             </a:extLst>
           </p:cNvPr>
@@ -10679,7 +10679,7 @@
           <p:cNvPr id="4" name="TextBox 3">
             <a:extLst>
               <a:ext uri="{FF2B5EF4-FFF2-40B4-BE49-F238E27FC236}">
-                <a16:creationId xmlns:a16="http://schemas.microsoft.com/office/drawing/2014/main" id="{5E7E4DE1-00AB-4A40-03D5-DBA06C8241FC}"/>
+                <a16:creationId xmlns:a16="http://schemas.microsoft.com/office/drawing/2014/main" id="{5F7E635B-872C-07BE-1F67-7F7B6F96D844}"/>
               </a:ext>
             </a:extLst>
           </p:cNvPr>
@@ -10728,7 +10728,7 @@
           <p:cNvPr id="5" name="TextBox 4">
             <a:extLst>
               <a:ext uri="{FF2B5EF4-FFF2-40B4-BE49-F238E27FC236}">
-                <a16:creationId xmlns:a16="http://schemas.microsoft.com/office/drawing/2014/main" id="{D4D3E554-DE0F-F3B0-10D6-4CB6101BCB74}"/>
+                <a16:creationId xmlns:a16="http://schemas.microsoft.com/office/drawing/2014/main" id="{5D90A0F5-534D-EB54-2DC2-90A3EDFCA4C3}"/>
               </a:ext>
             </a:extLst>
           </p:cNvPr>
@@ -10786,7 +10786,7 @@
           <p:cNvPr id="6" name="직선 연결선 5">
             <a:extLst>
               <a:ext uri="{FF2B5EF4-FFF2-40B4-BE49-F238E27FC236}">
-                <a16:creationId xmlns:a16="http://schemas.microsoft.com/office/drawing/2014/main" id="{54423443-4F7C-3166-7F5A-3E5BC4CB0C2F}"/>
+                <a16:creationId xmlns:a16="http://schemas.microsoft.com/office/drawing/2014/main" id="{31266599-267B-6248-89B4-1929EBD77F96}"/>
               </a:ext>
             </a:extLst>
           </p:cNvPr>
@@ -10795,8 +10795,8 @@
         </p:nvCxnSpPr>
         <p:spPr>
           <a:xfrm>
-            <a:off x="1778000" y="3124200"/>
-            <a:ext cx="0" cy="584200"/>
+            <a:off x="1714500" y="3022600"/>
+            <a:ext cx="0" cy="558800"/>
           </a:xfrm>
           <a:prstGeom prst="line">
             <a:avLst/>
@@ -10828,7 +10828,7 @@
           <p:cNvPr id="7" name="사각형: 둥근 모서리 6">
             <a:extLst>
               <a:ext uri="{FF2B5EF4-FFF2-40B4-BE49-F238E27FC236}">
-                <a16:creationId xmlns:a16="http://schemas.microsoft.com/office/drawing/2014/main" id="{0502D508-38C6-7239-3EFA-DC82138FAF86}"/>
+                <a16:creationId xmlns:a16="http://schemas.microsoft.com/office/drawing/2014/main" id="{BF997C6B-E480-E060-3536-FDA8018E1803}"/>
               </a:ext>
             </a:extLst>
           </p:cNvPr>
@@ -10837,7 +10837,7 @@
         </p:nvSpPr>
         <p:spPr>
           <a:xfrm>
-            <a:off x="1917700" y="3251200"/>
+            <a:off x="1841500" y="3162300"/>
             <a:ext cx="914400" cy="254000"/>
           </a:xfrm>
           <a:prstGeom prst="roundRect">
@@ -10904,7 +10904,7 @@
           <p:cNvPr id="8" name="직선 연결선 7">
             <a:extLst>
               <a:ext uri="{FF2B5EF4-FFF2-40B4-BE49-F238E27FC236}">
-                <a16:creationId xmlns:a16="http://schemas.microsoft.com/office/drawing/2014/main" id="{07691811-F6F5-6F2A-B573-A247B81BA1CD}"/>
+                <a16:creationId xmlns:a16="http://schemas.microsoft.com/office/drawing/2014/main" id="{A3954F96-1EF2-F64E-2C35-1400FEF2E118}"/>
               </a:ext>
             </a:extLst>
           </p:cNvPr>
@@ -10912,9 +10912,9 @@
           <p:nvPr/>
         </p:nvCxnSpPr>
         <p:spPr>
-          <a:xfrm flipV="1">
-            <a:off x="2921000" y="2832100"/>
-            <a:ext cx="1968500" cy="1384300"/>
+          <a:xfrm flipH="1">
+            <a:off x="2857500" y="2565400"/>
+            <a:ext cx="2095500" cy="1333500"/>
           </a:xfrm>
           <a:prstGeom prst="line">
             <a:avLst/>
@@ -10946,7 +10946,7 @@
           <p:cNvPr id="9" name="사각형: 둥근 모서리 8">
             <a:extLst>
               <a:ext uri="{FF2B5EF4-FFF2-40B4-BE49-F238E27FC236}">
-                <a16:creationId xmlns:a16="http://schemas.microsoft.com/office/drawing/2014/main" id="{CA95FAC3-CE01-9264-71E3-7ED757BE60AB}"/>
+                <a16:creationId xmlns:a16="http://schemas.microsoft.com/office/drawing/2014/main" id="{BD21D7AE-BBCC-BF9E-FEEA-676E039624C4}"/>
               </a:ext>
             </a:extLst>
           </p:cNvPr>
@@ -10955,8 +10955,8 @@
         </p:nvSpPr>
         <p:spPr>
           <a:xfrm>
-            <a:off x="3365500" y="3302000"/>
-            <a:ext cx="1333500" cy="254000"/>
+            <a:off x="3390900" y="2933700"/>
+            <a:ext cx="1168400" cy="254000"/>
           </a:xfrm>
           <a:prstGeom prst="roundRect">
             <a:avLst/>
@@ -11012,25 +11012,7 @@
                 </a:solidFill>
                 <a:latin typeface="Malgun Gothic" panose="020B0503020000020004" pitchFamily="50" charset="-127"/>
               </a:rPr>
-              <a:t>코드</a:t>
-            </a:r>
-            <a:r>
-              <a:rPr lang="en-US" altLang="ko-KR" sz="900" b="1">
-                <a:solidFill>
-                  <a:srgbClr val="697386"/>
-                </a:solidFill>
-                <a:latin typeface="Malgun Gothic" panose="020B0503020000020004" pitchFamily="50" charset="-127"/>
-              </a:rPr>
-              <a:t>·</a:t>
-            </a:r>
-            <a:r>
-              <a:rPr lang="ko-KR" altLang="en-US" sz="900" b="1">
-                <a:solidFill>
-                  <a:srgbClr val="697386"/>
-                </a:solidFill>
-                <a:latin typeface="Malgun Gothic" panose="020B0503020000020004" pitchFamily="50" charset="-127"/>
-              </a:rPr>
-              <a:t>데이터 저장</a:t>
+              <a:t>매일 자동 실행</a:t>
             </a:r>
           </a:p>
         </p:txBody>
@@ -11040,7 +11022,7 @@
           <p:cNvPr id="10" name="직선 연결선 9">
             <a:extLst>
               <a:ext uri="{FF2B5EF4-FFF2-40B4-BE49-F238E27FC236}">
-                <a16:creationId xmlns:a16="http://schemas.microsoft.com/office/drawing/2014/main" id="{B10A31EE-61C7-D079-DCA8-2F8FFE94463B}"/>
+                <a16:creationId xmlns:a16="http://schemas.microsoft.com/office/drawing/2014/main" id="{AE46B4AF-0279-DBC4-BEC3-037A67E57E5C}"/>
               </a:ext>
             </a:extLst>
           </p:cNvPr>
@@ -11049,8 +11031,8 @@
         </p:nvCxnSpPr>
         <p:spPr>
           <a:xfrm>
-            <a:off x="7175500" y="2565400"/>
-            <a:ext cx="2159000" cy="203200"/>
+            <a:off x="7239000" y="2565400"/>
+            <a:ext cx="2095500" cy="127000"/>
           </a:xfrm>
           <a:prstGeom prst="line">
             <a:avLst/>
@@ -11082,7 +11064,7 @@
           <p:cNvPr id="11" name="사각형: 둥근 모서리 10">
             <a:extLst>
               <a:ext uri="{FF2B5EF4-FFF2-40B4-BE49-F238E27FC236}">
-                <a16:creationId xmlns:a16="http://schemas.microsoft.com/office/drawing/2014/main" id="{DC4D5C90-44A5-A091-CFAC-FB97F9CC009B}"/>
+                <a16:creationId xmlns:a16="http://schemas.microsoft.com/office/drawing/2014/main" id="{58A8C023-5805-9568-382C-4EE4E379FB19}"/>
               </a:ext>
             </a:extLst>
           </p:cNvPr>
@@ -11091,8 +11073,8 @@
         </p:nvSpPr>
         <p:spPr>
           <a:xfrm>
-            <a:off x="7810500" y="2349500"/>
-            <a:ext cx="952500" cy="254000"/>
+            <a:off x="7810500" y="2298700"/>
+            <a:ext cx="914400" cy="254000"/>
           </a:xfrm>
           <a:prstGeom prst="roundRect">
             <a:avLst/>
@@ -11148,7 +11130,7 @@
                 </a:solidFill>
                 <a:latin typeface="Malgun Gothic" panose="020B0503020000020004" pitchFamily="50" charset="-127"/>
               </a:rPr>
-              <a:t>자동 배포</a:t>
+              <a:t>코드 배포</a:t>
             </a:r>
           </a:p>
         </p:txBody>
@@ -11158,7 +11140,7 @@
           <p:cNvPr id="12" name="직선 연결선 11">
             <a:extLst>
               <a:ext uri="{FF2B5EF4-FFF2-40B4-BE49-F238E27FC236}">
-                <a16:creationId xmlns:a16="http://schemas.microsoft.com/office/drawing/2014/main" id="{F74FE7E9-671E-5C0A-3A0A-FC96295CA002}"/>
+                <a16:creationId xmlns:a16="http://schemas.microsoft.com/office/drawing/2014/main" id="{63BC4747-0100-1AA2-F30A-BA73FC1C121A}"/>
               </a:ext>
             </a:extLst>
           </p:cNvPr>
@@ -11167,8 +11149,8 @@
         </p:nvCxnSpPr>
         <p:spPr>
           <a:xfrm flipH="1">
-            <a:off x="7493000" y="3200400"/>
-            <a:ext cx="1841500" cy="622300"/>
+            <a:off x="7493000" y="3098800"/>
+            <a:ext cx="1841500" cy="584200"/>
           </a:xfrm>
           <a:prstGeom prst="line">
             <a:avLst/>
@@ -11200,7 +11182,7 @@
           <p:cNvPr id="13" name="사각형: 둥근 모서리 12">
             <a:extLst>
               <a:ext uri="{FF2B5EF4-FFF2-40B4-BE49-F238E27FC236}">
-                <a16:creationId xmlns:a16="http://schemas.microsoft.com/office/drawing/2014/main" id="{AEFEAC61-8D33-1FB5-2976-BC23C8BB3762}"/>
+                <a16:creationId xmlns:a16="http://schemas.microsoft.com/office/drawing/2014/main" id="{CB6269DF-CB2D-EA51-69BC-43DBA7E1098F}"/>
               </a:ext>
             </a:extLst>
           </p:cNvPr>
@@ -11209,7 +11191,7 @@
         </p:nvSpPr>
         <p:spPr>
           <a:xfrm>
-            <a:off x="7975600" y="3390900"/>
+            <a:off x="7962900" y="3225800"/>
             <a:ext cx="1143000" cy="254000"/>
           </a:xfrm>
           <a:prstGeom prst="roundRect">
@@ -11276,7 +11258,7 @@
           <p:cNvPr id="14" name="직선 연결선 13">
             <a:extLst>
               <a:ext uri="{FF2B5EF4-FFF2-40B4-BE49-F238E27FC236}">
-                <a16:creationId xmlns:a16="http://schemas.microsoft.com/office/drawing/2014/main" id="{BB762FFE-DEDF-23BC-D604-D978F1203D5E}"/>
+                <a16:creationId xmlns:a16="http://schemas.microsoft.com/office/drawing/2014/main" id="{157A15AC-3603-43F1-E5B5-F79B98EB308E}"/>
               </a:ext>
             </a:extLst>
           </p:cNvPr>
@@ -11285,8 +11267,8 @@
         </p:nvCxnSpPr>
         <p:spPr>
           <a:xfrm>
-            <a:off x="7429500" y="4241800"/>
-            <a:ext cx="1905000" cy="368300"/>
+            <a:off x="2857500" y="4279900"/>
+            <a:ext cx="1778000" cy="1282700"/>
           </a:xfrm>
           <a:prstGeom prst="line">
             <a:avLst/>
@@ -11295,7 +11277,6 @@
             <a:solidFill>
               <a:srgbClr val="765C7D"/>
             </a:solidFill>
-            <a:headEnd type="arrow"/>
             <a:tailEnd type="arrow"/>
           </a:ln>
         </p:spPr>
@@ -11319,7 +11300,7 @@
           <p:cNvPr id="15" name="사각형: 둥근 모서리 14">
             <a:extLst>
               <a:ext uri="{FF2B5EF4-FFF2-40B4-BE49-F238E27FC236}">
-                <a16:creationId xmlns:a16="http://schemas.microsoft.com/office/drawing/2014/main" id="{FAEA68B0-BD9F-3D7C-1634-26FC1CA481D5}"/>
+                <a16:creationId xmlns:a16="http://schemas.microsoft.com/office/drawing/2014/main" id="{A888A1B1-14CF-FE97-2C2E-5AEE8778CE5A}"/>
               </a:ext>
             </a:extLst>
           </p:cNvPr>
@@ -11328,7 +11309,7 @@
         </p:nvSpPr>
         <p:spPr>
           <a:xfrm>
-            <a:off x="7975600" y="4279900"/>
+            <a:off x="3098800" y="4749800"/>
             <a:ext cx="1270000" cy="254000"/>
           </a:xfrm>
           <a:prstGeom prst="roundRect">
@@ -11385,7 +11366,7 @@
                 </a:solidFill>
                 <a:latin typeface="Malgun Gothic" panose="020B0503020000020004" pitchFamily="50" charset="-127"/>
               </a:rPr>
-              <a:t>계획 저장</a:t>
+              <a:t>환율 계산</a:t>
             </a:r>
             <a:r>
               <a:rPr lang="en-US" altLang="ko-KR" sz="900" b="1">
@@ -11403,7 +11384,7 @@
                 </a:solidFill>
                 <a:latin typeface="Malgun Gothic" panose="020B0503020000020004" pitchFamily="50" charset="-127"/>
               </a:rPr>
-              <a:t>조회</a:t>
+              <a:t>적재</a:t>
             </a:r>
           </a:p>
         </p:txBody>
@@ -11413,7 +11394,7 @@
           <p:cNvPr id="16" name="직선 연결선 15">
             <a:extLst>
               <a:ext uri="{FF2B5EF4-FFF2-40B4-BE49-F238E27FC236}">
-                <a16:creationId xmlns:a16="http://schemas.microsoft.com/office/drawing/2014/main" id="{D4D52837-F309-38ED-277F-70111FC2DC6D}"/>
+                <a16:creationId xmlns:a16="http://schemas.microsoft.com/office/drawing/2014/main" id="{37FFD041-D583-0A16-C324-A3E9FC42236B}"/>
               </a:ext>
             </a:extLst>
           </p:cNvPr>
@@ -11421,17 +11402,18 @@
           <p:nvPr/>
         </p:nvCxnSpPr>
         <p:spPr>
-          <a:xfrm>
-            <a:off x="2921000" y="4521200"/>
-            <a:ext cx="635000" cy="901700"/>
+          <a:xfrm flipV="1">
+            <a:off x="6070600" y="4521200"/>
+            <a:ext cx="0" cy="736600"/>
           </a:xfrm>
           <a:prstGeom prst="line">
             <a:avLst/>
           </a:prstGeom>
           <a:ln w="25400">
             <a:solidFill>
-              <a:srgbClr val="A56A3A"/>
+              <a:srgbClr val="765C7D"/>
             </a:solidFill>
+            <a:headEnd type="arrow"/>
             <a:tailEnd type="arrow"/>
           </a:ln>
         </p:spPr>
@@ -11455,7 +11437,7 @@
           <p:cNvPr id="17" name="사각형: 둥근 모서리 16">
             <a:extLst>
               <a:ext uri="{FF2B5EF4-FFF2-40B4-BE49-F238E27FC236}">
-                <a16:creationId xmlns:a16="http://schemas.microsoft.com/office/drawing/2014/main" id="{C7B1E33A-5929-B950-7BB1-00D2B2E7D031}"/>
+                <a16:creationId xmlns:a16="http://schemas.microsoft.com/office/drawing/2014/main" id="{8B42DED9-3668-8BAB-E1B5-EECD01965F32}"/>
               </a:ext>
             </a:extLst>
           </p:cNvPr>
@@ -11464,8 +11446,8 @@
         </p:nvSpPr>
         <p:spPr>
           <a:xfrm>
-            <a:off x="2476500" y="4889500"/>
-            <a:ext cx="1066800" cy="254000"/>
+            <a:off x="6235700" y="4699000"/>
+            <a:ext cx="1270000" cy="254000"/>
           </a:xfrm>
           <a:prstGeom prst="roundRect">
             <a:avLst/>
@@ -11521,7 +11503,25 @@
                 </a:solidFill>
                 <a:latin typeface="Malgun Gothic" panose="020B0503020000020004" pitchFamily="50" charset="-127"/>
               </a:rPr>
-              <a:t>리포트 생성</a:t>
+              <a:t>환율</a:t>
+            </a:r>
+            <a:r>
+              <a:rPr lang="en-US" altLang="ko-KR" sz="900" b="1">
+                <a:solidFill>
+                  <a:srgbClr val="697386"/>
+                </a:solidFill>
+                <a:latin typeface="Malgun Gothic" panose="020B0503020000020004" pitchFamily="50" charset="-127"/>
+              </a:rPr>
+              <a:t>·</a:t>
+            </a:r>
+            <a:r>
+              <a:rPr lang="ko-KR" altLang="en-US" sz="900" b="1">
+                <a:solidFill>
+                  <a:srgbClr val="697386"/>
+                </a:solidFill>
+                <a:latin typeface="Malgun Gothic" panose="020B0503020000020004" pitchFamily="50" charset="-127"/>
+              </a:rPr>
+              <a:t>계획 조회</a:t>
             </a:r>
           </a:p>
         </p:txBody>
@@ -11531,7 +11531,7 @@
           <p:cNvPr id="18" name="직선 연결선 17">
             <a:extLst>
               <a:ext uri="{FF2B5EF4-FFF2-40B4-BE49-F238E27FC236}">
-                <a16:creationId xmlns:a16="http://schemas.microsoft.com/office/drawing/2014/main" id="{847DFBE4-0717-58A2-51A5-AE28ADC5C937}"/>
+                <a16:creationId xmlns:a16="http://schemas.microsoft.com/office/drawing/2014/main" id="{1651A3AC-BB73-D80B-B48F-303AB7BD13C4}"/>
               </a:ext>
             </a:extLst>
           </p:cNvPr>
@@ -11540,8 +11540,8 @@
         </p:nvCxnSpPr>
         <p:spPr>
           <a:xfrm>
-            <a:off x="5397500" y="5702300"/>
-            <a:ext cx="952500" cy="0"/>
+            <a:off x="6921500" y="5702300"/>
+            <a:ext cx="571500" cy="0"/>
           </a:xfrm>
           <a:prstGeom prst="line">
             <a:avLst/>
@@ -11573,7 +11573,7 @@
           <p:cNvPr id="19" name="사각형: 둥근 모서리 18">
             <a:extLst>
               <a:ext uri="{FF2B5EF4-FFF2-40B4-BE49-F238E27FC236}">
-                <a16:creationId xmlns:a16="http://schemas.microsoft.com/office/drawing/2014/main" id="{3331C29E-3CFC-3D55-95F4-88F975D619B3}"/>
+                <a16:creationId xmlns:a16="http://schemas.microsoft.com/office/drawing/2014/main" id="{A777A81D-9FD2-D462-F280-1535A3E36F35}"/>
               </a:ext>
             </a:extLst>
           </p:cNvPr>
@@ -11582,7 +11582,7 @@
         </p:nvSpPr>
         <p:spPr>
           <a:xfrm>
-            <a:off x="5397500" y="5359400"/>
+            <a:off x="6807200" y="4953000"/>
             <a:ext cx="1041400" cy="254000"/>
           </a:xfrm>
           <a:prstGeom prst="roundRect">
@@ -11639,7 +11639,7 @@
                 </a:solidFill>
                 <a:latin typeface="Malgun Gothic" panose="020B0503020000020004" pitchFamily="50" charset="-127"/>
               </a:rPr>
-              <a:t>리포트 전달</a:t>
+              <a:t>데이터 조회</a:t>
             </a:r>
           </a:p>
         </p:txBody>
@@ -11649,7 +11649,7 @@
           <p:cNvPr id="20" name="직선 연결선 19">
             <a:extLst>
               <a:ext uri="{FF2B5EF4-FFF2-40B4-BE49-F238E27FC236}">
-                <a16:creationId xmlns:a16="http://schemas.microsoft.com/office/drawing/2014/main" id="{308B0EC2-0BBE-983C-3153-348975EB8390}"/>
+                <a16:creationId xmlns:a16="http://schemas.microsoft.com/office/drawing/2014/main" id="{4BAAF3DE-AD5D-0193-B950-FB6013BB380B}"/>
               </a:ext>
             </a:extLst>
           </p:cNvPr>
@@ -11658,15 +11658,15 @@
         </p:nvCxnSpPr>
         <p:spPr>
           <a:xfrm>
-            <a:off x="6096000" y="4521200"/>
-            <a:ext cx="1079500" cy="749300"/>
+            <a:off x="9461500" y="5702300"/>
+            <a:ext cx="444500" cy="0"/>
           </a:xfrm>
           <a:prstGeom prst="line">
             <a:avLst/>
           </a:prstGeom>
           <a:ln w="25400">
             <a:solidFill>
-              <a:srgbClr val="24736B"/>
+              <a:srgbClr val="A56A3A"/>
             </a:solidFill>
             <a:tailEnd type="arrow"/>
           </a:ln>
@@ -11691,7 +11691,7 @@
           <p:cNvPr id="21" name="사각형: 둥근 모서리 20">
             <a:extLst>
               <a:ext uri="{FF2B5EF4-FFF2-40B4-BE49-F238E27FC236}">
-                <a16:creationId xmlns:a16="http://schemas.microsoft.com/office/drawing/2014/main" id="{85B94359-A287-0589-245F-A971FEA7908A}"/>
+                <a16:creationId xmlns:a16="http://schemas.microsoft.com/office/drawing/2014/main" id="{CFB04E01-7721-C353-0501-648F0E31B620}"/>
               </a:ext>
             </a:extLst>
           </p:cNvPr>
@@ -11700,7 +11700,7 @@
         </p:nvSpPr>
         <p:spPr>
           <a:xfrm>
-            <a:off x="6261100" y="4749800"/>
+            <a:off x="9207500" y="4953000"/>
             <a:ext cx="889000" cy="254000"/>
           </a:xfrm>
           <a:prstGeom prst="roundRect">
@@ -11757,6 +11757,124 @@
                 </a:solidFill>
                 <a:latin typeface="Malgun Gothic" panose="020B0503020000020004" pitchFamily="50" charset="-127"/>
               </a:rPr>
+              <a:t>메일 전달</a:t>
+            </a:r>
+          </a:p>
+        </p:txBody>
+      </p:sp>
+      <p:cxnSp>
+        <p:nvCxnSpPr>
+          <p:cNvPr id="22" name="직선 연결선 21">
+            <a:extLst>
+              <a:ext uri="{FF2B5EF4-FFF2-40B4-BE49-F238E27FC236}">
+                <a16:creationId xmlns:a16="http://schemas.microsoft.com/office/drawing/2014/main" id="{5B1DB747-CF2E-4516-DA2F-A99A51B5CD89}"/>
+              </a:ext>
+            </a:extLst>
+          </p:cNvPr>
+          <p:cNvCxnSpPr/>
+          <p:nvPr/>
+        </p:nvCxnSpPr>
+        <p:spPr>
+          <a:xfrm>
+            <a:off x="7493000" y="4191000"/>
+            <a:ext cx="2413000" cy="1270000"/>
+          </a:xfrm>
+          <a:prstGeom prst="line">
+            <a:avLst/>
+          </a:prstGeom>
+          <a:ln w="25400">
+            <a:solidFill>
+              <a:srgbClr val="24736B"/>
+            </a:solidFill>
+            <a:tailEnd type="arrow"/>
+          </a:ln>
+        </p:spPr>
+        <p:style>
+          <a:lnRef idx="2">
+            <a:schemeClr val="accent1"/>
+          </a:lnRef>
+          <a:fillRef idx="0">
+            <a:schemeClr val="accent1"/>
+          </a:fillRef>
+          <a:effectRef idx="1">
+            <a:schemeClr val="accent1"/>
+          </a:effectRef>
+          <a:fontRef idx="minor">
+            <a:schemeClr val="tx1"/>
+          </a:fontRef>
+        </p:style>
+      </p:cxnSp>
+      <p:sp>
+        <p:nvSpPr>
+          <p:cNvPr id="23" name="사각형: 둥근 모서리 22">
+            <a:extLst>
+              <a:ext uri="{FF2B5EF4-FFF2-40B4-BE49-F238E27FC236}">
+                <a16:creationId xmlns:a16="http://schemas.microsoft.com/office/drawing/2014/main" id="{854AB2FD-5CF2-2AB7-8643-348688681B5B}"/>
+              </a:ext>
+            </a:extLst>
+          </p:cNvPr>
+          <p:cNvSpPr/>
+          <p:nvPr/>
+        </p:nvSpPr>
+        <p:spPr>
+          <a:xfrm>
+            <a:off x="8445500" y="4546600"/>
+            <a:ext cx="889000" cy="254000"/>
+          </a:xfrm>
+          <a:prstGeom prst="roundRect">
+            <a:avLst/>
+          </a:prstGeom>
+          <a:solidFill>
+            <a:srgbClr val="F6F3EC"/>
+          </a:solidFill>
+          <a:ln w="19050" cap="flat" cmpd="sng" algn="ctr">
+            <a:noFill/>
+            <a:prstDash val="solid"/>
+            <a:miter lim="800000"/>
+          </a:ln>
+          <a:effectLst/>
+          <a:extLst>
+            <a:ext uri="{91240B29-F687-4F45-9708-019B960494DF}">
+              <a14:hiddenLine xmlns:a14="http://schemas.microsoft.com/office/drawing/2010/main" w="19050" cap="flat" cmpd="sng" algn="ctr">
+                <a:solidFill>
+                  <a:schemeClr val="accent1">
+                    <a:shade val="15000"/>
+                  </a:schemeClr>
+                </a:solidFill>
+                <a:prstDash val="solid"/>
+                <a:miter lim="800000"/>
+              </a14:hiddenLine>
+            </a:ext>
+          </a:extLst>
+        </p:spPr>
+        <p:style>
+          <a:lnRef idx="2">
+            <a:schemeClr val="accent1">
+              <a:shade val="15000"/>
+            </a:schemeClr>
+          </a:lnRef>
+          <a:fillRef idx="1">
+            <a:schemeClr val="accent1"/>
+          </a:fillRef>
+          <a:effectRef idx="0">
+            <a:schemeClr val="accent1"/>
+          </a:effectRef>
+          <a:fontRef idx="minor">
+            <a:schemeClr val="lt1"/>
+          </a:fontRef>
+        </p:style>
+        <p:txBody>
+          <a:bodyPr rtlCol="0" anchor="ctr"/>
+          <a:lstStyle/>
+          <a:p>
+            <a:pPr algn="ctr"/>
+            <a:r>
+              <a:rPr lang="ko-KR" altLang="en-US" sz="900" b="1">
+                <a:solidFill>
+                  <a:srgbClr val="697386"/>
+                </a:solidFill>
+                <a:latin typeface="Malgun Gothic" panose="020B0503020000020004" pitchFamily="50" charset="-127"/>
+              </a:rPr>
               <a:t>화면 확인</a:t>
             </a:r>
           </a:p>
@@ -11764,10 +11882,10 @@
       </p:sp>
       <p:sp>
         <p:nvSpPr>
-          <p:cNvPr id="22" name="사각형: 둥근 모서리 21">
-            <a:extLst>
-              <a:ext uri="{FF2B5EF4-FFF2-40B4-BE49-F238E27FC236}">
-                <a16:creationId xmlns:a16="http://schemas.microsoft.com/office/drawing/2014/main" id="{3173CA6B-5178-B378-16F0-040C0CA39887}"/>
+          <p:cNvPr id="24" name="사각형: 둥근 모서리 23">
+            <a:extLst>
+              <a:ext uri="{FF2B5EF4-FFF2-40B4-BE49-F238E27FC236}">
+                <a16:creationId xmlns:a16="http://schemas.microsoft.com/office/drawing/2014/main" id="{ADA1E62D-9236-64E8-A4BE-247D0417FABE}"/>
               </a:ext>
             </a:extLst>
           </p:cNvPr>
@@ -11776,8 +11894,8 @@
         </p:nvSpPr>
         <p:spPr>
           <a:xfrm>
-            <a:off x="571500" y="2222500"/>
-            <a:ext cx="2413000" cy="914400"/>
+            <a:off x="571500" y="2159000"/>
+            <a:ext cx="2286000" cy="863600"/>
           </a:xfrm>
           <a:prstGeom prst="roundRect">
             <a:avLst/>
@@ -11818,10 +11936,10 @@
       </p:sp>
       <p:sp>
         <p:nvSpPr>
-          <p:cNvPr id="23" name="직사각형 22">
-            <a:extLst>
-              <a:ext uri="{FF2B5EF4-FFF2-40B4-BE49-F238E27FC236}">
-                <a16:creationId xmlns:a16="http://schemas.microsoft.com/office/drawing/2014/main" id="{E7B6B06E-A8BE-558E-6B0F-D82CF360852D}"/>
+          <p:cNvPr id="25" name="직사각형 24">
+            <a:extLst>
+              <a:ext uri="{FF2B5EF4-FFF2-40B4-BE49-F238E27FC236}">
+                <a16:creationId xmlns:a16="http://schemas.microsoft.com/office/drawing/2014/main" id="{386F4F15-E974-0A2E-EB10-BA220D6F7A64}"/>
               </a:ext>
             </a:extLst>
           </p:cNvPr>
@@ -11830,8 +11948,8 @@
         </p:nvSpPr>
         <p:spPr>
           <a:xfrm>
-            <a:off x="571500" y="2222500"/>
-            <a:ext cx="76200" cy="914400"/>
+            <a:off x="571500" y="2159000"/>
+            <a:ext cx="76200" cy="863600"/>
           </a:xfrm>
           <a:prstGeom prst="rect">
             <a:avLst/>
@@ -11886,10 +12004,10 @@
       </p:sp>
       <p:sp>
         <p:nvSpPr>
-          <p:cNvPr id="24" name="TextBox 23">
-            <a:extLst>
-              <a:ext uri="{FF2B5EF4-FFF2-40B4-BE49-F238E27FC236}">
-                <a16:creationId xmlns:a16="http://schemas.microsoft.com/office/drawing/2014/main" id="{65EEAFD8-DAF0-55AA-39B9-E7744458D9F1}"/>
+          <p:cNvPr id="26" name="TextBox 25">
+            <a:extLst>
+              <a:ext uri="{FF2B5EF4-FFF2-40B4-BE49-F238E27FC236}">
+                <a16:creationId xmlns:a16="http://schemas.microsoft.com/office/drawing/2014/main" id="{3DF3446E-6B17-0B80-E0D8-0BF06BF2904E}"/>
               </a:ext>
             </a:extLst>
           </p:cNvPr>
@@ -11898,8 +12016,8 @@
         </p:nvSpPr>
         <p:spPr>
           <a:xfrm>
-            <a:off x="774700" y="2387600"/>
-            <a:ext cx="2006600" cy="230832"/>
+            <a:off x="774700" y="2324100"/>
+            <a:ext cx="1879600" cy="230832"/>
           </a:xfrm>
           <a:prstGeom prst="rect">
             <a:avLst/>
@@ -11927,10 +12045,10 @@
       </p:sp>
       <p:sp>
         <p:nvSpPr>
-          <p:cNvPr id="25" name="TextBox 24">
-            <a:extLst>
-              <a:ext uri="{FF2B5EF4-FFF2-40B4-BE49-F238E27FC236}">
-                <a16:creationId xmlns:a16="http://schemas.microsoft.com/office/drawing/2014/main" id="{864BB565-4242-663B-B9A0-5DF39BA29934}"/>
+          <p:cNvPr id="27" name="TextBox 26">
+            <a:extLst>
+              <a:ext uri="{FF2B5EF4-FFF2-40B4-BE49-F238E27FC236}">
+                <a16:creationId xmlns:a16="http://schemas.microsoft.com/office/drawing/2014/main" id="{A3D06ACB-ED9F-0447-73C2-0041639F6D4F}"/>
               </a:ext>
             </a:extLst>
           </p:cNvPr>
@@ -11939,8 +12057,8 @@
         </p:nvSpPr>
         <p:spPr>
           <a:xfrm>
-            <a:off x="749300" y="2755900"/>
-            <a:ext cx="2057400" cy="153888"/>
+            <a:off x="749300" y="2692400"/>
+            <a:ext cx="1930400" cy="153888"/>
           </a:xfrm>
           <a:prstGeom prst="rect">
             <a:avLst/>
@@ -11968,10 +12086,10 @@
       </p:sp>
       <p:sp>
         <p:nvSpPr>
-          <p:cNvPr id="26" name="사각형: 둥근 모서리 25">
-            <a:extLst>
-              <a:ext uri="{FF2B5EF4-FFF2-40B4-BE49-F238E27FC236}">
-                <a16:creationId xmlns:a16="http://schemas.microsoft.com/office/drawing/2014/main" id="{4941EB5D-BDFB-C577-EE4F-0D23F9D1B616}"/>
+          <p:cNvPr id="28" name="사각형: 둥근 모서리 27">
+            <a:extLst>
+              <a:ext uri="{FF2B5EF4-FFF2-40B4-BE49-F238E27FC236}">
+                <a16:creationId xmlns:a16="http://schemas.microsoft.com/office/drawing/2014/main" id="{D7DF8DAB-42EF-B127-F9E9-109466FB5054}"/>
               </a:ext>
             </a:extLst>
           </p:cNvPr>
@@ -11980,8 +12098,8 @@
         </p:nvSpPr>
         <p:spPr>
           <a:xfrm>
-            <a:off x="571500" y="3721100"/>
-            <a:ext cx="2413000" cy="1041400"/>
+            <a:off x="571500" y="3581400"/>
+            <a:ext cx="2286000" cy="990600"/>
           </a:xfrm>
           <a:prstGeom prst="roundRect">
             <a:avLst/>
@@ -12022,10 +12140,10 @@
       </p:sp>
       <p:sp>
         <p:nvSpPr>
-          <p:cNvPr id="27" name="직사각형 26">
-            <a:extLst>
-              <a:ext uri="{FF2B5EF4-FFF2-40B4-BE49-F238E27FC236}">
-                <a16:creationId xmlns:a16="http://schemas.microsoft.com/office/drawing/2014/main" id="{D125BACC-ACD3-B235-B72B-D441B91BF579}"/>
+          <p:cNvPr id="29" name="직사각형 28">
+            <a:extLst>
+              <a:ext uri="{FF2B5EF4-FFF2-40B4-BE49-F238E27FC236}">
+                <a16:creationId xmlns:a16="http://schemas.microsoft.com/office/drawing/2014/main" id="{EBD3B815-D508-8314-F929-9D88608972DD}"/>
               </a:ext>
             </a:extLst>
           </p:cNvPr>
@@ -12034,8 +12152,8 @@
         </p:nvSpPr>
         <p:spPr>
           <a:xfrm>
-            <a:off x="571500" y="3721100"/>
-            <a:ext cx="76200" cy="1041400"/>
+            <a:off x="571500" y="3581400"/>
+            <a:ext cx="76200" cy="990600"/>
           </a:xfrm>
           <a:prstGeom prst="rect">
             <a:avLst/>
@@ -12090,10 +12208,10 @@
       </p:sp>
       <p:sp>
         <p:nvSpPr>
-          <p:cNvPr id="28" name="TextBox 27">
-            <a:extLst>
-              <a:ext uri="{FF2B5EF4-FFF2-40B4-BE49-F238E27FC236}">
-                <a16:creationId xmlns:a16="http://schemas.microsoft.com/office/drawing/2014/main" id="{8ABC1357-C0A9-0E83-8727-091A0DD0013D}"/>
+          <p:cNvPr id="30" name="TextBox 29">
+            <a:extLst>
+              <a:ext uri="{FF2B5EF4-FFF2-40B4-BE49-F238E27FC236}">
+                <a16:creationId xmlns:a16="http://schemas.microsoft.com/office/drawing/2014/main" id="{8E9E92BC-0A74-0C5B-A0D1-A472C8FFB2E8}"/>
               </a:ext>
             </a:extLst>
           </p:cNvPr>
@@ -12102,8 +12220,8 @@
         </p:nvSpPr>
         <p:spPr>
           <a:xfrm>
-            <a:off x="774700" y="3886200"/>
-            <a:ext cx="2006600" cy="230832"/>
+            <a:off x="774700" y="3746500"/>
+            <a:ext cx="1879600" cy="230832"/>
           </a:xfrm>
           <a:prstGeom prst="rect">
             <a:avLst/>
@@ -12137,10 +12255,10 @@
       </p:sp>
       <p:sp>
         <p:nvSpPr>
-          <p:cNvPr id="29" name="TextBox 28">
-            <a:extLst>
-              <a:ext uri="{FF2B5EF4-FFF2-40B4-BE49-F238E27FC236}">
-                <a16:creationId xmlns:a16="http://schemas.microsoft.com/office/drawing/2014/main" id="{F8AF9465-F665-25B0-0412-C006FE511554}"/>
+          <p:cNvPr id="31" name="TextBox 30">
+            <a:extLst>
+              <a:ext uri="{FF2B5EF4-FFF2-40B4-BE49-F238E27FC236}">
+                <a16:creationId xmlns:a16="http://schemas.microsoft.com/office/drawing/2014/main" id="{F868D607-889E-BA74-DF96-1767512C62D9}"/>
               </a:ext>
             </a:extLst>
           </p:cNvPr>
@@ -12149,8 +12267,8 @@
         </p:nvSpPr>
         <p:spPr>
           <a:xfrm>
-            <a:off x="749300" y="4254500"/>
-            <a:ext cx="2057400" cy="153888"/>
+            <a:off x="749300" y="4114800"/>
+            <a:ext cx="1930400" cy="153888"/>
           </a:xfrm>
           <a:prstGeom prst="rect">
             <a:avLst/>
@@ -12198,7 +12316,7 @@
                 </a:solidFill>
                 <a:latin typeface="Malgun Gothic" panose="020B0503020000020004" pitchFamily="50" charset="-127"/>
               </a:rPr>
-              <a:t>·</a:t>
+              <a:t>·DB </a:t>
             </a:r>
             <a:r>
               <a:rPr lang="ko-KR" altLang="en-US" sz="1000">
@@ -12214,10 +12332,10 @@
       </p:sp>
       <p:sp>
         <p:nvSpPr>
-          <p:cNvPr id="30" name="사각형: 둥근 모서리 29">
-            <a:extLst>
-              <a:ext uri="{FF2B5EF4-FFF2-40B4-BE49-F238E27FC236}">
-                <a16:creationId xmlns:a16="http://schemas.microsoft.com/office/drawing/2014/main" id="{31E8186B-B71B-7292-C088-39A9028515FD}"/>
+          <p:cNvPr id="32" name="사각형: 둥근 모서리 31">
+            <a:extLst>
+              <a:ext uri="{FF2B5EF4-FFF2-40B4-BE49-F238E27FC236}">
+                <a16:creationId xmlns:a16="http://schemas.microsoft.com/office/drawing/2014/main" id="{EE805407-BDB2-9EB8-2FC6-AF8A3C6A4F2C}"/>
               </a:ext>
             </a:extLst>
           </p:cNvPr>
@@ -12226,8 +12344,8 @@
         </p:nvSpPr>
         <p:spPr>
           <a:xfrm>
-            <a:off x="4889500" y="2082800"/>
-            <a:ext cx="2286000" cy="990600"/>
+            <a:off x="4953000" y="2095500"/>
+            <a:ext cx="2286000" cy="952500"/>
           </a:xfrm>
           <a:prstGeom prst="roundRect">
             <a:avLst/>
@@ -12268,10 +12386,10 @@
       </p:sp>
       <p:sp>
         <p:nvSpPr>
-          <p:cNvPr id="31" name="직사각형 30">
-            <a:extLst>
-              <a:ext uri="{FF2B5EF4-FFF2-40B4-BE49-F238E27FC236}">
-                <a16:creationId xmlns:a16="http://schemas.microsoft.com/office/drawing/2014/main" id="{C7E34684-8614-E994-E36A-1E8655C5A1D7}"/>
+          <p:cNvPr id="33" name="직사각형 32">
+            <a:extLst>
+              <a:ext uri="{FF2B5EF4-FFF2-40B4-BE49-F238E27FC236}">
+                <a16:creationId xmlns:a16="http://schemas.microsoft.com/office/drawing/2014/main" id="{6365E095-9112-B273-C89D-4DAF93C7D920}"/>
               </a:ext>
             </a:extLst>
           </p:cNvPr>
@@ -12280,8 +12398,8 @@
         </p:nvSpPr>
         <p:spPr>
           <a:xfrm>
-            <a:off x="4889500" y="2082800"/>
-            <a:ext cx="76200" cy="990600"/>
+            <a:off x="4953000" y="2095500"/>
+            <a:ext cx="76200" cy="952500"/>
           </a:xfrm>
           <a:prstGeom prst="rect">
             <a:avLst/>
@@ -12336,10 +12454,10 @@
       </p:sp>
       <p:sp>
         <p:nvSpPr>
-          <p:cNvPr id="32" name="TextBox 31">
-            <a:extLst>
-              <a:ext uri="{FF2B5EF4-FFF2-40B4-BE49-F238E27FC236}">
-                <a16:creationId xmlns:a16="http://schemas.microsoft.com/office/drawing/2014/main" id="{2FBEED27-76BF-D4A5-C3B7-422CD1BD2792}"/>
+          <p:cNvPr id="34" name="TextBox 33">
+            <a:extLst>
+              <a:ext uri="{FF2B5EF4-FFF2-40B4-BE49-F238E27FC236}">
+                <a16:creationId xmlns:a16="http://schemas.microsoft.com/office/drawing/2014/main" id="{43B741CB-E636-FE5A-F3EE-EC45219A7E9B}"/>
               </a:ext>
             </a:extLst>
           </p:cNvPr>
@@ -12348,7 +12466,7 @@
         </p:nvSpPr>
         <p:spPr>
           <a:xfrm>
-            <a:off x="5092700" y="2247900"/>
+            <a:off x="5156200" y="2260600"/>
             <a:ext cx="1879600" cy="230832"/>
           </a:xfrm>
           <a:prstGeom prst="rect">
@@ -12383,10 +12501,10 @@
       </p:sp>
       <p:sp>
         <p:nvSpPr>
-          <p:cNvPr id="33" name="TextBox 32">
-            <a:extLst>
-              <a:ext uri="{FF2B5EF4-FFF2-40B4-BE49-F238E27FC236}">
-                <a16:creationId xmlns:a16="http://schemas.microsoft.com/office/drawing/2014/main" id="{C4126CF9-2B14-168F-9860-B9E437C3FC97}"/>
+          <p:cNvPr id="35" name="TextBox 34">
+            <a:extLst>
+              <a:ext uri="{FF2B5EF4-FFF2-40B4-BE49-F238E27FC236}">
+                <a16:creationId xmlns:a16="http://schemas.microsoft.com/office/drawing/2014/main" id="{F1AC159E-0672-32DA-B191-477FF56E463B}"/>
               </a:ext>
             </a:extLst>
           </p:cNvPr>
@@ -12395,7 +12513,7 @@
         </p:nvSpPr>
         <p:spPr>
           <a:xfrm>
-            <a:off x="5067300" y="2616200"/>
+            <a:off x="5130800" y="2628900"/>
             <a:ext cx="1930400" cy="153888"/>
           </a:xfrm>
           <a:prstGeom prst="rect">
@@ -12417,7 +12535,7 @@
                 </a:solidFill>
                 <a:latin typeface="Malgun Gothic" panose="020B0503020000020004" pitchFamily="50" charset="-127"/>
               </a:rPr>
-              <a:t>앱 코드 </a:t>
+              <a:t>앱 코드</a:t>
             </a:r>
             <a:r>
               <a:rPr lang="en-US" altLang="ko-KR" sz="1000">
@@ -12426,7 +12544,7 @@
                 </a:solidFill>
                 <a:latin typeface="Malgun Gothic" panose="020B0503020000020004" pitchFamily="50" charset="-127"/>
               </a:rPr>
-              <a:t>+ </a:t>
+              <a:t>·</a:t>
             </a:r>
             <a:r>
               <a:rPr lang="ko-KR" altLang="en-US" sz="1000">
@@ -12435,17 +12553,17 @@
                 </a:solidFill>
                 <a:latin typeface="Malgun Gothic" panose="020B0503020000020004" pitchFamily="50" charset="-127"/>
               </a:rPr>
-              <a:t>환율 데이터 저장</a:t>
-            </a:r>
-          </a:p>
-        </p:txBody>
-      </p:sp>
-      <p:sp>
-        <p:nvSpPr>
-          <p:cNvPr id="34" name="사각형: 둥근 모서리 33">
-            <a:extLst>
-              <a:ext uri="{FF2B5EF4-FFF2-40B4-BE49-F238E27FC236}">
-                <a16:creationId xmlns:a16="http://schemas.microsoft.com/office/drawing/2014/main" id="{D0857D40-4182-8D23-CA02-2FC06D324172}"/>
+              <a:t>자동화 설정 보관</a:t>
+            </a:r>
+          </a:p>
+        </p:txBody>
+      </p:sp>
+      <p:sp>
+        <p:nvSpPr>
+          <p:cNvPr id="36" name="사각형: 둥근 모서리 35">
+            <a:extLst>
+              <a:ext uri="{FF2B5EF4-FFF2-40B4-BE49-F238E27FC236}">
+                <a16:creationId xmlns:a16="http://schemas.microsoft.com/office/drawing/2014/main" id="{951556C4-5291-FE45-555E-37F7BE452DE4}"/>
               </a:ext>
             </a:extLst>
           </p:cNvPr>
@@ -12454,8 +12572,8 @@
         </p:nvSpPr>
         <p:spPr>
           <a:xfrm>
-            <a:off x="9334500" y="2260600"/>
-            <a:ext cx="2286000" cy="990600"/>
+            <a:off x="9334500" y="2222500"/>
+            <a:ext cx="2286000" cy="952500"/>
           </a:xfrm>
           <a:prstGeom prst="roundRect">
             <a:avLst/>
@@ -12496,10 +12614,10 @@
       </p:sp>
       <p:sp>
         <p:nvSpPr>
-          <p:cNvPr id="35" name="직사각형 34">
-            <a:extLst>
-              <a:ext uri="{FF2B5EF4-FFF2-40B4-BE49-F238E27FC236}">
-                <a16:creationId xmlns:a16="http://schemas.microsoft.com/office/drawing/2014/main" id="{E9DEFA5B-F1EE-3DDE-207E-D76ADFD67A21}"/>
+          <p:cNvPr id="37" name="직사각형 36">
+            <a:extLst>
+              <a:ext uri="{FF2B5EF4-FFF2-40B4-BE49-F238E27FC236}">
+                <a16:creationId xmlns:a16="http://schemas.microsoft.com/office/drawing/2014/main" id="{44D66BE0-0A57-E092-E84D-351AC502356B}"/>
               </a:ext>
             </a:extLst>
           </p:cNvPr>
@@ -12508,8 +12626,8 @@
         </p:nvSpPr>
         <p:spPr>
           <a:xfrm>
-            <a:off x="9334500" y="2260600"/>
-            <a:ext cx="76200" cy="990600"/>
+            <a:off x="9334500" y="2222500"/>
+            <a:ext cx="76200" cy="952500"/>
           </a:xfrm>
           <a:prstGeom prst="rect">
             <a:avLst/>
@@ -12564,10 +12682,10 @@
       </p:sp>
       <p:sp>
         <p:nvSpPr>
-          <p:cNvPr id="36" name="TextBox 35">
-            <a:extLst>
-              <a:ext uri="{FF2B5EF4-FFF2-40B4-BE49-F238E27FC236}">
-                <a16:creationId xmlns:a16="http://schemas.microsoft.com/office/drawing/2014/main" id="{63805B19-75FA-47ED-B0D3-2FF179E80718}"/>
+          <p:cNvPr id="38" name="TextBox 37">
+            <a:extLst>
+              <a:ext uri="{FF2B5EF4-FFF2-40B4-BE49-F238E27FC236}">
+                <a16:creationId xmlns:a16="http://schemas.microsoft.com/office/drawing/2014/main" id="{F8D77F51-DBB1-9862-A32C-327B5FA4D4CD}"/>
               </a:ext>
             </a:extLst>
           </p:cNvPr>
@@ -12576,7 +12694,7 @@
         </p:nvSpPr>
         <p:spPr>
           <a:xfrm>
-            <a:off x="9537700" y="2425700"/>
+            <a:off x="9537700" y="2387600"/>
             <a:ext cx="1879600" cy="230832"/>
           </a:xfrm>
           <a:prstGeom prst="rect">
@@ -12611,10 +12729,10 @@
       </p:sp>
       <p:sp>
         <p:nvSpPr>
-          <p:cNvPr id="37" name="TextBox 36">
-            <a:extLst>
-              <a:ext uri="{FF2B5EF4-FFF2-40B4-BE49-F238E27FC236}">
-                <a16:creationId xmlns:a16="http://schemas.microsoft.com/office/drawing/2014/main" id="{040A75AE-F850-396D-8960-733CFEE40F6A}"/>
+          <p:cNvPr id="39" name="TextBox 38">
+            <a:extLst>
+              <a:ext uri="{FF2B5EF4-FFF2-40B4-BE49-F238E27FC236}">
+                <a16:creationId xmlns:a16="http://schemas.microsoft.com/office/drawing/2014/main" id="{800D4FF3-9A74-189B-9D73-733DE0E2FA74}"/>
               </a:ext>
             </a:extLst>
           </p:cNvPr>
@@ -12623,7 +12741,7 @@
         </p:nvSpPr>
         <p:spPr>
           <a:xfrm>
-            <a:off x="9512300" y="2794000"/>
+            <a:off x="9512300" y="2755900"/>
             <a:ext cx="1930400" cy="153888"/>
           </a:xfrm>
           <a:prstGeom prst="rect">
@@ -12652,10 +12770,10 @@
       </p:sp>
       <p:sp>
         <p:nvSpPr>
-          <p:cNvPr id="38" name="사각형: 둥근 모서리 37">
-            <a:extLst>
-              <a:ext uri="{FF2B5EF4-FFF2-40B4-BE49-F238E27FC236}">
-                <a16:creationId xmlns:a16="http://schemas.microsoft.com/office/drawing/2014/main" id="{F6093A6D-D174-1B97-9BBD-74E7B34E9497}"/>
+          <p:cNvPr id="40" name="사각형: 둥근 모서리 39">
+            <a:extLst>
+              <a:ext uri="{FF2B5EF4-FFF2-40B4-BE49-F238E27FC236}">
+                <a16:creationId xmlns:a16="http://schemas.microsoft.com/office/drawing/2014/main" id="{6AB14CE7-5D55-9B4C-45E6-93FCC215041D}"/>
               </a:ext>
             </a:extLst>
           </p:cNvPr>
@@ -12664,8 +12782,8 @@
         </p:nvSpPr>
         <p:spPr>
           <a:xfrm>
-            <a:off x="4635500" y="3403600"/>
-            <a:ext cx="2857500" cy="1143000"/>
+            <a:off x="4635500" y="3429000"/>
+            <a:ext cx="2857500" cy="1092200"/>
           </a:xfrm>
           <a:prstGeom prst="roundRect">
             <a:avLst/>
@@ -12706,10 +12824,10 @@
       </p:sp>
       <p:sp>
         <p:nvSpPr>
-          <p:cNvPr id="39" name="TextBox 38">
-            <a:extLst>
-              <a:ext uri="{FF2B5EF4-FFF2-40B4-BE49-F238E27FC236}">
-                <a16:creationId xmlns:a16="http://schemas.microsoft.com/office/drawing/2014/main" id="{B34EE502-E53A-4A29-FA0C-D962F60EE6F1}"/>
+          <p:cNvPr id="41" name="TextBox 40">
+            <a:extLst>
+              <a:ext uri="{FF2B5EF4-FFF2-40B4-BE49-F238E27FC236}">
+                <a16:creationId xmlns:a16="http://schemas.microsoft.com/office/drawing/2014/main" id="{936F1521-737D-B71E-6D69-938353538E6A}"/>
               </a:ext>
             </a:extLst>
           </p:cNvPr>
@@ -12718,7 +12836,7 @@
         </p:nvSpPr>
         <p:spPr>
           <a:xfrm>
-            <a:off x="4838700" y="3568700"/>
+            <a:off x="4838700" y="3594100"/>
             <a:ext cx="2451100" cy="230832"/>
           </a:xfrm>
           <a:prstGeom prst="rect">
@@ -12753,10 +12871,10 @@
       </p:sp>
       <p:sp>
         <p:nvSpPr>
-          <p:cNvPr id="40" name="TextBox 39">
-            <a:extLst>
-              <a:ext uri="{FF2B5EF4-FFF2-40B4-BE49-F238E27FC236}">
-                <a16:creationId xmlns:a16="http://schemas.microsoft.com/office/drawing/2014/main" id="{B28181F3-3FBE-57B7-7464-92E06AF216ED}"/>
+          <p:cNvPr id="42" name="TextBox 41">
+            <a:extLst>
+              <a:ext uri="{FF2B5EF4-FFF2-40B4-BE49-F238E27FC236}">
+                <a16:creationId xmlns:a16="http://schemas.microsoft.com/office/drawing/2014/main" id="{D852D8BF-736F-921E-9416-958CD2C26AF7}"/>
               </a:ext>
             </a:extLst>
           </p:cNvPr>
@@ -12765,7 +12883,7 @@
         </p:nvSpPr>
         <p:spPr>
           <a:xfrm>
-            <a:off x="4813300" y="3937000"/>
+            <a:off x="4813300" y="3962400"/>
             <a:ext cx="2501900" cy="307777"/>
           </a:xfrm>
           <a:prstGeom prst="rect">
@@ -12787,35 +12905,17 @@
                 </a:solidFill>
                 <a:latin typeface="Malgun Gothic" panose="020B0503020000020004" pitchFamily="50" charset="-127"/>
               </a:rPr>
-              <a:t>계산</a:t>
-            </a:r>
-            <a:r>
-              <a:rPr lang="en-US" altLang="ko-KR" sz="1000">
-                <a:solidFill>
-                  <a:srgbClr val="DCE4EA"/>
-                </a:solidFill>
-                <a:latin typeface="Malgun Gothic" panose="020B0503020000020004" pitchFamily="50" charset="-127"/>
-              </a:rPr>
-              <a:t>·</a:t>
-            </a:r>
-            <a:r>
-              <a:rPr lang="ko-KR" altLang="en-US" sz="1000">
-                <a:solidFill>
-                  <a:srgbClr val="DCE4EA"/>
-                </a:solidFill>
-                <a:latin typeface="Malgun Gothic" panose="020B0503020000020004" pitchFamily="50" charset="-127"/>
-              </a:rPr>
-              <a:t>비교하고 판단하기 쉽게 보여주는 업무 화면</a:t>
-            </a:r>
-          </a:p>
-        </p:txBody>
-      </p:sp>
-      <p:sp>
-        <p:nvSpPr>
-          <p:cNvPr id="41" name="사각형: 둥근 모서리 40">
-            <a:extLst>
-              <a:ext uri="{FF2B5EF4-FFF2-40B4-BE49-F238E27FC236}">
-                <a16:creationId xmlns:a16="http://schemas.microsoft.com/office/drawing/2014/main" id="{BC2F4D2B-7BAB-27C9-B225-20C12893D9F8}"/>
+              <a:t>환율을 비교하고 판단하기 쉽게 보여주는 업무 화면</a:t>
+            </a:r>
+          </a:p>
+        </p:txBody>
+      </p:sp>
+      <p:sp>
+        <p:nvSpPr>
+          <p:cNvPr id="43" name="사각형: 둥근 모서리 42">
+            <a:extLst>
+              <a:ext uri="{FF2B5EF4-FFF2-40B4-BE49-F238E27FC236}">
+                <a16:creationId xmlns:a16="http://schemas.microsoft.com/office/drawing/2014/main" id="{51B1C224-94A6-C371-7C92-E26459C1E767}"/>
               </a:ext>
             </a:extLst>
           </p:cNvPr>
@@ -12824,8 +12924,8 @@
         </p:nvSpPr>
         <p:spPr>
           <a:xfrm>
-            <a:off x="9334500" y="4140200"/>
-            <a:ext cx="2286000" cy="990600"/>
+            <a:off x="4635500" y="5257800"/>
+            <a:ext cx="2286000" cy="863600"/>
           </a:xfrm>
           <a:prstGeom prst="roundRect">
             <a:avLst/>
@@ -12866,10 +12966,10 @@
       </p:sp>
       <p:sp>
         <p:nvSpPr>
-          <p:cNvPr id="42" name="직사각형 41">
-            <a:extLst>
-              <a:ext uri="{FF2B5EF4-FFF2-40B4-BE49-F238E27FC236}">
-                <a16:creationId xmlns:a16="http://schemas.microsoft.com/office/drawing/2014/main" id="{3F9C48A1-EEDA-7AE4-AF92-13B8E3029BF8}"/>
+          <p:cNvPr id="44" name="직사각형 43">
+            <a:extLst>
+              <a:ext uri="{FF2B5EF4-FFF2-40B4-BE49-F238E27FC236}">
+                <a16:creationId xmlns:a16="http://schemas.microsoft.com/office/drawing/2014/main" id="{6849CEDD-6CF7-396F-4C6D-9279550F2759}"/>
               </a:ext>
             </a:extLst>
           </p:cNvPr>
@@ -12878,8 +12978,8 @@
         </p:nvSpPr>
         <p:spPr>
           <a:xfrm>
-            <a:off x="9334500" y="4140200"/>
-            <a:ext cx="76200" cy="990600"/>
+            <a:off x="4635500" y="5257800"/>
+            <a:ext cx="76200" cy="863600"/>
           </a:xfrm>
           <a:prstGeom prst="rect">
             <a:avLst/>
@@ -12934,10 +13034,10 @@
       </p:sp>
       <p:sp>
         <p:nvSpPr>
-          <p:cNvPr id="43" name="TextBox 42">
-            <a:extLst>
-              <a:ext uri="{FF2B5EF4-FFF2-40B4-BE49-F238E27FC236}">
-                <a16:creationId xmlns:a16="http://schemas.microsoft.com/office/drawing/2014/main" id="{6EB1C00C-AED0-2301-77FA-592BB34BB8DA}"/>
+          <p:cNvPr id="45" name="TextBox 44">
+            <a:extLst>
+              <a:ext uri="{FF2B5EF4-FFF2-40B4-BE49-F238E27FC236}">
+                <a16:creationId xmlns:a16="http://schemas.microsoft.com/office/drawing/2014/main" id="{AB4BA460-1801-855E-5DBB-DFE89D70C54C}"/>
               </a:ext>
             </a:extLst>
           </p:cNvPr>
@@ -12946,7 +13046,7 @@
         </p:nvSpPr>
         <p:spPr>
           <a:xfrm>
-            <a:off x="9537700" y="4305300"/>
+            <a:off x="4838700" y="5422900"/>
             <a:ext cx="1879600" cy="230832"/>
           </a:xfrm>
           <a:prstGeom prst="rect">
@@ -12981,10 +13081,10 @@
       </p:sp>
       <p:sp>
         <p:nvSpPr>
-          <p:cNvPr id="44" name="TextBox 43">
-            <a:extLst>
-              <a:ext uri="{FF2B5EF4-FFF2-40B4-BE49-F238E27FC236}">
-                <a16:creationId xmlns:a16="http://schemas.microsoft.com/office/drawing/2014/main" id="{2ACEE2B0-20F4-4418-5582-247C8F60E3B1}"/>
+          <p:cNvPr id="46" name="TextBox 45">
+            <a:extLst>
+              <a:ext uri="{FF2B5EF4-FFF2-40B4-BE49-F238E27FC236}">
+                <a16:creationId xmlns:a16="http://schemas.microsoft.com/office/drawing/2014/main" id="{276B5D60-9A71-B4A6-B182-194355800667}"/>
               </a:ext>
             </a:extLst>
           </p:cNvPr>
@@ -12993,7 +13093,7 @@
         </p:nvSpPr>
         <p:spPr>
           <a:xfrm>
-            <a:off x="9512300" y="4673600"/>
+            <a:off x="4813300" y="5791200"/>
             <a:ext cx="1930400" cy="153888"/>
           </a:xfrm>
           <a:prstGeom prst="rect">
@@ -13015,7 +13115,7 @@
                 </a:solidFill>
                 <a:latin typeface="Malgun Gothic" panose="020B0503020000020004" pitchFamily="50" charset="-127"/>
               </a:rPr>
-              <a:t>계획 환율</a:t>
+              <a:t>환율</a:t>
             </a:r>
             <a:r>
               <a:rPr lang="en-US" altLang="ko-KR" sz="1000">
@@ -13033,35 +13133,17 @@
                 </a:solidFill>
                 <a:latin typeface="Malgun Gothic" panose="020B0503020000020004" pitchFamily="50" charset="-127"/>
               </a:rPr>
-              <a:t>로그인</a:t>
-            </a:r>
-            <a:r>
-              <a:rPr lang="en-US" altLang="ko-KR" sz="1000">
-                <a:solidFill>
-                  <a:srgbClr val="4D586A"/>
-                </a:solidFill>
-                <a:latin typeface="Malgun Gothic" panose="020B0503020000020004" pitchFamily="50" charset="-127"/>
-              </a:rPr>
-              <a:t>·</a:t>
-            </a:r>
-            <a:r>
-              <a:rPr lang="ko-KR" altLang="en-US" sz="1000">
-                <a:solidFill>
-                  <a:srgbClr val="4D586A"/>
-                </a:solidFill>
-                <a:latin typeface="Malgun Gothic" panose="020B0503020000020004" pitchFamily="50" charset="-127"/>
-              </a:rPr>
-              <a:t>수정 권한</a:t>
-            </a:r>
-          </a:p>
-        </p:txBody>
-      </p:sp>
-      <p:sp>
-        <p:nvSpPr>
-          <p:cNvPr id="45" name="사각형: 둥근 모서리 44">
-            <a:extLst>
-              <a:ext uri="{FF2B5EF4-FFF2-40B4-BE49-F238E27FC236}">
-                <a16:creationId xmlns:a16="http://schemas.microsoft.com/office/drawing/2014/main" id="{FFEF8F38-8F45-A37C-96FC-EB346A34365C}"/>
+              <a:t>계획 데이터와 권한 관리</a:t>
+            </a:r>
+          </a:p>
+        </p:txBody>
+      </p:sp>
+      <p:sp>
+        <p:nvSpPr>
+          <p:cNvPr id="47" name="사각형: 둥근 모서리 46">
+            <a:extLst>
+              <a:ext uri="{FF2B5EF4-FFF2-40B4-BE49-F238E27FC236}">
+                <a16:creationId xmlns:a16="http://schemas.microsoft.com/office/drawing/2014/main" id="{FCFAC3AF-8AB6-44B0-6500-002AD8157D2A}"/>
               </a:ext>
             </a:extLst>
           </p:cNvPr>
@@ -13070,8 +13152,8 @@
         </p:nvSpPr>
         <p:spPr>
           <a:xfrm>
-            <a:off x="3238500" y="5257800"/>
-            <a:ext cx="2222500" cy="914400"/>
+            <a:off x="7493000" y="5257800"/>
+            <a:ext cx="1968500" cy="863600"/>
           </a:xfrm>
           <a:prstGeom prst="roundRect">
             <a:avLst/>
@@ -13112,10 +13194,10 @@
       </p:sp>
       <p:sp>
         <p:nvSpPr>
-          <p:cNvPr id="46" name="직사각형 45">
-            <a:extLst>
-              <a:ext uri="{FF2B5EF4-FFF2-40B4-BE49-F238E27FC236}">
-                <a16:creationId xmlns:a16="http://schemas.microsoft.com/office/drawing/2014/main" id="{E79A7EC0-3C8A-E7F2-8E7B-370F6ED5CEFB}"/>
+          <p:cNvPr id="48" name="직사각형 47">
+            <a:extLst>
+              <a:ext uri="{FF2B5EF4-FFF2-40B4-BE49-F238E27FC236}">
+                <a16:creationId xmlns:a16="http://schemas.microsoft.com/office/drawing/2014/main" id="{DDFB2087-8B71-93BB-77DE-A531CA833B05}"/>
               </a:ext>
             </a:extLst>
           </p:cNvPr>
@@ -13124,8 +13206,8 @@
         </p:nvSpPr>
         <p:spPr>
           <a:xfrm>
-            <a:off x="3238500" y="5257800"/>
-            <a:ext cx="76200" cy="914400"/>
+            <a:off x="7493000" y="5257800"/>
+            <a:ext cx="76200" cy="863600"/>
           </a:xfrm>
           <a:prstGeom prst="rect">
             <a:avLst/>
@@ -13180,10 +13262,10 @@
       </p:sp>
       <p:sp>
         <p:nvSpPr>
-          <p:cNvPr id="47" name="TextBox 46">
-            <a:extLst>
-              <a:ext uri="{FF2B5EF4-FFF2-40B4-BE49-F238E27FC236}">
-                <a16:creationId xmlns:a16="http://schemas.microsoft.com/office/drawing/2014/main" id="{89CC132D-D0C5-29FB-1527-1A2DC4222CCB}"/>
+          <p:cNvPr id="49" name="TextBox 48">
+            <a:extLst>
+              <a:ext uri="{FF2B5EF4-FFF2-40B4-BE49-F238E27FC236}">
+                <a16:creationId xmlns:a16="http://schemas.microsoft.com/office/drawing/2014/main" id="{E07976A5-5DDF-2900-6797-4354B24419A4}"/>
               </a:ext>
             </a:extLst>
           </p:cNvPr>
@@ -13192,8 +13274,8 @@
         </p:nvSpPr>
         <p:spPr>
           <a:xfrm>
-            <a:off x="3441700" y="5422900"/>
-            <a:ext cx="1816100" cy="230832"/>
+            <a:off x="7696200" y="5422900"/>
+            <a:ext cx="1562100" cy="230832"/>
           </a:xfrm>
           <a:prstGeom prst="rect">
             <a:avLst/>
@@ -13221,10 +13303,10 @@
       </p:sp>
       <p:sp>
         <p:nvSpPr>
-          <p:cNvPr id="48" name="TextBox 47">
-            <a:extLst>
-              <a:ext uri="{FF2B5EF4-FFF2-40B4-BE49-F238E27FC236}">
-                <a16:creationId xmlns:a16="http://schemas.microsoft.com/office/drawing/2014/main" id="{3799B187-A1BB-ADB4-3AC1-9A212CA768B0}"/>
+          <p:cNvPr id="50" name="TextBox 49">
+            <a:extLst>
+              <a:ext uri="{FF2B5EF4-FFF2-40B4-BE49-F238E27FC236}">
+                <a16:creationId xmlns:a16="http://schemas.microsoft.com/office/drawing/2014/main" id="{712B1C7C-CA4F-338B-175B-354665F691A3}"/>
               </a:ext>
             </a:extLst>
           </p:cNvPr>
@@ -13233,8 +13315,8 @@
         </p:nvSpPr>
         <p:spPr>
           <a:xfrm>
-            <a:off x="3416300" y="5791200"/>
-            <a:ext cx="1866900" cy="153888"/>
+            <a:off x="7670800" y="5791200"/>
+            <a:ext cx="1612900" cy="153888"/>
           </a:xfrm>
           <a:prstGeom prst="rect">
             <a:avLst/>
@@ -13255,17 +13337,17 @@
                 </a:solidFill>
                 <a:latin typeface="Malgun Gothic" panose="020B0503020000020004" pitchFamily="50" charset="-127"/>
               </a:rPr>
-              <a:t>정리된 환율 정보를 자동 전달</a:t>
-            </a:r>
-          </a:p>
-        </p:txBody>
-      </p:sp>
-      <p:sp>
-        <p:nvSpPr>
-          <p:cNvPr id="49" name="사각형: 둥근 모서리 48">
-            <a:extLst>
-              <a:ext uri="{FF2B5EF4-FFF2-40B4-BE49-F238E27FC236}">
-                <a16:creationId xmlns:a16="http://schemas.microsoft.com/office/drawing/2014/main" id="{C09DC537-1443-2C6D-B20A-BEA40051CE1B}"/>
+              <a:t>같은 환율 정보를 자동 전달</a:t>
+            </a:r>
+          </a:p>
+        </p:txBody>
+      </p:sp>
+      <p:sp>
+        <p:nvSpPr>
+          <p:cNvPr id="51" name="사각형: 둥근 모서리 50">
+            <a:extLst>
+              <a:ext uri="{FF2B5EF4-FFF2-40B4-BE49-F238E27FC236}">
+                <a16:creationId xmlns:a16="http://schemas.microsoft.com/office/drawing/2014/main" id="{FF44327A-C12E-0456-4BDC-769B6A4ACEBE}"/>
               </a:ext>
             </a:extLst>
           </p:cNvPr>
@@ -13274,8 +13356,8 @@
         </p:nvSpPr>
         <p:spPr>
           <a:xfrm>
-            <a:off x="6350000" y="5257800"/>
-            <a:ext cx="2413000" cy="914400"/>
+            <a:off x="9906000" y="5257800"/>
+            <a:ext cx="1905000" cy="863600"/>
           </a:xfrm>
           <a:prstGeom prst="roundRect">
             <a:avLst/>
@@ -13316,10 +13398,10 @@
       </p:sp>
       <p:sp>
         <p:nvSpPr>
-          <p:cNvPr id="50" name="직사각형 49">
-            <a:extLst>
-              <a:ext uri="{FF2B5EF4-FFF2-40B4-BE49-F238E27FC236}">
-                <a16:creationId xmlns:a16="http://schemas.microsoft.com/office/drawing/2014/main" id="{ADE72FBB-D4AE-84D6-833A-53E7793493F7}"/>
+          <p:cNvPr id="52" name="직사각형 51">
+            <a:extLst>
+              <a:ext uri="{FF2B5EF4-FFF2-40B4-BE49-F238E27FC236}">
+                <a16:creationId xmlns:a16="http://schemas.microsoft.com/office/drawing/2014/main" id="{E2EF9F78-B3B7-7F7F-D335-9F272F245EFA}"/>
               </a:ext>
             </a:extLst>
           </p:cNvPr>
@@ -13328,8 +13410,8 @@
         </p:nvSpPr>
         <p:spPr>
           <a:xfrm>
-            <a:off x="6350000" y="5257800"/>
-            <a:ext cx="76200" cy="914400"/>
+            <a:off x="9906000" y="5257800"/>
+            <a:ext cx="76200" cy="863600"/>
           </a:xfrm>
           <a:prstGeom prst="rect">
             <a:avLst/>
@@ -13384,10 +13466,10 @@
       </p:sp>
       <p:sp>
         <p:nvSpPr>
-          <p:cNvPr id="51" name="TextBox 50">
-            <a:extLst>
-              <a:ext uri="{FF2B5EF4-FFF2-40B4-BE49-F238E27FC236}">
-                <a16:creationId xmlns:a16="http://schemas.microsoft.com/office/drawing/2014/main" id="{6D66EB7D-5B78-E1C2-B048-53F53C1D110B}"/>
+          <p:cNvPr id="53" name="TextBox 52">
+            <a:extLst>
+              <a:ext uri="{FF2B5EF4-FFF2-40B4-BE49-F238E27FC236}">
+                <a16:creationId xmlns:a16="http://schemas.microsoft.com/office/drawing/2014/main" id="{EB17A81F-39D9-7E6A-3444-9D957AE0FE7C}"/>
               </a:ext>
             </a:extLst>
           </p:cNvPr>
@@ -13396,8 +13478,8 @@
         </p:nvSpPr>
         <p:spPr>
           <a:xfrm>
-            <a:off x="6553200" y="5422900"/>
-            <a:ext cx="2006600" cy="230832"/>
+            <a:off x="10109200" y="5422900"/>
+            <a:ext cx="1498600" cy="230832"/>
           </a:xfrm>
           <a:prstGeom prst="rect">
             <a:avLst/>
@@ -13425,10 +13507,10 @@
       </p:sp>
       <p:sp>
         <p:nvSpPr>
-          <p:cNvPr id="52" name="TextBox 51">
-            <a:extLst>
-              <a:ext uri="{FF2B5EF4-FFF2-40B4-BE49-F238E27FC236}">
-                <a16:creationId xmlns:a16="http://schemas.microsoft.com/office/drawing/2014/main" id="{A00482AB-6948-84A3-614B-50F7ECB0E64A}"/>
+          <p:cNvPr id="54" name="TextBox 53">
+            <a:extLst>
+              <a:ext uri="{FF2B5EF4-FFF2-40B4-BE49-F238E27FC236}">
+                <a16:creationId xmlns:a16="http://schemas.microsoft.com/office/drawing/2014/main" id="{CEA6647B-6B4B-7067-4C6C-30CDEA228022}"/>
               </a:ext>
             </a:extLst>
           </p:cNvPr>
@@ -13437,8 +13519,8 @@
         </p:nvSpPr>
         <p:spPr>
           <a:xfrm>
-            <a:off x="6527800" y="5791200"/>
-            <a:ext cx="2057400" cy="153888"/>
+            <a:off x="10083800" y="5791200"/>
+            <a:ext cx="1549400" cy="153888"/>
           </a:xfrm>
           <a:prstGeom prst="rect">
             <a:avLst/>
@@ -13459,17 +13541,35 @@
                 </a:solidFill>
                 <a:latin typeface="Malgun Gothic" panose="020B0503020000020004" pitchFamily="50" charset="-127"/>
               </a:rPr>
-              <a:t>같은 기준으로 확인하고 최종 판단</a:t>
-            </a:r>
-          </a:p>
-        </p:txBody>
-      </p:sp>
-      <p:sp>
-        <p:nvSpPr>
-          <p:cNvPr id="53" name="TextBox 52">
-            <a:extLst>
-              <a:ext uri="{FF2B5EF4-FFF2-40B4-BE49-F238E27FC236}">
-                <a16:creationId xmlns:a16="http://schemas.microsoft.com/office/drawing/2014/main" id="{6864C180-93A2-ADCB-98ED-F49C3E0E0903}"/>
+              <a:t>웹</a:t>
+            </a:r>
+            <a:r>
+              <a:rPr lang="en-US" altLang="ko-KR" sz="1000">
+                <a:solidFill>
+                  <a:srgbClr val="4D586A"/>
+                </a:solidFill>
+                <a:latin typeface="Malgun Gothic" panose="020B0503020000020004" pitchFamily="50" charset="-127"/>
+              </a:rPr>
+              <a:t>·</a:t>
+            </a:r>
+            <a:r>
+              <a:rPr lang="ko-KR" altLang="en-US" sz="1000">
+                <a:solidFill>
+                  <a:srgbClr val="4D586A"/>
+                </a:solidFill>
+                <a:latin typeface="Malgun Gothic" panose="020B0503020000020004" pitchFamily="50" charset="-127"/>
+              </a:rPr>
+              <a:t>메일 확인 후 판단</a:t>
+            </a:r>
+          </a:p>
+        </p:txBody>
+      </p:sp>
+      <p:sp>
+        <p:nvSpPr>
+          <p:cNvPr id="55" name="TextBox 54">
+            <a:extLst>
+              <a:ext uri="{FF2B5EF4-FFF2-40B4-BE49-F238E27FC236}">
+                <a16:creationId xmlns:a16="http://schemas.microsoft.com/office/drawing/2014/main" id="{4E488B84-BDEC-3656-F31D-FF82CD5ABB83}"/>
               </a:ext>
             </a:extLst>
           </p:cNvPr>
@@ -13570,7 +13670,7 @@
     </p:spTree>
     <p:extLst>
       <p:ext uri="{BB962C8B-B14F-4D97-AF65-F5344CB8AC3E}">
-        <p14:creationId xmlns:p14="http://schemas.microsoft.com/office/powerpoint/2010/main" val="2017237917"/>
+        <p14:creationId xmlns:p14="http://schemas.microsoft.com/office/powerpoint/2010/main" val="2319965578"/>
       </p:ext>
     </p:extLst>
   </p:cSld>
@@ -13610,7 +13710,7 @@
           <p:cNvPr id="2" name="TextBox 1">
             <a:extLst>
               <a:ext uri="{FF2B5EF4-FFF2-40B4-BE49-F238E27FC236}">
-                <a16:creationId xmlns:a16="http://schemas.microsoft.com/office/drawing/2014/main" id="{6AD98D87-5F35-B086-93A0-F06F0C369CA7}"/>
+                <a16:creationId xmlns:a16="http://schemas.microsoft.com/office/drawing/2014/main" id="{E4D5BC57-17AD-5C6A-E90F-D527996FBD8C}"/>
               </a:ext>
             </a:extLst>
           </p:cNvPr>
@@ -13656,7 +13756,7 @@
           <p:cNvPr id="3" name="TextBox 2">
             <a:extLst>
               <a:ext uri="{FF2B5EF4-FFF2-40B4-BE49-F238E27FC236}">
-                <a16:creationId xmlns:a16="http://schemas.microsoft.com/office/drawing/2014/main" id="{BB8E77EA-1040-6F1A-DA75-759DF304D024}"/>
+                <a16:creationId xmlns:a16="http://schemas.microsoft.com/office/drawing/2014/main" id="{091593A1-8CDB-0250-52A2-A65C49B6BFD1}"/>
               </a:ext>
             </a:extLst>
           </p:cNvPr>
@@ -13702,7 +13802,7 @@
           <p:cNvPr id="4" name="TextBox 3">
             <a:extLst>
               <a:ext uri="{FF2B5EF4-FFF2-40B4-BE49-F238E27FC236}">
-                <a16:creationId xmlns:a16="http://schemas.microsoft.com/office/drawing/2014/main" id="{96282562-5648-CF6E-2214-B10AE940F296}"/>
+                <a16:creationId xmlns:a16="http://schemas.microsoft.com/office/drawing/2014/main" id="{957B9BAF-A2F3-49D2-7A9D-6081DE33C9F9}"/>
               </a:ext>
             </a:extLst>
           </p:cNvPr>
@@ -13760,7 +13860,7 @@
           <p:cNvPr id="5" name="TextBox 4">
             <a:extLst>
               <a:ext uri="{FF2B5EF4-FFF2-40B4-BE49-F238E27FC236}">
-                <a16:creationId xmlns:a16="http://schemas.microsoft.com/office/drawing/2014/main" id="{98D2AF0E-FB30-4AF3-A3E2-5CA526E87757}"/>
+                <a16:creationId xmlns:a16="http://schemas.microsoft.com/office/drawing/2014/main" id="{9B334E27-E1C2-DE89-1887-1AF2213EA9F6}"/>
               </a:ext>
             </a:extLst>
           </p:cNvPr>
@@ -13800,7 +13900,7 @@
           <p:cNvPr id="6" name="사각형: 둥근 모서리 5">
             <a:extLst>
               <a:ext uri="{FF2B5EF4-FFF2-40B4-BE49-F238E27FC236}">
-                <a16:creationId xmlns:a16="http://schemas.microsoft.com/office/drawing/2014/main" id="{A83D3577-1D96-4D32-30A3-987C72690539}"/>
+                <a16:creationId xmlns:a16="http://schemas.microsoft.com/office/drawing/2014/main" id="{E674BB70-C633-ABEF-1F56-72C2683D7B9C}"/>
               </a:ext>
             </a:extLst>
           </p:cNvPr>
@@ -13854,7 +13954,7 @@
           <p:cNvPr id="7" name="직사각형 6">
             <a:extLst>
               <a:ext uri="{FF2B5EF4-FFF2-40B4-BE49-F238E27FC236}">
-                <a16:creationId xmlns:a16="http://schemas.microsoft.com/office/drawing/2014/main" id="{64776B0D-691D-ABDF-62E6-1E212D99FC19}"/>
+                <a16:creationId xmlns:a16="http://schemas.microsoft.com/office/drawing/2014/main" id="{CB939131-9CB8-51DB-5B82-AEE87D6B2BC7}"/>
               </a:ext>
             </a:extLst>
           </p:cNvPr>
@@ -13922,7 +14022,7 @@
           <p:cNvPr id="8" name="TextBox 7">
             <a:extLst>
               <a:ext uri="{FF2B5EF4-FFF2-40B4-BE49-F238E27FC236}">
-                <a16:creationId xmlns:a16="http://schemas.microsoft.com/office/drawing/2014/main" id="{92DFDAEC-FAD2-67A6-B392-B9834E7F4A38}"/>
+                <a16:creationId xmlns:a16="http://schemas.microsoft.com/office/drawing/2014/main" id="{86EC96C4-7A6F-7D52-CB88-28AF40677EAF}"/>
               </a:ext>
             </a:extLst>
           </p:cNvPr>
@@ -13962,7 +14062,7 @@
           <p:cNvPr id="9" name="TextBox 8">
             <a:extLst>
               <a:ext uri="{FF2B5EF4-FFF2-40B4-BE49-F238E27FC236}">
-                <a16:creationId xmlns:a16="http://schemas.microsoft.com/office/drawing/2014/main" id="{727347CB-13CC-FBE0-F6EF-BEC8F96FC56E}"/>
+                <a16:creationId xmlns:a16="http://schemas.microsoft.com/office/drawing/2014/main" id="{E613F620-E6EE-5B86-0DE4-D5DF1F815830}"/>
               </a:ext>
             </a:extLst>
           </p:cNvPr>
@@ -14017,7 +14117,7 @@
           <p:cNvPr id="10" name="사각형: 둥근 모서리 9">
             <a:extLst>
               <a:ext uri="{FF2B5EF4-FFF2-40B4-BE49-F238E27FC236}">
-                <a16:creationId xmlns:a16="http://schemas.microsoft.com/office/drawing/2014/main" id="{66769B12-3074-D9B9-A40C-29A5AB8521EB}"/>
+                <a16:creationId xmlns:a16="http://schemas.microsoft.com/office/drawing/2014/main" id="{0C5E86C0-3034-9A7F-8922-167A2E55C015}"/>
               </a:ext>
             </a:extLst>
           </p:cNvPr>
@@ -14071,7 +14171,7 @@
           <p:cNvPr id="11" name="직사각형 10">
             <a:extLst>
               <a:ext uri="{FF2B5EF4-FFF2-40B4-BE49-F238E27FC236}">
-                <a16:creationId xmlns:a16="http://schemas.microsoft.com/office/drawing/2014/main" id="{3ED4C558-77EC-CEE6-9C89-6AB4C2A3F89D}"/>
+                <a16:creationId xmlns:a16="http://schemas.microsoft.com/office/drawing/2014/main" id="{6B9AB1ED-B5E0-BFC0-E6EF-2E9799F928F7}"/>
               </a:ext>
             </a:extLst>
           </p:cNvPr>
@@ -14139,7 +14239,7 @@
           <p:cNvPr id="12" name="TextBox 11">
             <a:extLst>
               <a:ext uri="{FF2B5EF4-FFF2-40B4-BE49-F238E27FC236}">
-                <a16:creationId xmlns:a16="http://schemas.microsoft.com/office/drawing/2014/main" id="{8E0CBC49-711F-3E7E-23E4-6E463D698F1A}"/>
+                <a16:creationId xmlns:a16="http://schemas.microsoft.com/office/drawing/2014/main" id="{8E8722FA-3944-838B-4CC5-F46A9DE5A53A}"/>
               </a:ext>
             </a:extLst>
           </p:cNvPr>
@@ -14179,7 +14279,7 @@
           <p:cNvPr id="13" name="TextBox 12">
             <a:extLst>
               <a:ext uri="{FF2B5EF4-FFF2-40B4-BE49-F238E27FC236}">
-                <a16:creationId xmlns:a16="http://schemas.microsoft.com/office/drawing/2014/main" id="{EFDBC633-6617-9BE2-689B-569A09B9E756}"/>
+                <a16:creationId xmlns:a16="http://schemas.microsoft.com/office/drawing/2014/main" id="{4601EEE3-9E2B-3EE6-567B-C58AAAA84E96}"/>
               </a:ext>
             </a:extLst>
           </p:cNvPr>
@@ -14234,7 +14334,7 @@
           <p:cNvPr id="14" name="사각형: 둥근 모서리 13">
             <a:extLst>
               <a:ext uri="{FF2B5EF4-FFF2-40B4-BE49-F238E27FC236}">
-                <a16:creationId xmlns:a16="http://schemas.microsoft.com/office/drawing/2014/main" id="{BC2A6A92-3308-D1D3-3E98-EAF84C71D7AD}"/>
+                <a16:creationId xmlns:a16="http://schemas.microsoft.com/office/drawing/2014/main" id="{9A0E562F-DF32-9D85-EBD6-4642480649F0}"/>
               </a:ext>
             </a:extLst>
           </p:cNvPr>
@@ -14288,7 +14388,7 @@
           <p:cNvPr id="15" name="직사각형 14">
             <a:extLst>
               <a:ext uri="{FF2B5EF4-FFF2-40B4-BE49-F238E27FC236}">
-                <a16:creationId xmlns:a16="http://schemas.microsoft.com/office/drawing/2014/main" id="{E593B382-64E3-937B-13D8-34EACA7C85C5}"/>
+                <a16:creationId xmlns:a16="http://schemas.microsoft.com/office/drawing/2014/main" id="{4586BA70-F089-7352-A61D-0A2C74542316}"/>
               </a:ext>
             </a:extLst>
           </p:cNvPr>
@@ -14356,7 +14456,7 @@
           <p:cNvPr id="16" name="TextBox 15">
             <a:extLst>
               <a:ext uri="{FF2B5EF4-FFF2-40B4-BE49-F238E27FC236}">
-                <a16:creationId xmlns:a16="http://schemas.microsoft.com/office/drawing/2014/main" id="{1CFD190F-962E-13F7-8CA8-628181FE99C8}"/>
+                <a16:creationId xmlns:a16="http://schemas.microsoft.com/office/drawing/2014/main" id="{F909FF3D-A249-0EA1-EC16-3A113AEAFB83}"/>
               </a:ext>
             </a:extLst>
           </p:cNvPr>
@@ -14396,7 +14496,7 @@
           <p:cNvPr id="17" name="TextBox 16">
             <a:extLst>
               <a:ext uri="{FF2B5EF4-FFF2-40B4-BE49-F238E27FC236}">
-                <a16:creationId xmlns:a16="http://schemas.microsoft.com/office/drawing/2014/main" id="{BAD7523F-8FAD-1D04-E729-99B59599A2C1}"/>
+                <a16:creationId xmlns:a16="http://schemas.microsoft.com/office/drawing/2014/main" id="{7DFC8320-9DF3-EC33-CB10-7333B8780C45}"/>
               </a:ext>
             </a:extLst>
           </p:cNvPr>
@@ -14451,7 +14551,7 @@
           <p:cNvPr id="18" name="사각형: 둥근 모서리 17">
             <a:extLst>
               <a:ext uri="{FF2B5EF4-FFF2-40B4-BE49-F238E27FC236}">
-                <a16:creationId xmlns:a16="http://schemas.microsoft.com/office/drawing/2014/main" id="{CBC710DA-671F-8663-D067-EB4EEBE640E5}"/>
+                <a16:creationId xmlns:a16="http://schemas.microsoft.com/office/drawing/2014/main" id="{A9DCE344-6587-6850-7080-A57361F2FBF2}"/>
               </a:ext>
             </a:extLst>
           </p:cNvPr>
@@ -14505,7 +14605,7 @@
           <p:cNvPr id="19" name="직사각형 18">
             <a:extLst>
               <a:ext uri="{FF2B5EF4-FFF2-40B4-BE49-F238E27FC236}">
-                <a16:creationId xmlns:a16="http://schemas.microsoft.com/office/drawing/2014/main" id="{CD2592CF-B2C4-8822-63C7-80BC543818A9}"/>
+                <a16:creationId xmlns:a16="http://schemas.microsoft.com/office/drawing/2014/main" id="{66A8C89F-FB64-055B-2582-1C03AF1C3554}"/>
               </a:ext>
             </a:extLst>
           </p:cNvPr>
@@ -14573,7 +14673,7 @@
           <p:cNvPr id="20" name="TextBox 19">
             <a:extLst>
               <a:ext uri="{FF2B5EF4-FFF2-40B4-BE49-F238E27FC236}">
-                <a16:creationId xmlns:a16="http://schemas.microsoft.com/office/drawing/2014/main" id="{110C53C5-244B-40D2-AC4B-B04740E8939E}"/>
+                <a16:creationId xmlns:a16="http://schemas.microsoft.com/office/drawing/2014/main" id="{1E7C96C4-7275-A3AA-C1D5-CEAADEE59E0C}"/>
               </a:ext>
             </a:extLst>
           </p:cNvPr>
@@ -14613,7 +14713,7 @@
           <p:cNvPr id="21" name="TextBox 20">
             <a:extLst>
               <a:ext uri="{FF2B5EF4-FFF2-40B4-BE49-F238E27FC236}">
-                <a16:creationId xmlns:a16="http://schemas.microsoft.com/office/drawing/2014/main" id="{D9D23EC4-CCBE-3944-CB1A-45649CF5A8E1}"/>
+                <a16:creationId xmlns:a16="http://schemas.microsoft.com/office/drawing/2014/main" id="{DC349BE9-3E9A-62AE-79CF-E5EE097A3317}"/>
               </a:ext>
             </a:extLst>
           </p:cNvPr>
@@ -14722,7 +14822,7 @@
           <p:cNvPr id="22" name="TextBox 21">
             <a:extLst>
               <a:ext uri="{FF2B5EF4-FFF2-40B4-BE49-F238E27FC236}">
-                <a16:creationId xmlns:a16="http://schemas.microsoft.com/office/drawing/2014/main" id="{935D51AA-128E-8209-A05D-9DDE408E0718}"/>
+                <a16:creationId xmlns:a16="http://schemas.microsoft.com/office/drawing/2014/main" id="{9B5A0F40-9EF3-6F24-B2EA-E6E8118260F7}"/>
               </a:ext>
             </a:extLst>
           </p:cNvPr>
@@ -14850,7 +14950,7 @@
           <p:cNvPr id="23" name="TextBox 22">
             <a:extLst>
               <a:ext uri="{FF2B5EF4-FFF2-40B4-BE49-F238E27FC236}">
-                <a16:creationId xmlns:a16="http://schemas.microsoft.com/office/drawing/2014/main" id="{40782A2A-CD45-74C6-50A4-C67095848E7D}"/>
+                <a16:creationId xmlns:a16="http://schemas.microsoft.com/office/drawing/2014/main" id="{79D64315-224A-F74B-2B85-DB7C2B9DA30F}"/>
               </a:ext>
             </a:extLst>
           </p:cNvPr>
@@ -14915,7 +15015,7 @@
     </p:spTree>
     <p:extLst>
       <p:ext uri="{BB962C8B-B14F-4D97-AF65-F5344CB8AC3E}">
-        <p14:creationId xmlns:p14="http://schemas.microsoft.com/office/powerpoint/2010/main" val="594087337"/>
+        <p14:creationId xmlns:p14="http://schemas.microsoft.com/office/powerpoint/2010/main" val="2760076873"/>
       </p:ext>
     </p:extLst>
   </p:cSld>
@@ -14955,7 +15055,7 @@
           <p:cNvPr id="2" name="TextBox 1">
             <a:extLst>
               <a:ext uri="{FF2B5EF4-FFF2-40B4-BE49-F238E27FC236}">
-                <a16:creationId xmlns:a16="http://schemas.microsoft.com/office/drawing/2014/main" id="{9B8D8D94-C152-AD2E-14C8-D553F9233BDB}"/>
+                <a16:creationId xmlns:a16="http://schemas.microsoft.com/office/drawing/2014/main" id="{B4D71C25-FD9D-4C04-A347-50C8ECCBED8E}"/>
               </a:ext>
             </a:extLst>
           </p:cNvPr>
@@ -15001,7 +15101,7 @@
           <p:cNvPr id="3" name="TextBox 2">
             <a:extLst>
               <a:ext uri="{FF2B5EF4-FFF2-40B4-BE49-F238E27FC236}">
-                <a16:creationId xmlns:a16="http://schemas.microsoft.com/office/drawing/2014/main" id="{C49FB085-E522-2A52-ABF8-91210D413999}"/>
+                <a16:creationId xmlns:a16="http://schemas.microsoft.com/office/drawing/2014/main" id="{D4577DBD-F19E-022D-86B5-2C8BD51331E7}"/>
               </a:ext>
             </a:extLst>
           </p:cNvPr>
@@ -15047,7 +15147,7 @@
           <p:cNvPr id="4" name="TextBox 3">
             <a:extLst>
               <a:ext uri="{FF2B5EF4-FFF2-40B4-BE49-F238E27FC236}">
-                <a16:creationId xmlns:a16="http://schemas.microsoft.com/office/drawing/2014/main" id="{1D58E34D-D3FF-AB3D-E295-7C240C51B84B}"/>
+                <a16:creationId xmlns:a16="http://schemas.microsoft.com/office/drawing/2014/main" id="{555AC1B9-3B51-C62A-9E94-15CA29D6A5B5}"/>
               </a:ext>
             </a:extLst>
           </p:cNvPr>
@@ -15105,7 +15205,7 @@
           <p:cNvPr id="5" name="TextBox 4">
             <a:extLst>
               <a:ext uri="{FF2B5EF4-FFF2-40B4-BE49-F238E27FC236}">
-                <a16:creationId xmlns:a16="http://schemas.microsoft.com/office/drawing/2014/main" id="{AFB76F97-5467-B21E-5FFB-AAD904FACCF1}"/>
+                <a16:creationId xmlns:a16="http://schemas.microsoft.com/office/drawing/2014/main" id="{AEB49757-1324-42CB-DFFB-1DFF067F8B7D}"/>
               </a:ext>
             </a:extLst>
           </p:cNvPr>
@@ -15145,7 +15245,7 @@
           <p:cNvPr id="6" name="타원 5">
             <a:extLst>
               <a:ext uri="{FF2B5EF4-FFF2-40B4-BE49-F238E27FC236}">
-                <a16:creationId xmlns:a16="http://schemas.microsoft.com/office/drawing/2014/main" id="{02E2A79C-714B-DA03-465C-D6A320CE7AFD}"/>
+                <a16:creationId xmlns:a16="http://schemas.microsoft.com/office/drawing/2014/main" id="{0F580853-15C6-7411-29E9-0ACC016A04E4}"/>
               </a:ext>
             </a:extLst>
           </p:cNvPr>
@@ -15227,7 +15327,7 @@
           <p:cNvPr id="7" name="사각형: 둥근 모서리 6">
             <a:extLst>
               <a:ext uri="{FF2B5EF4-FFF2-40B4-BE49-F238E27FC236}">
-                <a16:creationId xmlns:a16="http://schemas.microsoft.com/office/drawing/2014/main" id="{ABB0C0B1-5F98-C4EB-BAC0-ED8B2FD59265}"/>
+                <a16:creationId xmlns:a16="http://schemas.microsoft.com/office/drawing/2014/main" id="{C04A85A8-2030-47DE-6B3F-955D561A633A}"/>
               </a:ext>
             </a:extLst>
           </p:cNvPr>
@@ -15281,7 +15381,7 @@
           <p:cNvPr id="8" name="직사각형 7">
             <a:extLst>
               <a:ext uri="{FF2B5EF4-FFF2-40B4-BE49-F238E27FC236}">
-                <a16:creationId xmlns:a16="http://schemas.microsoft.com/office/drawing/2014/main" id="{73E5D80F-7857-0140-0841-802B8CFE74DC}"/>
+                <a16:creationId xmlns:a16="http://schemas.microsoft.com/office/drawing/2014/main" id="{71971B59-5B17-F334-4544-3A7385ED2FF1}"/>
               </a:ext>
             </a:extLst>
           </p:cNvPr>
@@ -15349,7 +15449,7 @@
           <p:cNvPr id="9" name="TextBox 8">
             <a:extLst>
               <a:ext uri="{FF2B5EF4-FFF2-40B4-BE49-F238E27FC236}">
-                <a16:creationId xmlns:a16="http://schemas.microsoft.com/office/drawing/2014/main" id="{71EB6046-3B0C-B193-ED57-0A606B92B7A0}"/>
+                <a16:creationId xmlns:a16="http://schemas.microsoft.com/office/drawing/2014/main" id="{DFCD05B9-1D48-FBB5-65B9-C5FEAD8FCA06}"/>
               </a:ext>
             </a:extLst>
           </p:cNvPr>
@@ -15389,7 +15489,7 @@
           <p:cNvPr id="10" name="TextBox 9">
             <a:extLst>
               <a:ext uri="{FF2B5EF4-FFF2-40B4-BE49-F238E27FC236}">
-                <a16:creationId xmlns:a16="http://schemas.microsoft.com/office/drawing/2014/main" id="{40BC8BD6-B6FE-3E1C-50E2-495B8D91267B}"/>
+                <a16:creationId xmlns:a16="http://schemas.microsoft.com/office/drawing/2014/main" id="{6A997FCB-9A0D-3A10-3321-31CAFB2F94B4}"/>
               </a:ext>
             </a:extLst>
           </p:cNvPr>
@@ -15440,7 +15540,7 @@
           <p:cNvPr id="11" name="직선 연결선 10">
             <a:extLst>
               <a:ext uri="{FF2B5EF4-FFF2-40B4-BE49-F238E27FC236}">
-                <a16:creationId xmlns:a16="http://schemas.microsoft.com/office/drawing/2014/main" id="{0A568AAF-AA9A-6A39-6AFE-D418A232409F}"/>
+                <a16:creationId xmlns:a16="http://schemas.microsoft.com/office/drawing/2014/main" id="{1C7DD4D8-2369-FEF0-3DEB-80E5908184C5}"/>
               </a:ext>
             </a:extLst>
           </p:cNvPr>
@@ -15482,7 +15582,7 @@
           <p:cNvPr id="12" name="타원 11">
             <a:extLst>
               <a:ext uri="{FF2B5EF4-FFF2-40B4-BE49-F238E27FC236}">
-                <a16:creationId xmlns:a16="http://schemas.microsoft.com/office/drawing/2014/main" id="{B55509BD-A2B8-8BBE-DD34-D305EBD9D167}"/>
+                <a16:creationId xmlns:a16="http://schemas.microsoft.com/office/drawing/2014/main" id="{AD9ED41B-9CE3-5824-0FD0-E2ED9D67F2EC}"/>
               </a:ext>
             </a:extLst>
           </p:cNvPr>
@@ -15564,7 +15664,7 @@
           <p:cNvPr id="13" name="사각형: 둥근 모서리 12">
             <a:extLst>
               <a:ext uri="{FF2B5EF4-FFF2-40B4-BE49-F238E27FC236}">
-                <a16:creationId xmlns:a16="http://schemas.microsoft.com/office/drawing/2014/main" id="{E4279866-03E4-4164-B060-0B5544C7DDA9}"/>
+                <a16:creationId xmlns:a16="http://schemas.microsoft.com/office/drawing/2014/main" id="{61FF3909-5244-4CE4-7362-C3E3B7B3DD7B}"/>
               </a:ext>
             </a:extLst>
           </p:cNvPr>
@@ -15618,7 +15718,7 @@
           <p:cNvPr id="14" name="직사각형 13">
             <a:extLst>
               <a:ext uri="{FF2B5EF4-FFF2-40B4-BE49-F238E27FC236}">
-                <a16:creationId xmlns:a16="http://schemas.microsoft.com/office/drawing/2014/main" id="{05983C5D-BF97-9625-4DCF-D3EEE7B6A1A5}"/>
+                <a16:creationId xmlns:a16="http://schemas.microsoft.com/office/drawing/2014/main" id="{EC4BF7E8-9E03-0216-508A-F40A93E1CC85}"/>
               </a:ext>
             </a:extLst>
           </p:cNvPr>
@@ -15686,7 +15786,7 @@
           <p:cNvPr id="15" name="TextBox 14">
             <a:extLst>
               <a:ext uri="{FF2B5EF4-FFF2-40B4-BE49-F238E27FC236}">
-                <a16:creationId xmlns:a16="http://schemas.microsoft.com/office/drawing/2014/main" id="{3122E9E4-C738-206F-06F4-8A14AE60DF1F}"/>
+                <a16:creationId xmlns:a16="http://schemas.microsoft.com/office/drawing/2014/main" id="{5828F162-DE26-B1CD-535E-4C4D12EE3594}"/>
               </a:ext>
             </a:extLst>
           </p:cNvPr>
@@ -15726,7 +15826,7 @@
           <p:cNvPr id="16" name="TextBox 15">
             <a:extLst>
               <a:ext uri="{FF2B5EF4-FFF2-40B4-BE49-F238E27FC236}">
-                <a16:creationId xmlns:a16="http://schemas.microsoft.com/office/drawing/2014/main" id="{7092169A-599E-837C-15FB-6F9033BA4044}"/>
+                <a16:creationId xmlns:a16="http://schemas.microsoft.com/office/drawing/2014/main" id="{E2E73AA3-E5B8-3FF5-C271-0836CFB79744}"/>
               </a:ext>
             </a:extLst>
           </p:cNvPr>
@@ -15777,7 +15877,7 @@
           <p:cNvPr id="17" name="직선 연결선 16">
             <a:extLst>
               <a:ext uri="{FF2B5EF4-FFF2-40B4-BE49-F238E27FC236}">
-                <a16:creationId xmlns:a16="http://schemas.microsoft.com/office/drawing/2014/main" id="{A2995F06-5474-ECA4-AE7F-65EC8CFAE852}"/>
+                <a16:creationId xmlns:a16="http://schemas.microsoft.com/office/drawing/2014/main" id="{CFBF4292-5D82-61DB-B9F9-0746E0187C0A}"/>
               </a:ext>
             </a:extLst>
           </p:cNvPr>
@@ -15819,7 +15919,7 @@
           <p:cNvPr id="18" name="타원 17">
             <a:extLst>
               <a:ext uri="{FF2B5EF4-FFF2-40B4-BE49-F238E27FC236}">
-                <a16:creationId xmlns:a16="http://schemas.microsoft.com/office/drawing/2014/main" id="{60C16D3F-1B52-D4C7-C391-48507A2A0A40}"/>
+                <a16:creationId xmlns:a16="http://schemas.microsoft.com/office/drawing/2014/main" id="{0FBD1484-8CE5-1661-27C2-DB6DB497718F}"/>
               </a:ext>
             </a:extLst>
           </p:cNvPr>
@@ -15901,7 +16001,7 @@
           <p:cNvPr id="19" name="사각형: 둥근 모서리 18">
             <a:extLst>
               <a:ext uri="{FF2B5EF4-FFF2-40B4-BE49-F238E27FC236}">
-                <a16:creationId xmlns:a16="http://schemas.microsoft.com/office/drawing/2014/main" id="{31BA9509-CAF5-E5C9-F543-97115F60A9C5}"/>
+                <a16:creationId xmlns:a16="http://schemas.microsoft.com/office/drawing/2014/main" id="{581296D5-A8E6-0444-D37D-01FA6FFB4E6D}"/>
               </a:ext>
             </a:extLst>
           </p:cNvPr>
@@ -15955,7 +16055,7 @@
           <p:cNvPr id="20" name="직사각형 19">
             <a:extLst>
               <a:ext uri="{FF2B5EF4-FFF2-40B4-BE49-F238E27FC236}">
-                <a16:creationId xmlns:a16="http://schemas.microsoft.com/office/drawing/2014/main" id="{BB9700CD-B3A4-ECE4-7571-C637A87289E8}"/>
+                <a16:creationId xmlns:a16="http://schemas.microsoft.com/office/drawing/2014/main" id="{6EBBDD13-B66C-9EC6-8EB6-892F754D97CE}"/>
               </a:ext>
             </a:extLst>
           </p:cNvPr>
@@ -16023,7 +16123,7 @@
           <p:cNvPr id="21" name="TextBox 20">
             <a:extLst>
               <a:ext uri="{FF2B5EF4-FFF2-40B4-BE49-F238E27FC236}">
-                <a16:creationId xmlns:a16="http://schemas.microsoft.com/office/drawing/2014/main" id="{4B6B4D48-DDE1-4569-7224-B0998DE5D99B}"/>
+                <a16:creationId xmlns:a16="http://schemas.microsoft.com/office/drawing/2014/main" id="{0C80F977-14DA-3B24-014C-B05E39DDD8D5}"/>
               </a:ext>
             </a:extLst>
           </p:cNvPr>
@@ -16063,7 +16163,7 @@
           <p:cNvPr id="22" name="TextBox 21">
             <a:extLst>
               <a:ext uri="{FF2B5EF4-FFF2-40B4-BE49-F238E27FC236}">
-                <a16:creationId xmlns:a16="http://schemas.microsoft.com/office/drawing/2014/main" id="{F696DB0F-D933-7D60-34DC-63F50CEB3F46}"/>
+                <a16:creationId xmlns:a16="http://schemas.microsoft.com/office/drawing/2014/main" id="{0AC51DD2-961D-EA93-CCF2-F1CF2E626A3D}"/>
               </a:ext>
             </a:extLst>
           </p:cNvPr>
@@ -16132,7 +16232,7 @@
           <p:cNvPr id="23" name="직선 연결선 22">
             <a:extLst>
               <a:ext uri="{FF2B5EF4-FFF2-40B4-BE49-F238E27FC236}">
-                <a16:creationId xmlns:a16="http://schemas.microsoft.com/office/drawing/2014/main" id="{D610F080-3D31-8962-B1B4-E4C4ED462308}"/>
+                <a16:creationId xmlns:a16="http://schemas.microsoft.com/office/drawing/2014/main" id="{933AD40E-92E8-5859-6A4C-4196695B258E}"/>
               </a:ext>
             </a:extLst>
           </p:cNvPr>
@@ -16174,7 +16274,7 @@
           <p:cNvPr id="24" name="타원 23">
             <a:extLst>
               <a:ext uri="{FF2B5EF4-FFF2-40B4-BE49-F238E27FC236}">
-                <a16:creationId xmlns:a16="http://schemas.microsoft.com/office/drawing/2014/main" id="{C0945C60-ACDD-40EA-A57F-35A459B19C1E}"/>
+                <a16:creationId xmlns:a16="http://schemas.microsoft.com/office/drawing/2014/main" id="{618F6AF7-747F-49CC-C123-B4A03BA9F63F}"/>
               </a:ext>
             </a:extLst>
           </p:cNvPr>
@@ -16256,7 +16356,7 @@
           <p:cNvPr id="25" name="사각형: 둥근 모서리 24">
             <a:extLst>
               <a:ext uri="{FF2B5EF4-FFF2-40B4-BE49-F238E27FC236}">
-                <a16:creationId xmlns:a16="http://schemas.microsoft.com/office/drawing/2014/main" id="{429A7413-5AC1-B0BD-7453-4048D2013025}"/>
+                <a16:creationId xmlns:a16="http://schemas.microsoft.com/office/drawing/2014/main" id="{98B2E6A7-F18F-FCA3-04A6-751332D29C75}"/>
               </a:ext>
             </a:extLst>
           </p:cNvPr>
@@ -16310,7 +16410,7 @@
           <p:cNvPr id="26" name="직사각형 25">
             <a:extLst>
               <a:ext uri="{FF2B5EF4-FFF2-40B4-BE49-F238E27FC236}">
-                <a16:creationId xmlns:a16="http://schemas.microsoft.com/office/drawing/2014/main" id="{B9632A8B-82E2-33BF-6A79-7FF5DBE14FA7}"/>
+                <a16:creationId xmlns:a16="http://schemas.microsoft.com/office/drawing/2014/main" id="{8FD2CC6E-DFD8-E19F-AD34-0A32A68BBA15}"/>
               </a:ext>
             </a:extLst>
           </p:cNvPr>
@@ -16378,7 +16478,7 @@
           <p:cNvPr id="27" name="TextBox 26">
             <a:extLst>
               <a:ext uri="{FF2B5EF4-FFF2-40B4-BE49-F238E27FC236}">
-                <a16:creationId xmlns:a16="http://schemas.microsoft.com/office/drawing/2014/main" id="{72DCA205-FE6A-EAD2-D053-E465C7A7F257}"/>
+                <a16:creationId xmlns:a16="http://schemas.microsoft.com/office/drawing/2014/main" id="{50E4E1C0-F415-019E-0CE1-14A6D5C13540}"/>
               </a:ext>
             </a:extLst>
           </p:cNvPr>
@@ -16418,7 +16518,7 @@
           <p:cNvPr id="28" name="TextBox 27">
             <a:extLst>
               <a:ext uri="{FF2B5EF4-FFF2-40B4-BE49-F238E27FC236}">
-                <a16:creationId xmlns:a16="http://schemas.microsoft.com/office/drawing/2014/main" id="{19E20297-C7C9-9368-C0AA-273700B14568}"/>
+                <a16:creationId xmlns:a16="http://schemas.microsoft.com/office/drawing/2014/main" id="{3A04098D-94D0-7D86-81B3-0D9355BC803A}"/>
               </a:ext>
             </a:extLst>
           </p:cNvPr>
@@ -16505,7 +16605,7 @@
           <p:cNvPr id="29" name="직선 연결선 28">
             <a:extLst>
               <a:ext uri="{FF2B5EF4-FFF2-40B4-BE49-F238E27FC236}">
-                <a16:creationId xmlns:a16="http://schemas.microsoft.com/office/drawing/2014/main" id="{506211F2-CCFA-01C1-757A-390D09DBAA64}"/>
+                <a16:creationId xmlns:a16="http://schemas.microsoft.com/office/drawing/2014/main" id="{2FFD4813-1E92-DA8A-B1F9-F5B869F8C09C}"/>
               </a:ext>
             </a:extLst>
           </p:cNvPr>
@@ -16547,7 +16647,7 @@
           <p:cNvPr id="30" name="타원 29">
             <a:extLst>
               <a:ext uri="{FF2B5EF4-FFF2-40B4-BE49-F238E27FC236}">
-                <a16:creationId xmlns:a16="http://schemas.microsoft.com/office/drawing/2014/main" id="{E002092B-9EC3-8931-02E2-D67F59FE7242}"/>
+                <a16:creationId xmlns:a16="http://schemas.microsoft.com/office/drawing/2014/main" id="{7E87B2E3-A57A-1A96-77CF-9DB05B8E2323}"/>
               </a:ext>
             </a:extLst>
           </p:cNvPr>
@@ -16629,7 +16729,7 @@
           <p:cNvPr id="31" name="사각형: 둥근 모서리 30">
             <a:extLst>
               <a:ext uri="{FF2B5EF4-FFF2-40B4-BE49-F238E27FC236}">
-                <a16:creationId xmlns:a16="http://schemas.microsoft.com/office/drawing/2014/main" id="{16208C36-B6A5-53F4-AF09-9693DE3067F8}"/>
+                <a16:creationId xmlns:a16="http://schemas.microsoft.com/office/drawing/2014/main" id="{28443C25-85EF-56F2-BC8E-4F95949C26E7}"/>
               </a:ext>
             </a:extLst>
           </p:cNvPr>
@@ -16683,7 +16783,7 @@
           <p:cNvPr id="32" name="직사각형 31">
             <a:extLst>
               <a:ext uri="{FF2B5EF4-FFF2-40B4-BE49-F238E27FC236}">
-                <a16:creationId xmlns:a16="http://schemas.microsoft.com/office/drawing/2014/main" id="{F43DEAC2-8C0C-AD45-34CF-1D251CAF1B96}"/>
+                <a16:creationId xmlns:a16="http://schemas.microsoft.com/office/drawing/2014/main" id="{830469C6-F90D-3AB4-1925-D3709AEFD748}"/>
               </a:ext>
             </a:extLst>
           </p:cNvPr>
@@ -16751,7 +16851,7 @@
           <p:cNvPr id="33" name="TextBox 32">
             <a:extLst>
               <a:ext uri="{FF2B5EF4-FFF2-40B4-BE49-F238E27FC236}">
-                <a16:creationId xmlns:a16="http://schemas.microsoft.com/office/drawing/2014/main" id="{3EF21E3F-070C-B429-DE52-59CFDA3FDE4B}"/>
+                <a16:creationId xmlns:a16="http://schemas.microsoft.com/office/drawing/2014/main" id="{653AB0C0-397F-6651-0D7A-520CB46ECE60}"/>
               </a:ext>
             </a:extLst>
           </p:cNvPr>
@@ -16809,7 +16909,7 @@
           <p:cNvPr id="34" name="TextBox 33">
             <a:extLst>
               <a:ext uri="{FF2B5EF4-FFF2-40B4-BE49-F238E27FC236}">
-                <a16:creationId xmlns:a16="http://schemas.microsoft.com/office/drawing/2014/main" id="{CD6BCD12-CF25-A5B2-DB51-70BEEEA83A7D}"/>
+                <a16:creationId xmlns:a16="http://schemas.microsoft.com/office/drawing/2014/main" id="{7D767DF8-273A-C47D-2394-FB26444DE75C}"/>
               </a:ext>
             </a:extLst>
           </p:cNvPr>
@@ -16896,7 +16996,7 @@
           <p:cNvPr id="35" name="TextBox 34">
             <a:extLst>
               <a:ext uri="{FF2B5EF4-FFF2-40B4-BE49-F238E27FC236}">
-                <a16:creationId xmlns:a16="http://schemas.microsoft.com/office/drawing/2014/main" id="{EDEA83B3-2E97-0A74-22A3-61EB661D8B86}"/>
+                <a16:creationId xmlns:a16="http://schemas.microsoft.com/office/drawing/2014/main" id="{E63FF760-20D0-4C4C-BC5A-BCA3234EADA3}"/>
               </a:ext>
             </a:extLst>
           </p:cNvPr>
@@ -16988,7 +17088,7 @@
           <p:cNvPr id="36" name="TextBox 35">
             <a:extLst>
               <a:ext uri="{FF2B5EF4-FFF2-40B4-BE49-F238E27FC236}">
-                <a16:creationId xmlns:a16="http://schemas.microsoft.com/office/drawing/2014/main" id="{F2689EB6-44A6-EB88-2F72-65317086832A}"/>
+                <a16:creationId xmlns:a16="http://schemas.microsoft.com/office/drawing/2014/main" id="{B1D590D4-1010-C0A2-2F8D-592DF3675958}"/>
               </a:ext>
             </a:extLst>
           </p:cNvPr>
@@ -17053,7 +17153,7 @@
     </p:spTree>
     <p:extLst>
       <p:ext uri="{BB962C8B-B14F-4D97-AF65-F5344CB8AC3E}">
-        <p14:creationId xmlns:p14="http://schemas.microsoft.com/office/powerpoint/2010/main" val="3827071668"/>
+        <p14:creationId xmlns:p14="http://schemas.microsoft.com/office/powerpoint/2010/main" val="3809867363"/>
       </p:ext>
     </p:extLst>
   </p:cSld>
@@ -17093,7 +17193,7 @@
           <p:cNvPr id="2" name="사각형: 둥근 모서리 1">
             <a:extLst>
               <a:ext uri="{FF2B5EF4-FFF2-40B4-BE49-F238E27FC236}">
-                <a16:creationId xmlns:a16="http://schemas.microsoft.com/office/drawing/2014/main" id="{B01CDF61-51AB-E3B6-01DE-77B29165DE57}"/>
+                <a16:creationId xmlns:a16="http://schemas.microsoft.com/office/drawing/2014/main" id="{F6327BE5-1B58-5674-F054-FFC7723CBD88}"/>
               </a:ext>
             </a:extLst>
           </p:cNvPr>
@@ -17175,7 +17275,7 @@
           <p:cNvPr id="3" name="TextBox 2">
             <a:extLst>
               <a:ext uri="{FF2B5EF4-FFF2-40B4-BE49-F238E27FC236}">
-                <a16:creationId xmlns:a16="http://schemas.microsoft.com/office/drawing/2014/main" id="{9604AA3E-8A02-70F5-6017-0C16AD424DAF}"/>
+                <a16:creationId xmlns:a16="http://schemas.microsoft.com/office/drawing/2014/main" id="{F21F02E4-1490-A542-6DEA-A46339C8D7B3}"/>
               </a:ext>
             </a:extLst>
           </p:cNvPr>
@@ -17230,7 +17330,7 @@
           <p:cNvPr id="4" name="TextBox 3">
             <a:extLst>
               <a:ext uri="{FF2B5EF4-FFF2-40B4-BE49-F238E27FC236}">
-                <a16:creationId xmlns:a16="http://schemas.microsoft.com/office/drawing/2014/main" id="{91970975-74E6-C2C4-21EB-97106B6C4A1D}"/>
+                <a16:creationId xmlns:a16="http://schemas.microsoft.com/office/drawing/2014/main" id="{83039111-D5C5-4C94-1AD0-D2B17D228C2F}"/>
               </a:ext>
             </a:extLst>
           </p:cNvPr>
@@ -17305,7 +17405,7 @@
           <p:cNvPr id="5" name="사각형: 둥근 모서리 4">
             <a:extLst>
               <a:ext uri="{FF2B5EF4-FFF2-40B4-BE49-F238E27FC236}">
-                <a16:creationId xmlns:a16="http://schemas.microsoft.com/office/drawing/2014/main" id="{0EC303D4-605E-0301-8EE2-D0A44999A07F}"/>
+                <a16:creationId xmlns:a16="http://schemas.microsoft.com/office/drawing/2014/main" id="{66032995-F836-5296-9D3A-AA9FFBA2DF42}"/>
               </a:ext>
             </a:extLst>
           </p:cNvPr>
@@ -17359,7 +17459,7 @@
           <p:cNvPr id="6" name="직사각형 5">
             <a:extLst>
               <a:ext uri="{FF2B5EF4-FFF2-40B4-BE49-F238E27FC236}">
-                <a16:creationId xmlns:a16="http://schemas.microsoft.com/office/drawing/2014/main" id="{E994D271-4B21-227D-E615-04D44B06E01E}"/>
+                <a16:creationId xmlns:a16="http://schemas.microsoft.com/office/drawing/2014/main" id="{46CC22C2-BEE0-7C11-78B2-E8A1CDF92520}"/>
               </a:ext>
             </a:extLst>
           </p:cNvPr>
@@ -17427,7 +17527,7 @@
           <p:cNvPr id="7" name="TextBox 6">
             <a:extLst>
               <a:ext uri="{FF2B5EF4-FFF2-40B4-BE49-F238E27FC236}">
-                <a16:creationId xmlns:a16="http://schemas.microsoft.com/office/drawing/2014/main" id="{965C2ABB-A2BF-1661-761B-FB9E43A06763}"/>
+                <a16:creationId xmlns:a16="http://schemas.microsoft.com/office/drawing/2014/main" id="{7030F255-461F-1D75-2121-CB15CACD38A8}"/>
               </a:ext>
             </a:extLst>
           </p:cNvPr>
@@ -17467,7 +17567,7 @@
           <p:cNvPr id="8" name="TextBox 7">
             <a:extLst>
               <a:ext uri="{FF2B5EF4-FFF2-40B4-BE49-F238E27FC236}">
-                <a16:creationId xmlns:a16="http://schemas.microsoft.com/office/drawing/2014/main" id="{F5DC729E-294A-348E-CFD8-D022096E26C4}"/>
+                <a16:creationId xmlns:a16="http://schemas.microsoft.com/office/drawing/2014/main" id="{46BC412E-5DC3-F1AF-7E7E-0410C98687F5}"/>
               </a:ext>
             </a:extLst>
           </p:cNvPr>
@@ -17540,7 +17640,7 @@
           <p:cNvPr id="9" name="사각형: 둥근 모서리 8">
             <a:extLst>
               <a:ext uri="{FF2B5EF4-FFF2-40B4-BE49-F238E27FC236}">
-                <a16:creationId xmlns:a16="http://schemas.microsoft.com/office/drawing/2014/main" id="{03834F7E-0151-F182-168B-454AC793DA13}"/>
+                <a16:creationId xmlns:a16="http://schemas.microsoft.com/office/drawing/2014/main" id="{348A9020-FD8E-1009-DA2D-B7ADE89805E5}"/>
               </a:ext>
             </a:extLst>
           </p:cNvPr>
@@ -17594,7 +17694,7 @@
           <p:cNvPr id="10" name="직사각형 9">
             <a:extLst>
               <a:ext uri="{FF2B5EF4-FFF2-40B4-BE49-F238E27FC236}">
-                <a16:creationId xmlns:a16="http://schemas.microsoft.com/office/drawing/2014/main" id="{5DA486A0-C8CA-DA6F-8B5D-A710D2F59BF2}"/>
+                <a16:creationId xmlns:a16="http://schemas.microsoft.com/office/drawing/2014/main" id="{881D404C-7EFA-5229-F9CC-C2AB7EE9372B}"/>
               </a:ext>
             </a:extLst>
           </p:cNvPr>
@@ -17662,7 +17762,7 @@
           <p:cNvPr id="11" name="TextBox 10">
             <a:extLst>
               <a:ext uri="{FF2B5EF4-FFF2-40B4-BE49-F238E27FC236}">
-                <a16:creationId xmlns:a16="http://schemas.microsoft.com/office/drawing/2014/main" id="{D0B05E7B-1917-A68D-E5E3-5FF81C28F8D3}"/>
+                <a16:creationId xmlns:a16="http://schemas.microsoft.com/office/drawing/2014/main" id="{DC11732E-4978-8899-35DB-7F6A0E08421E}"/>
               </a:ext>
             </a:extLst>
           </p:cNvPr>
@@ -17702,7 +17802,7 @@
           <p:cNvPr id="12" name="TextBox 11">
             <a:extLst>
               <a:ext uri="{FF2B5EF4-FFF2-40B4-BE49-F238E27FC236}">
-                <a16:creationId xmlns:a16="http://schemas.microsoft.com/office/drawing/2014/main" id="{CCB6CA52-58CD-09AF-ACD5-B1193DB87FED}"/>
+                <a16:creationId xmlns:a16="http://schemas.microsoft.com/office/drawing/2014/main" id="{0DFCE97C-1F79-17E6-876D-BBE1D77286CF}"/>
               </a:ext>
             </a:extLst>
           </p:cNvPr>
@@ -17793,7 +17893,7 @@
           <p:cNvPr id="13" name="사각형: 둥근 모서리 12">
             <a:extLst>
               <a:ext uri="{FF2B5EF4-FFF2-40B4-BE49-F238E27FC236}">
-                <a16:creationId xmlns:a16="http://schemas.microsoft.com/office/drawing/2014/main" id="{AC63302D-B1E8-DCA0-518B-1A8597A96341}"/>
+                <a16:creationId xmlns:a16="http://schemas.microsoft.com/office/drawing/2014/main" id="{517B91C9-16C4-9B8E-46D4-0F54D5A788C2}"/>
               </a:ext>
             </a:extLst>
           </p:cNvPr>
@@ -17847,7 +17947,7 @@
           <p:cNvPr id="14" name="직사각형 13">
             <a:extLst>
               <a:ext uri="{FF2B5EF4-FFF2-40B4-BE49-F238E27FC236}">
-                <a16:creationId xmlns:a16="http://schemas.microsoft.com/office/drawing/2014/main" id="{CD188E73-6DFF-24C7-0829-16217676A6AE}"/>
+                <a16:creationId xmlns:a16="http://schemas.microsoft.com/office/drawing/2014/main" id="{479DF8BE-3DDB-084F-5274-705337E3C666}"/>
               </a:ext>
             </a:extLst>
           </p:cNvPr>
@@ -17915,7 +18015,7 @@
           <p:cNvPr id="15" name="TextBox 14">
             <a:extLst>
               <a:ext uri="{FF2B5EF4-FFF2-40B4-BE49-F238E27FC236}">
-                <a16:creationId xmlns:a16="http://schemas.microsoft.com/office/drawing/2014/main" id="{A678F5D3-E576-CC4E-AE11-EC6643AC61B0}"/>
+                <a16:creationId xmlns:a16="http://schemas.microsoft.com/office/drawing/2014/main" id="{95F9206C-9A79-4DE7-707E-BBFF004F9946}"/>
               </a:ext>
             </a:extLst>
           </p:cNvPr>
@@ -17964,7 +18064,7 @@
           <p:cNvPr id="16" name="TextBox 15">
             <a:extLst>
               <a:ext uri="{FF2B5EF4-FFF2-40B4-BE49-F238E27FC236}">
-                <a16:creationId xmlns:a16="http://schemas.microsoft.com/office/drawing/2014/main" id="{9297F1D5-6DC7-C470-0A4A-ABD01DC778F8}"/>
+                <a16:creationId xmlns:a16="http://schemas.microsoft.com/office/drawing/2014/main" id="{37B8BB48-B9AB-9CCF-CC75-C8F78F02EFC0}"/>
               </a:ext>
             </a:extLst>
           </p:cNvPr>
@@ -18019,7 +18119,7 @@
           <p:cNvPr id="17" name="TextBox 16">
             <a:extLst>
               <a:ext uri="{FF2B5EF4-FFF2-40B4-BE49-F238E27FC236}">
-                <a16:creationId xmlns:a16="http://schemas.microsoft.com/office/drawing/2014/main" id="{B247282B-646D-09D6-424E-ADAD84B879F2}"/>
+                <a16:creationId xmlns:a16="http://schemas.microsoft.com/office/drawing/2014/main" id="{DB12D0C6-E362-279C-0354-5AA07737FE84}"/>
               </a:ext>
             </a:extLst>
           </p:cNvPr>
@@ -18127,7 +18227,7 @@
     </p:spTree>
     <p:extLst>
       <p:ext uri="{BB962C8B-B14F-4D97-AF65-F5344CB8AC3E}">
-        <p14:creationId xmlns:p14="http://schemas.microsoft.com/office/powerpoint/2010/main" val="4176534535"/>
+        <p14:creationId xmlns:p14="http://schemas.microsoft.com/office/powerpoint/2010/main" val="711637582"/>
       </p:ext>
     </p:extLst>
   </p:cSld>
@@ -18167,7 +18267,7 @@
           <p:cNvPr id="2" name="사각형: 둥근 모서리 1">
             <a:extLst>
               <a:ext uri="{FF2B5EF4-FFF2-40B4-BE49-F238E27FC236}">
-                <a16:creationId xmlns:a16="http://schemas.microsoft.com/office/drawing/2014/main" id="{88FD04E6-5DA6-ABB4-1698-8F4AFC705D62}"/>
+                <a16:creationId xmlns:a16="http://schemas.microsoft.com/office/drawing/2014/main" id="{34A7E4D1-AA75-ECBA-BC71-4891559088CB}"/>
               </a:ext>
             </a:extLst>
           </p:cNvPr>
@@ -18249,7 +18349,7 @@
           <p:cNvPr id="3" name="TextBox 2">
             <a:extLst>
               <a:ext uri="{FF2B5EF4-FFF2-40B4-BE49-F238E27FC236}">
-                <a16:creationId xmlns:a16="http://schemas.microsoft.com/office/drawing/2014/main" id="{DB5EE8A1-E730-ABFF-100D-9F9947E9393E}"/>
+                <a16:creationId xmlns:a16="http://schemas.microsoft.com/office/drawing/2014/main" id="{212CF037-2083-B9CA-4B20-5DB001831093}"/>
               </a:ext>
             </a:extLst>
           </p:cNvPr>
@@ -18289,7 +18389,7 @@
           <p:cNvPr id="4" name="TextBox 3">
             <a:extLst>
               <a:ext uri="{FF2B5EF4-FFF2-40B4-BE49-F238E27FC236}">
-                <a16:creationId xmlns:a16="http://schemas.microsoft.com/office/drawing/2014/main" id="{8B11409A-46FF-E0B2-9DCD-0DCF58D9815C}"/>
+                <a16:creationId xmlns:a16="http://schemas.microsoft.com/office/drawing/2014/main" id="{A7BC8E12-587C-6866-A645-D27EAF301AE5}"/>
               </a:ext>
             </a:extLst>
           </p:cNvPr>
@@ -18329,7 +18429,7 @@
           <p:cNvPr id="5" name="사각형: 둥근 모서리 4">
             <a:extLst>
               <a:ext uri="{FF2B5EF4-FFF2-40B4-BE49-F238E27FC236}">
-                <a16:creationId xmlns:a16="http://schemas.microsoft.com/office/drawing/2014/main" id="{243446CF-F6E2-6523-0325-B9677DB709E2}"/>
+                <a16:creationId xmlns:a16="http://schemas.microsoft.com/office/drawing/2014/main" id="{6E05291D-3A08-C80D-F6AA-72A9F80824C5}"/>
               </a:ext>
             </a:extLst>
           </p:cNvPr>
@@ -18423,7 +18523,7 @@
           <p:cNvPr id="6" name="직선 연결선 5">
             <a:extLst>
               <a:ext uri="{FF2B5EF4-FFF2-40B4-BE49-F238E27FC236}">
-                <a16:creationId xmlns:a16="http://schemas.microsoft.com/office/drawing/2014/main" id="{DF295873-6907-F0C8-327C-C44631087B7B}"/>
+                <a16:creationId xmlns:a16="http://schemas.microsoft.com/office/drawing/2014/main" id="{362C8BA5-FB89-A250-748A-5707E9452A71}"/>
               </a:ext>
             </a:extLst>
           </p:cNvPr>
@@ -18465,7 +18565,7 @@
           <p:cNvPr id="7" name="사각형: 둥근 모서리 6">
             <a:extLst>
               <a:ext uri="{FF2B5EF4-FFF2-40B4-BE49-F238E27FC236}">
-                <a16:creationId xmlns:a16="http://schemas.microsoft.com/office/drawing/2014/main" id="{94D119D1-76A3-381B-D576-5E3551F4FFEE}"/>
+                <a16:creationId xmlns:a16="http://schemas.microsoft.com/office/drawing/2014/main" id="{6EF9E580-429F-2FC9-368C-126E1A2AE500}"/>
               </a:ext>
             </a:extLst>
           </p:cNvPr>
@@ -18531,7 +18631,43 @@
                 </a:solidFill>
                 <a:latin typeface="Malgun Gothic" panose="020B0503020000020004" pitchFamily="50" charset="-127"/>
               </a:rPr>
-              <a:t>정기 데이터 생성</a:t>
+              <a:t>수집</a:t>
+            </a:r>
+            <a:r>
+              <a:rPr lang="en-US" altLang="ko-KR" sz="1400" b="1">
+                <a:solidFill>
+                  <a:srgbClr val="FFFFFF"/>
+                </a:solidFill>
+                <a:latin typeface="Malgun Gothic" panose="020B0503020000020004" pitchFamily="50" charset="-127"/>
+              </a:rPr>
+              <a:t>·</a:t>
+            </a:r>
+            <a:r>
+              <a:rPr lang="ko-KR" altLang="en-US" sz="1400" b="1">
+                <a:solidFill>
+                  <a:srgbClr val="FFFFFF"/>
+                </a:solidFill>
+                <a:latin typeface="Malgun Gothic" panose="020B0503020000020004" pitchFamily="50" charset="-127"/>
+              </a:rPr>
+              <a:t>계산</a:t>
+            </a:r>
+            <a:r>
+              <a:rPr lang="en-US" altLang="ko-KR" sz="1400" b="1">
+                <a:solidFill>
+                  <a:srgbClr val="FFFFFF"/>
+                </a:solidFill>
+                <a:latin typeface="Malgun Gothic" panose="020B0503020000020004" pitchFamily="50" charset="-127"/>
+              </a:rPr>
+              <a:t>·DB </a:t>
+            </a:r>
+            <a:r>
+              <a:rPr lang="ko-KR" altLang="en-US" sz="1400" b="1">
+                <a:solidFill>
+                  <a:srgbClr val="FFFFFF"/>
+                </a:solidFill>
+                <a:latin typeface="Malgun Gothic" panose="020B0503020000020004" pitchFamily="50" charset="-127"/>
+              </a:rPr>
+              <a:t>적재</a:t>
             </a:r>
           </a:p>
         </p:txBody>
@@ -18541,7 +18677,7 @@
           <p:cNvPr id="8" name="직선 연결선 7">
             <a:extLst>
               <a:ext uri="{FF2B5EF4-FFF2-40B4-BE49-F238E27FC236}">
-                <a16:creationId xmlns:a16="http://schemas.microsoft.com/office/drawing/2014/main" id="{34B86809-C167-A5C6-D97B-F0FA1915CC5A}"/>
+                <a16:creationId xmlns:a16="http://schemas.microsoft.com/office/drawing/2014/main" id="{F39603A9-425D-D5B7-1B5E-DE7F94BF37DC}"/>
               </a:ext>
             </a:extLst>
           </p:cNvPr>
@@ -18583,7 +18719,7 @@
           <p:cNvPr id="9" name="사각형: 둥근 모서리 8">
             <a:extLst>
               <a:ext uri="{FF2B5EF4-FFF2-40B4-BE49-F238E27FC236}">
-                <a16:creationId xmlns:a16="http://schemas.microsoft.com/office/drawing/2014/main" id="{23C487AA-6D30-74A7-728A-C605EB91C2D3}"/>
+                <a16:creationId xmlns:a16="http://schemas.microsoft.com/office/drawing/2014/main" id="{75E1A91A-ECAC-46BF-5D49-9F1C7CB7ACF3}"/>
               </a:ext>
             </a:extLst>
           </p:cNvPr>
@@ -18643,13 +18779,40 @@
           <a:p>
             <a:pPr algn="ctr"/>
             <a:r>
+              <a:rPr lang="en-US" altLang="ko-KR" sz="1400" b="1">
+                <a:solidFill>
+                  <a:srgbClr val="FFFFFF"/>
+                </a:solidFill>
+                <a:latin typeface="Malgun Gothic" panose="020B0503020000020004" pitchFamily="50" charset="-127"/>
+              </a:rPr>
+              <a:t>Supabase </a:t>
+            </a:r>
+            <a:r>
               <a:rPr lang="ko-KR" altLang="en-US" sz="1400" b="1">
                 <a:solidFill>
                   <a:srgbClr val="FFFFFF"/>
                 </a:solidFill>
                 <a:latin typeface="Malgun Gothic" panose="020B0503020000020004" pitchFamily="50" charset="-127"/>
               </a:rPr>
-              <a:t>대시보드 배포</a:t>
+              <a:t>저장</a:t>
+            </a:r>
+            <a:r>
+              <a:rPr lang="en-US" altLang="ko-KR" sz="1400" b="1">
+                <a:solidFill>
+                  <a:srgbClr val="FFFFFF"/>
+                </a:solidFill>
+                <a:latin typeface="Malgun Gothic" panose="020B0503020000020004" pitchFamily="50" charset="-127"/>
+              </a:rPr>
+              <a:t>·</a:t>
+            </a:r>
+            <a:r>
+              <a:rPr lang="ko-KR" altLang="en-US" sz="1400" b="1">
+                <a:solidFill>
+                  <a:srgbClr val="FFFFFF"/>
+                </a:solidFill>
+                <a:latin typeface="Malgun Gothic" panose="020B0503020000020004" pitchFamily="50" charset="-127"/>
+              </a:rPr>
+              <a:t>조회</a:t>
             </a:r>
           </a:p>
         </p:txBody>
@@ -18659,7 +18822,7 @@
           <p:cNvPr id="10" name="직선 연결선 9">
             <a:extLst>
               <a:ext uri="{FF2B5EF4-FFF2-40B4-BE49-F238E27FC236}">
-                <a16:creationId xmlns:a16="http://schemas.microsoft.com/office/drawing/2014/main" id="{7EEA413E-DC80-4069-59A6-42811270E52F}"/>
+                <a16:creationId xmlns:a16="http://schemas.microsoft.com/office/drawing/2014/main" id="{4BE51320-71A4-554A-21CC-7E7886A1D223}"/>
               </a:ext>
             </a:extLst>
           </p:cNvPr>
@@ -18701,7 +18864,7 @@
           <p:cNvPr id="11" name="사각형: 둥근 모서리 10">
             <a:extLst>
               <a:ext uri="{FF2B5EF4-FFF2-40B4-BE49-F238E27FC236}">
-                <a16:creationId xmlns:a16="http://schemas.microsoft.com/office/drawing/2014/main" id="{7B55719C-B673-3243-645C-0C79DA3F373F}"/>
+                <a16:creationId xmlns:a16="http://schemas.microsoft.com/office/drawing/2014/main" id="{D44527FD-0B47-2293-9D4E-FFB555052F61}"/>
               </a:ext>
             </a:extLst>
           </p:cNvPr>
@@ -18767,7 +18930,25 @@
                 </a:solidFill>
                 <a:latin typeface="Malgun Gothic" panose="020B0503020000020004" pitchFamily="50" charset="-127"/>
               </a:rPr>
-              <a:t>사용자 확인</a:t>
+              <a:t>화면</a:t>
+            </a:r>
+            <a:r>
+              <a:rPr lang="en-US" altLang="ko-KR" sz="1400" b="1">
+                <a:solidFill>
+                  <a:srgbClr val="FFFFFF"/>
+                </a:solidFill>
+                <a:latin typeface="Malgun Gothic" panose="020B0503020000020004" pitchFamily="50" charset="-127"/>
+              </a:rPr>
+              <a:t>·</a:t>
+            </a:r>
+            <a:r>
+              <a:rPr lang="ko-KR" altLang="en-US" sz="1400" b="1">
+                <a:solidFill>
+                  <a:srgbClr val="FFFFFF"/>
+                </a:solidFill>
+                <a:latin typeface="Malgun Gothic" panose="020B0503020000020004" pitchFamily="50" charset="-127"/>
+              </a:rPr>
+              <a:t>메일 확인</a:t>
             </a:r>
           </a:p>
         </p:txBody>
@@ -18777,7 +18958,7 @@
           <p:cNvPr id="12" name="사각형: 둥근 모서리 11">
             <a:extLst>
               <a:ext uri="{FF2B5EF4-FFF2-40B4-BE49-F238E27FC236}">
-                <a16:creationId xmlns:a16="http://schemas.microsoft.com/office/drawing/2014/main" id="{35979260-24C5-AE0E-3204-6067D69CE097}"/>
+                <a16:creationId xmlns:a16="http://schemas.microsoft.com/office/drawing/2014/main" id="{EC57EDF8-62E5-6B5E-8060-95CA7C740C55}"/>
               </a:ext>
             </a:extLst>
           </p:cNvPr>
@@ -18831,7 +19012,7 @@
           <p:cNvPr id="13" name="직사각형 12">
             <a:extLst>
               <a:ext uri="{FF2B5EF4-FFF2-40B4-BE49-F238E27FC236}">
-                <a16:creationId xmlns:a16="http://schemas.microsoft.com/office/drawing/2014/main" id="{6BFF05C8-99FA-40EA-8F66-4E7F603591C0}"/>
+                <a16:creationId xmlns:a16="http://schemas.microsoft.com/office/drawing/2014/main" id="{C1C17AB1-36DD-3C53-C7D1-A629EB1C212A}"/>
               </a:ext>
             </a:extLst>
           </p:cNvPr>
@@ -18899,7 +19080,7 @@
           <p:cNvPr id="14" name="TextBox 13">
             <a:extLst>
               <a:ext uri="{FF2B5EF4-FFF2-40B4-BE49-F238E27FC236}">
-                <a16:creationId xmlns:a16="http://schemas.microsoft.com/office/drawing/2014/main" id="{04430B88-1791-3D2E-4B0F-75AADFF0B204}"/>
+                <a16:creationId xmlns:a16="http://schemas.microsoft.com/office/drawing/2014/main" id="{3F1C6505-9BB4-6CD7-A8BB-03ABAD9C5E3A}"/>
               </a:ext>
             </a:extLst>
           </p:cNvPr>
@@ -18939,7 +19120,7 @@
           <p:cNvPr id="15" name="TextBox 14">
             <a:extLst>
               <a:ext uri="{FF2B5EF4-FFF2-40B4-BE49-F238E27FC236}">
-                <a16:creationId xmlns:a16="http://schemas.microsoft.com/office/drawing/2014/main" id="{9CE61DFF-B80F-637C-72D4-0FEBDC077C03}"/>
+                <a16:creationId xmlns:a16="http://schemas.microsoft.com/office/drawing/2014/main" id="{5F79C2BE-D063-945E-B243-6A73964D21F1}"/>
               </a:ext>
             </a:extLst>
           </p:cNvPr>
@@ -18999,7 +19180,7 @@
           <p:cNvPr id="16" name="사각형: 둥근 모서리 15">
             <a:extLst>
               <a:ext uri="{FF2B5EF4-FFF2-40B4-BE49-F238E27FC236}">
-                <a16:creationId xmlns:a16="http://schemas.microsoft.com/office/drawing/2014/main" id="{68A371D8-03D0-1C41-CB94-73E64ACF6E16}"/>
+                <a16:creationId xmlns:a16="http://schemas.microsoft.com/office/drawing/2014/main" id="{08059907-81EB-2D0B-AB06-7F1AF8BB01D4}"/>
               </a:ext>
             </a:extLst>
           </p:cNvPr>
@@ -19053,7 +19234,7 @@
           <p:cNvPr id="17" name="직사각형 16">
             <a:extLst>
               <a:ext uri="{FF2B5EF4-FFF2-40B4-BE49-F238E27FC236}">
-                <a16:creationId xmlns:a16="http://schemas.microsoft.com/office/drawing/2014/main" id="{6393A813-9F7B-56E5-B6B4-998DC7683321}"/>
+                <a16:creationId xmlns:a16="http://schemas.microsoft.com/office/drawing/2014/main" id="{EFB7CB75-77B0-7CB9-205C-3911D6E21D77}"/>
               </a:ext>
             </a:extLst>
           </p:cNvPr>
@@ -19121,7 +19302,7 @@
           <p:cNvPr id="18" name="TextBox 17">
             <a:extLst>
               <a:ext uri="{FF2B5EF4-FFF2-40B4-BE49-F238E27FC236}">
-                <a16:creationId xmlns:a16="http://schemas.microsoft.com/office/drawing/2014/main" id="{6ECEBC86-FA1B-07CC-A9D0-AD6DF9ED6C61}"/>
+                <a16:creationId xmlns:a16="http://schemas.microsoft.com/office/drawing/2014/main" id="{992666D1-2894-5FFA-E5D3-2228637D67AE}"/>
               </a:ext>
             </a:extLst>
           </p:cNvPr>
@@ -19151,7 +19332,7 @@
                 </a:solidFill>
                 <a:latin typeface="Malgun Gothic" panose="020B0503020000020004" pitchFamily="50" charset="-127"/>
               </a:rPr>
-              <a:t>계획 환율</a:t>
+              <a:t>환율</a:t>
             </a:r>
             <a:r>
               <a:rPr lang="en-US" altLang="ko-KR" sz="1600" b="1">
@@ -19169,7 +19350,7 @@
                 </a:solidFill>
                 <a:latin typeface="Malgun Gothic" panose="020B0503020000020004" pitchFamily="50" charset="-127"/>
               </a:rPr>
-              <a:t>권한</a:t>
+              <a:t>계획 데이터</a:t>
             </a:r>
           </a:p>
         </p:txBody>
@@ -19179,7 +19360,7 @@
           <p:cNvPr id="19" name="TextBox 18">
             <a:extLst>
               <a:ext uri="{FF2B5EF4-FFF2-40B4-BE49-F238E27FC236}">
-                <a16:creationId xmlns:a16="http://schemas.microsoft.com/office/drawing/2014/main" id="{0075D63F-A077-416F-FAD0-68CE82F03E2E}"/>
+                <a16:creationId xmlns:a16="http://schemas.microsoft.com/office/drawing/2014/main" id="{CB035B95-A4E9-7FA7-652B-1788B3BBBB41}"/>
               </a:ext>
             </a:extLst>
           </p:cNvPr>
@@ -19209,7 +19390,7 @@
                 </a:solidFill>
                 <a:latin typeface="Malgun Gothic" panose="020B0503020000020004" pitchFamily="50" charset="-127"/>
               </a:rPr>
-              <a:t>Supabase Auth + Database</a:t>
+              <a:t>Supabase Database + Auth</a:t>
             </a:r>
           </a:p>
           <a:p>
@@ -19220,7 +19401,7 @@
                 </a:solidFill>
                 <a:latin typeface="Malgun Gothic" panose="020B0503020000020004" pitchFamily="50" charset="-127"/>
               </a:rPr>
-              <a:t>권한별 수정</a:t>
+              <a:t>조회와 권한별 수정</a:t>
             </a:r>
           </a:p>
         </p:txBody>
@@ -19230,7 +19411,7 @@
           <p:cNvPr id="20" name="사각형: 둥근 모서리 19">
             <a:extLst>
               <a:ext uri="{FF2B5EF4-FFF2-40B4-BE49-F238E27FC236}">
-                <a16:creationId xmlns:a16="http://schemas.microsoft.com/office/drawing/2014/main" id="{5743AC65-96A6-643C-5C55-D8B70856A286}"/>
+                <a16:creationId xmlns:a16="http://schemas.microsoft.com/office/drawing/2014/main" id="{8075F2E4-7871-B1FD-663A-64C139229FD8}"/>
               </a:ext>
             </a:extLst>
           </p:cNvPr>
@@ -19284,7 +19465,7 @@
           <p:cNvPr id="21" name="직사각형 20">
             <a:extLst>
               <a:ext uri="{FF2B5EF4-FFF2-40B4-BE49-F238E27FC236}">
-                <a16:creationId xmlns:a16="http://schemas.microsoft.com/office/drawing/2014/main" id="{92758053-CF08-C0E3-1DE4-FC93A5159797}"/>
+                <a16:creationId xmlns:a16="http://schemas.microsoft.com/office/drawing/2014/main" id="{6A321B69-7FF8-B435-DBAF-5FCF214792D1}"/>
               </a:ext>
             </a:extLst>
           </p:cNvPr>
@@ -19352,7 +19533,7 @@
           <p:cNvPr id="22" name="TextBox 21">
             <a:extLst>
               <a:ext uri="{FF2B5EF4-FFF2-40B4-BE49-F238E27FC236}">
-                <a16:creationId xmlns:a16="http://schemas.microsoft.com/office/drawing/2014/main" id="{69E92389-757D-45C5-ECAE-3920545DB4FD}"/>
+                <a16:creationId xmlns:a16="http://schemas.microsoft.com/office/drawing/2014/main" id="{1258687D-748D-F2CB-430C-1C2E92C94759}"/>
               </a:ext>
             </a:extLst>
           </p:cNvPr>
@@ -19392,7 +19573,7 @@
           <p:cNvPr id="23" name="TextBox 22">
             <a:extLst>
               <a:ext uri="{FF2B5EF4-FFF2-40B4-BE49-F238E27FC236}">
-                <a16:creationId xmlns:a16="http://schemas.microsoft.com/office/drawing/2014/main" id="{FDBE125F-DEB4-6F76-4412-0D022DBC6A87}"/>
+                <a16:creationId xmlns:a16="http://schemas.microsoft.com/office/drawing/2014/main" id="{4659024E-FAC6-2FA6-C811-961A5A83E9F1}"/>
               </a:ext>
             </a:extLst>
           </p:cNvPr>
@@ -19433,7 +19614,43 @@
                 </a:solidFill>
                 <a:latin typeface="Malgun Gothic" panose="020B0503020000020004" pitchFamily="50" charset="-127"/>
               </a:rPr>
-              <a:t>정기 생성과 배포</a:t>
+              <a:t>정기 수집</a:t>
+            </a:r>
+            <a:r>
+              <a:rPr lang="en-US" altLang="ko-KR" sz="1400">
+                <a:solidFill>
+                  <a:srgbClr val="4D586A"/>
+                </a:solidFill>
+                <a:latin typeface="Malgun Gothic" panose="020B0503020000020004" pitchFamily="50" charset="-127"/>
+              </a:rPr>
+              <a:t>·</a:t>
+            </a:r>
+            <a:r>
+              <a:rPr lang="ko-KR" altLang="en-US" sz="1400">
+                <a:solidFill>
+                  <a:srgbClr val="4D586A"/>
+                </a:solidFill>
+                <a:latin typeface="Malgun Gothic" panose="020B0503020000020004" pitchFamily="50" charset="-127"/>
+              </a:rPr>
+              <a:t>검증</a:t>
+            </a:r>
+            <a:r>
+              <a:rPr lang="en-US" altLang="ko-KR" sz="1400">
+                <a:solidFill>
+                  <a:srgbClr val="4D586A"/>
+                </a:solidFill>
+                <a:latin typeface="Malgun Gothic" panose="020B0503020000020004" pitchFamily="50" charset="-127"/>
+              </a:rPr>
+              <a:t>·</a:t>
+            </a:r>
+            <a:r>
+              <a:rPr lang="ko-KR" altLang="en-US" sz="1400">
+                <a:solidFill>
+                  <a:srgbClr val="4D586A"/>
+                </a:solidFill>
+                <a:latin typeface="Malgun Gothic" panose="020B0503020000020004" pitchFamily="50" charset="-127"/>
+              </a:rPr>
+              <a:t>적재</a:t>
             </a:r>
           </a:p>
         </p:txBody>
@@ -19441,7 +19658,7 @@
     </p:spTree>
     <p:extLst>
       <p:ext uri="{BB962C8B-B14F-4D97-AF65-F5344CB8AC3E}">
-        <p14:creationId xmlns:p14="http://schemas.microsoft.com/office/powerpoint/2010/main" val="577720886"/>
+        <p14:creationId xmlns:p14="http://schemas.microsoft.com/office/powerpoint/2010/main" val="643265897"/>
       </p:ext>
     </p:extLst>
   </p:cSld>

</xml_diff>